<commit_message>
Tighten deck: enumerated messages, six-motive table, learnings by motive
Shorter numbered messages throughout; adds the styled Table 1 of leaving
motives; one slide per half of the six areas with the paper's explicit
policy learnings; hierarchy slide from the closing paragraphs.

Co-Authored-By: Claude Fable 5 <noreply@anthropic.com>
Claude-Session: https://claude.ai/code/session_018LPM7UjuT86VaNxhN3T3Ra
</commit_message>
<xml_diff>
--- a/Former_Teachers_key_messages.pptx
+++ b/Former_Teachers_key_messages.pptx
@@ -1391,7 +1391,7 @@
     <p:bg>
       <p:bgPr>
         <a:solidFill>
-          <a:srgbClr val="FFFFFF"/>
+          <a:srgbClr val="1F3864"/>
         </a:solidFill>
       </p:bgPr>
     </p:bg>
@@ -1417,8 +1417,8 @@
         </p:nvSpPr>
         <p:spPr>
           <a:xfrm>
-            <a:off x="822960" y="1005840"/>
-            <a:ext cx="7498080" cy="1737360"/>
+            <a:off x="822960" y="1234440"/>
+            <a:ext cx="7498080" cy="1691640"/>
           </a:xfrm>
           <a:prstGeom prst="rect">
             <a:avLst/>
@@ -1432,14 +1432,14 @@
           <a:p>
             <a:pPr algn="ctr" indent="0" marL="0">
               <a:lnSpc>
-                <a:spcPts val="4000"/>
+                <a:spcPts val="3900"/>
               </a:lnSpc>
               <a:buNone/>
             </a:pPr>
             <a:r>
-              <a:rPr lang="en-US" sz="3200" b="1" dirty="0">
+              <a:rPr lang="en-US" sz="3100" b="1" dirty="0">
                 <a:solidFill>
-                  <a:srgbClr val="1F3864"/>
+                  <a:srgbClr val="FFFFFF"/>
                 </a:solidFill>
                 <a:latin typeface="Cambria" pitchFamily="34" charset="0"/>
                 <a:ea typeface="Cambria" pitchFamily="34" charset="-122"/>
@@ -1447,7 +1447,7 @@
               </a:rPr>
               <a:t>Former Teachers: Barriers, Incentives and Policy Lessons for Re-entry</a:t>
             </a:r>
-            <a:endParaRPr lang="en-US" sz="3200" dirty="0"/>
+            <a:endParaRPr lang="en-US" sz="3100" dirty="0"/>
           </a:p>
         </p:txBody>
       </p:sp>
@@ -1459,7 +1459,7 @@
         </p:nvSpPr>
         <p:spPr>
           <a:xfrm>
-            <a:off x="822960" y="2926080"/>
+            <a:off x="822960" y="3063240"/>
             <a:ext cx="7498080" cy="411480"/>
           </a:xfrm>
           <a:prstGeom prst="rect">
@@ -1478,13 +1478,13 @@
             <a:r>
               <a:rPr lang="en-US" sz="1600" dirty="0">
                 <a:solidFill>
-                  <a:srgbClr val="1A1A1A"/>
+                  <a:srgbClr val="C7D3E2"/>
                 </a:solidFill>
                 <a:latin typeface="Calibri" pitchFamily="34" charset="0"/>
                 <a:ea typeface="Calibri" pitchFamily="34" charset="-122"/>
                 <a:cs typeface="Calibri" pitchFamily="34" charset="-120"/>
               </a:rPr>
-              <a:t>Section 2. Teacher leaving: rates, determinants and implications for re-entry</a:t>
+              <a:t>Teacher leaving: what the research says and what it means for policy</a:t>
             </a:r>
             <a:endParaRPr lang="en-US" sz="1600" dirty="0"/>
           </a:p>
@@ -1498,46 +1498,7 @@
         </p:nvSpPr>
         <p:spPr>
           <a:xfrm>
-            <a:off x="822960" y="3401568"/>
-            <a:ext cx="7498080" cy="320040"/>
-          </a:xfrm>
-          <a:prstGeom prst="rect">
-            <a:avLst/>
-          </a:prstGeom>
-          <a:noFill/>
-          <a:ln/>
-        </p:spPr>
-        <p:txBody>
-          <a:bodyPr wrap="square" lIns="0" tIns="0" rIns="0" bIns="0" rtlCol="0" anchor="ctr"/>
-          <a:lstStyle/>
-          <a:p>
-            <a:pPr algn="ctr" indent="0" marL="0">
-              <a:buNone/>
-            </a:pPr>
-            <a:r>
-              <a:rPr lang="en-US" sz="1400" i="1" dirty="0">
-                <a:solidFill>
-                  <a:srgbClr val="1A1A1A"/>
-                </a:solidFill>
-                <a:latin typeface="Calibri" pitchFamily="34" charset="0"/>
-                <a:ea typeface="Calibri" pitchFamily="34" charset="-122"/>
-                <a:cs typeface="Calibri" pitchFamily="34" charset="-120"/>
-              </a:rPr>
-              <a:t>Key findings and policy implications</a:t>
-            </a:r>
-            <a:endParaRPr lang="en-US" sz="1400" dirty="0"/>
-          </a:p>
-        </p:txBody>
-      </p:sp>
-      <p:sp>
-        <p:nvSpPr>
-          <p:cNvPr id="5" name="Text 3"/>
-          <p:cNvSpPr txBox="1"/>
-          <p:nvPr/>
-        </p:nvSpPr>
-        <p:spPr>
-          <a:xfrm>
-            <a:off x="822960" y="4251960"/>
+            <a:off x="822960" y="4206240"/>
             <a:ext cx="7498080" cy="274320"/>
           </a:xfrm>
           <a:prstGeom prst="rect">
@@ -1556,13 +1517,13 @@
             <a:r>
               <a:rPr lang="en-US" sz="1100" dirty="0">
                 <a:solidFill>
-                  <a:srgbClr val="666666"/>
+                  <a:srgbClr val="8FA2B8"/>
                 </a:solidFill>
                 <a:latin typeface="Calibri" pitchFamily="34" charset="0"/>
                 <a:ea typeface="Calibri" pitchFamily="34" charset="-122"/>
                 <a:cs typeface="Calibri" pitchFamily="34" charset="-120"/>
               </a:rPr>
-              <a:t>Directorate for Education and Skills. Working draft.</a:t>
+              <a:t>Section 2. Working draft. Directorate for Education and Skills.</a:t>
             </a:r>
             <a:endParaRPr lang="en-US" sz="1100" dirty="0"/>
           </a:p>
@@ -1608,8 +1569,8 @@
         </p:nvSpPr>
         <p:spPr>
           <a:xfrm>
-            <a:off x="594360" y="384048"/>
-            <a:ext cx="7955280" cy="777240"/>
+            <a:off x="640080" y="438912"/>
+            <a:ext cx="7863840" cy="731520"/>
           </a:xfrm>
           <a:prstGeom prst="rect">
             <a:avLst/>
@@ -1625,7 +1586,7 @@
               <a:buNone/>
             </a:pPr>
             <a:r>
-              <a:rPr lang="en-US" sz="2600" b="1" dirty="0">
+              <a:rPr lang="en-US" sz="2700" b="1" dirty="0">
                 <a:solidFill>
                   <a:srgbClr val="1F3864"/>
                 </a:solidFill>
@@ -1633,9 +1594,9 @@
                 <a:ea typeface="Cambria" pitchFamily="34" charset="-122"/>
                 <a:cs typeface="Cambria" pitchFamily="34" charset="-120"/>
               </a:rPr>
-              <a:t>The teacher leaving rate is stable and unexceptional</a:t>
-            </a:r>
-            <a:endParaRPr lang="en-US" sz="2600" dirty="0"/>
+              <a:t>Why re-entry is on the policy agenda</a:t>
+            </a:r>
+            <a:endParaRPr lang="en-US" sz="2700" dirty="0"/>
           </a:p>
         </p:txBody>
       </p:sp>
@@ -1647,8 +1608,8 @@
         </p:nvSpPr>
         <p:spPr>
           <a:xfrm>
-            <a:off x="594360" y="1325880"/>
-            <a:ext cx="7955280" cy="2880360"/>
+            <a:off x="640080" y="1600200"/>
+            <a:ext cx="7863840" cy="3108960"/>
           </a:xfrm>
           <a:prstGeom prst="rect">
             <a:avLst/>
@@ -1660,18 +1621,19 @@
           <a:bodyPr wrap="square" lIns="0" tIns="0" rIns="0" bIns="0" rtlCol="0" anchor="t"/>
           <a:lstStyle/>
           <a:p>
-            <a:pPr algn="l" marL="152400" indent="-152400">
+            <a:pPr algn="l" marL="228600" indent="-228600">
               <a:lnSpc>
-                <a:spcPts val="1900"/>
+                <a:spcPts val="2100"/>
               </a:lnSpc>
               <a:spcAft>
-                <a:spcPts val="1200"/>
+                <a:spcPts val="2400"/>
               </a:spcAft>
               <a:buSzPct val="100000"/>
-              <a:buChar char="•"/>
+              <a:buFont typeface="+mj-lt"/>
+              <a:buAutoNum type="arabicPeriod" startAt="1"/>
             </a:pPr>
             <a:r>
-              <a:rPr lang="en-US" sz="1400" dirty="0">
+              <a:rPr lang="en-US" sz="1500" dirty="0">
                 <a:solidFill>
                   <a:srgbClr val="1A1A1A"/>
                 </a:solidFill>
@@ -1679,23 +1641,24 @@
                 <a:ea typeface="Calibri" pitchFamily="34" charset="-122"/>
                 <a:cs typeface="Calibri" pitchFamily="34" charset="-120"/>
               </a:rPr>
-              <a:t>The OECD average leaving rate was 6.5% in 2023, against 6.9% in 2015; most systems moved by less than one percentage point (OECD, 2025a).</a:t>
-            </a:r>
-            <a:endParaRPr lang="en-US" sz="1400" dirty="0"/>
-          </a:p>
-          <a:p>
-            <a:pPr algn="l" marL="152400" indent="-152400">
+              <a:t>Re-attracting former teachers relieves shortages in the short run, above all in the disadvantaged and rural schools where they concentrate. It does not close the gap on its own.</a:t>
+            </a:r>
+            <a:endParaRPr lang="en-US" sz="1500" dirty="0"/>
+          </a:p>
+          <a:p>
+            <a:pPr algn="l" marL="228600" indent="-228600">
               <a:lnSpc>
-                <a:spcPts val="1900"/>
+                <a:spcPts val="2100"/>
               </a:lnSpc>
               <a:spcAft>
-                <a:spcPts val="1200"/>
+                <a:spcPts val="2400"/>
               </a:spcAft>
               <a:buSzPct val="100000"/>
-              <a:buChar char="•"/>
+              <a:buFont typeface="+mj-lt"/>
+              <a:buAutoNum type="arabicPeriod" startAt="1"/>
             </a:pPr>
             <a:r>
-              <a:rPr lang="en-US" sz="1400" dirty="0">
+              <a:rPr lang="en-US" sz="1500" dirty="0">
                 <a:solidFill>
                   <a:srgbClr val="1A1A1A"/>
                 </a:solidFill>
@@ -1703,23 +1666,24 @@
                 <a:ea typeface="Calibri" pitchFamily="34" charset="-122"/>
                 <a:cs typeface="Calibri" pitchFamily="34" charset="-120"/>
               </a:rPr>
-              <a:t>The longest national series, the United States, has oscillated between 5% and 8.5% over three and a half decades, with no lasting pandemic effect (NCES, 2024). Similar stability holds in England, New Zealand, Sweden, Israel, Iceland, Norway and Flanders.</a:t>
-            </a:r>
-            <a:endParaRPr lang="en-US" sz="1400" dirty="0"/>
-          </a:p>
-          <a:p>
-            <a:pPr algn="l" marL="152400" indent="-152400">
+              <a:t>The margin is bounded: where leaving is almost all retirement (France, Greece, Ireland, Israel), the recoverable pool is small.</a:t>
+            </a:r>
+            <a:endParaRPr lang="en-US" sz="1500" dirty="0"/>
+          </a:p>
+          <a:p>
+            <a:pPr algn="l" marL="228600" indent="-228600">
               <a:lnSpc>
-                <a:spcPts val="1900"/>
+                <a:spcPts val="2100"/>
               </a:lnSpc>
               <a:spcAft>
-                <a:spcPts val="1200"/>
+                <a:spcPts val="2400"/>
               </a:spcAft>
               <a:buSzPct val="100000"/>
-              <a:buChar char="•"/>
+              <a:buFont typeface="+mj-lt"/>
+              <a:buAutoNum type="arabicPeriod" startAt="1"/>
             </a:pPr>
             <a:r>
-              <a:rPr lang="en-US" sz="1400" dirty="0">
+              <a:rPr lang="en-US" sz="1500" dirty="0">
                 <a:solidFill>
                   <a:srgbClr val="1A1A1A"/>
                 </a:solidFill>
@@ -1727,92 +1691,9 @@
                 <a:ea typeface="Calibri" pitchFamily="34" charset="-122"/>
                 <a:cs typeface="Calibri" pitchFamily="34" charset="-120"/>
               </a:rPr>
-              <a:t>Teachers leave at rates similar to nurses and accountants in the United States (Aldeman and Yi, 2025; Harris and Adams, 2007), and the lowest among 97 occupation groups in Australia (Buckley and Griselda, 2025).</a:t>
-            </a:r>
-            <a:endParaRPr lang="en-US" sz="1400" dirty="0"/>
-          </a:p>
-          <a:p>
-            <a:pPr algn="l" marL="152400" indent="-152400">
-              <a:lnSpc>
-                <a:spcPts val="1900"/>
-              </a:lnSpc>
-              <a:spcAft>
-                <a:spcPts val="1200"/>
-              </a:spcAft>
-              <a:buSzPct val="100000"/>
-              <a:buChar char="•"/>
-            </a:pPr>
-            <a:r>
-              <a:rPr lang="en-US" sz="1400" dirty="0">
-                <a:solidFill>
-                  <a:srgbClr val="1A1A1A"/>
-                </a:solidFill>
-                <a:latin typeface="Calibri" pitchFamily="34" charset="0"/>
-                <a:ea typeface="Calibri" pitchFamily="34" charset="-122"/>
-                <a:cs typeface="Calibri" pitchFamily="34" charset="-120"/>
-              </a:rPr>
-              <a:t>In France, Greece, Ireland and Israel leaving is almost entirely retirement, so the pool of recoverable teachers is small (OECD, 2025a).</a:t>
-            </a:r>
-            <a:endParaRPr lang="en-US" sz="1400" dirty="0"/>
-          </a:p>
-        </p:txBody>
-      </p:sp>
-      <p:sp>
-        <p:nvSpPr>
-          <p:cNvPr id="4" name="Text 2"/>
-          <p:cNvSpPr txBox="1"/>
-          <p:nvPr/>
-        </p:nvSpPr>
-        <p:spPr>
-          <a:xfrm>
-            <a:off x="594360" y="4315968"/>
-            <a:ext cx="7955280" cy="566928"/>
-          </a:xfrm>
-          <a:prstGeom prst="rect">
-            <a:avLst/>
-          </a:prstGeom>
-          <a:noFill/>
-          <a:ln/>
-        </p:spPr>
-        <p:txBody>
-          <a:bodyPr wrap="square" lIns="0" tIns="0" rIns="0" bIns="0" rtlCol="0" anchor="t"/>
-          <a:lstStyle/>
-          <a:p>
-            <a:pPr algn="l" indent="0" marL="0">
-              <a:lnSpc>
-                <a:spcPts val="1700"/>
-              </a:lnSpc>
-              <a:buNone/>
-            </a:pPr>
-            <a:r>
-              <a:rPr lang="en-US" sz="1350" b="1" i="1" dirty="0">
-                <a:solidFill>
-                  <a:srgbClr val="1F3864"/>
-                </a:solidFill>
-                <a:latin typeface="Calibri" pitchFamily="34" charset="0"/>
-                <a:ea typeface="Calibri" pitchFamily="34" charset="-122"/>
-                <a:cs typeface="Calibri" pitchFamily="34" charset="-120"/>
-              </a:rPr>
-              <a:t>Policy implication. </a:t>
-            </a:r>
-            <a:pPr algn="l" indent="0" marL="0">
-              <a:lnSpc>
-                <a:spcPts val="1700"/>
-              </a:lnSpc>
-              <a:buNone/>
-            </a:pPr>
-            <a:r>
-              <a:rPr lang="en-US" sz="1350" i="1" dirty="0">
-                <a:solidFill>
-                  <a:srgbClr val="1F3864"/>
-                </a:solidFill>
-                <a:latin typeface="Calibri" pitchFamily="34" charset="0"/>
-                <a:ea typeface="Calibri" pitchFamily="34" charset="-122"/>
-                <a:cs typeface="Calibri" pitchFamily="34" charset="-120"/>
-              </a:rPr>
-              <a:t>there is no exodus to stop; re-entry is a real but bounded margin against shortages.</a:t>
-            </a:r>
-            <a:endParaRPr lang="en-US" sz="1350" dirty="0"/>
+              <a:t>Returners and retirees add value of their own: experience spillovers to colleagues, mentorship for beginners, tutoring roles with experimental backing.</a:t>
+            </a:r>
+            <a:endParaRPr lang="en-US" sz="1500" dirty="0"/>
           </a:p>
         </p:txBody>
       </p:sp>
@@ -1856,8 +1737,8 @@
         </p:nvSpPr>
         <p:spPr>
           <a:xfrm>
-            <a:off x="594360" y="384048"/>
-            <a:ext cx="7955280" cy="777240"/>
+            <a:off x="640080" y="438912"/>
+            <a:ext cx="7863840" cy="731520"/>
           </a:xfrm>
           <a:prstGeom prst="rect">
             <a:avLst/>
@@ -1873,7 +1754,7 @@
               <a:buNone/>
             </a:pPr>
             <a:r>
-              <a:rPr lang="en-US" sz="2600" b="1" dirty="0">
+              <a:rPr lang="en-US" sz="2700" b="1" dirty="0">
                 <a:solidFill>
                   <a:srgbClr val="1F3864"/>
                 </a:solidFill>
@@ -1881,22 +1762,1018 @@
                 <a:ea typeface="Cambria" pitchFamily="34" charset="-122"/>
                 <a:cs typeface="Cambria" pitchFamily="34" charset="-120"/>
               </a:rPr>
-              <a:t>Three profiles of former teachers</a:t>
-            </a:r>
-            <a:endParaRPr lang="en-US" sz="2600" dirty="0"/>
+              <a:t>Why teachers leave: six areas of motives</a:t>
+            </a:r>
+            <a:endParaRPr lang="en-US" sz="2700" dirty="0"/>
           </a:p>
         </p:txBody>
       </p:sp>
-      <p:sp>
-        <p:nvSpPr>
-          <p:cNvPr id="3" name="Text 1"/>
+      <p:graphicFrame>
+        <p:nvGraphicFramePr>
+          <p:cNvPr id="4" name="Table 0"/>
+          <p:cNvGraphicFramePr>
+            <a:graphicFrameLocks noGrp="1"/>
+          </p:cNvGraphicFramePr>
+          <p:nvPr>
+            <p:extLst>
+              <p:ext uri="{D42A27DB-BD31-4B8C-83A1-F6EECF244321}">
+                <p14:modId xmlns:p14="http://schemas.microsoft.com/office/powerpoint/2010/main" val="1579011935"/>
+              </p:ext>
+            </p:extLst>
+          </p:nvPr>
+        </p:nvGraphicFramePr>
+        <p:xfrm>
+          <a:off x="640080" y="1298448"/>
+          <a:ext cx="7863840" cy="914400"/>
+        </p:xfrm>
+        <a:graphic>
+          <a:graphicData uri="http://schemas.openxmlformats.org/drawingml/2006/table">
+            <a:tbl>
+              <a:tblPr/>
+              <a:tblGrid>
+                <a:gridCol w="2148840"/>
+                <a:gridCol w="5715000"/>
+              </a:tblGrid>
+              <a:tr h="0">
+                <a:tc>
+                  <a:txBody>
+                    <a:bodyPr/>
+                    <a:lstStyle/>
+                    <a:p>
+                      <a:pPr indent="0" marL="0">
+                        <a:buNone/>
+                      </a:pPr>
+                      <a:r>
+                        <a:rPr lang="en-US" sz="1200" b="1" dirty="0">
+                          <a:solidFill>
+                            <a:srgbClr val="FFFFFF"/>
+                          </a:solidFill>
+                          <a:latin typeface="Calibri" pitchFamily="34" charset="0"/>
+                          <a:ea typeface="Calibri" pitchFamily="34" charset="-122"/>
+                          <a:cs typeface="Calibri" pitchFamily="34" charset="-120"/>
+                        </a:rPr>
+                        <a:t>Area</a:t>
+                      </a:r>
+                      <a:endParaRPr lang="en-US" sz="1200" dirty="0">
+                        <a:latin typeface="Calibri" charset="0"/>
+                        <a:ea typeface="Calibri" charset="0"/>
+                        <a:cs typeface="Calibri" charset="0"/>
+                      </a:endParaRPr>
+                    </a:p>
+                  </a:txBody>
+                  <a:tcPr marL="91440" marR="91440" marT="54864" marB="54864" anchor="ctr">
+                    <a:lnL w="9525" cap="flat" cmpd="sng" algn="ctr">
+                      <a:solidFill>
+                        <a:srgbClr val="C9D4E0"/>
+                      </a:solidFill>
+                      <a:prstDash val="solid"/>
+                      <a:round/>
+                      <a:headEnd type="none" w="med" len="med"/>
+                      <a:tailEnd type="none" w="med" len="med"/>
+                    </a:lnL>
+                    <a:lnR w="9525" cap="flat" cmpd="sng" algn="ctr">
+                      <a:solidFill>
+                        <a:srgbClr val="C9D4E0"/>
+                      </a:solidFill>
+                      <a:prstDash val="solid"/>
+                      <a:round/>
+                      <a:headEnd type="none" w="med" len="med"/>
+                      <a:tailEnd type="none" w="med" len="med"/>
+                    </a:lnR>
+                    <a:lnT w="9525" cap="flat" cmpd="sng" algn="ctr">
+                      <a:solidFill>
+                        <a:srgbClr val="C9D4E0"/>
+                      </a:solidFill>
+                      <a:prstDash val="solid"/>
+                      <a:round/>
+                      <a:headEnd type="none" w="med" len="med"/>
+                      <a:tailEnd type="none" w="med" len="med"/>
+                    </a:lnT>
+                    <a:lnB w="9525" cap="flat" cmpd="sng" algn="ctr">
+                      <a:solidFill>
+                        <a:srgbClr val="C9D4E0"/>
+                      </a:solidFill>
+                      <a:prstDash val="solid"/>
+                      <a:round/>
+                      <a:headEnd type="none" w="med" len="med"/>
+                      <a:tailEnd type="none" w="med" len="med"/>
+                    </a:lnB>
+                    <a:solidFill>
+                      <a:srgbClr val="1F3864"/>
+                    </a:solidFill>
+                  </a:tcPr>
+                </a:tc>
+                <a:tc>
+                  <a:txBody>
+                    <a:bodyPr/>
+                    <a:lstStyle/>
+                    <a:p>
+                      <a:pPr indent="0" marL="0">
+                        <a:buNone/>
+                      </a:pPr>
+                      <a:r>
+                        <a:rPr lang="en-US" sz="1200" b="1" dirty="0">
+                          <a:solidFill>
+                            <a:srgbClr val="FFFFFF"/>
+                          </a:solidFill>
+                          <a:latin typeface="Calibri" pitchFamily="34" charset="0"/>
+                          <a:ea typeface="Calibri" pitchFamily="34" charset="-122"/>
+                          <a:cs typeface="Calibri" pitchFamily="34" charset="-120"/>
+                        </a:rPr>
+                        <a:t>Reasons</a:t>
+                      </a:r>
+                      <a:endParaRPr lang="en-US" sz="1200" dirty="0">
+                        <a:latin typeface="Calibri" charset="0"/>
+                        <a:ea typeface="Calibri" charset="0"/>
+                        <a:cs typeface="Calibri" charset="0"/>
+                      </a:endParaRPr>
+                    </a:p>
+                  </a:txBody>
+                  <a:tcPr marL="91440" marR="91440" marT="54864" marB="54864" anchor="ctr">
+                    <a:lnL w="9525" cap="flat" cmpd="sng" algn="ctr">
+                      <a:solidFill>
+                        <a:srgbClr val="C9D4E0"/>
+                      </a:solidFill>
+                      <a:prstDash val="solid"/>
+                      <a:round/>
+                      <a:headEnd type="none" w="med" len="med"/>
+                      <a:tailEnd type="none" w="med" len="med"/>
+                    </a:lnL>
+                    <a:lnR w="9525" cap="flat" cmpd="sng" algn="ctr">
+                      <a:solidFill>
+                        <a:srgbClr val="C9D4E0"/>
+                      </a:solidFill>
+                      <a:prstDash val="solid"/>
+                      <a:round/>
+                      <a:headEnd type="none" w="med" len="med"/>
+                      <a:tailEnd type="none" w="med" len="med"/>
+                    </a:lnR>
+                    <a:lnT w="9525" cap="flat" cmpd="sng" algn="ctr">
+                      <a:solidFill>
+                        <a:srgbClr val="C9D4E0"/>
+                      </a:solidFill>
+                      <a:prstDash val="solid"/>
+                      <a:round/>
+                      <a:headEnd type="none" w="med" len="med"/>
+                      <a:tailEnd type="none" w="med" len="med"/>
+                    </a:lnT>
+                    <a:lnB w="9525" cap="flat" cmpd="sng" algn="ctr">
+                      <a:solidFill>
+                        <a:srgbClr val="C9D4E0"/>
+                      </a:solidFill>
+                      <a:prstDash val="solid"/>
+                      <a:round/>
+                      <a:headEnd type="none" w="med" len="med"/>
+                      <a:tailEnd type="none" w="med" len="med"/>
+                    </a:lnB>
+                    <a:solidFill>
+                      <a:srgbClr val="1F3864"/>
+                    </a:solidFill>
+                  </a:tcPr>
+                </a:tc>
+              </a:tr>
+              <a:tr h="0">
+                <a:tc>
+                  <a:txBody>
+                    <a:bodyPr/>
+                    <a:lstStyle/>
+                    <a:p>
+                      <a:pPr indent="0" marL="0">
+                        <a:buNone/>
+                      </a:pPr>
+                      <a:r>
+                        <a:rPr lang="en-US" sz="1150" b="1" dirty="0">
+                          <a:solidFill>
+                            <a:srgbClr val="1F3864"/>
+                          </a:solidFill>
+                          <a:latin typeface="Calibri" pitchFamily="34" charset="0"/>
+                          <a:ea typeface="Calibri" pitchFamily="34" charset="-122"/>
+                          <a:cs typeface="Calibri" pitchFamily="34" charset="-120"/>
+                        </a:rPr>
+                        <a:t>Professional factors</a:t>
+                      </a:r>
+                      <a:endParaRPr lang="en-US" sz="1150" dirty="0">
+                        <a:latin typeface="Calibri" charset="0"/>
+                        <a:ea typeface="Calibri" charset="0"/>
+                        <a:cs typeface="Calibri" charset="0"/>
+                      </a:endParaRPr>
+                    </a:p>
+                  </a:txBody>
+                  <a:tcPr marL="91440" marR="91440" marT="54864" marB="54864" anchor="ctr">
+                    <a:lnL w="9525" cap="flat" cmpd="sng" algn="ctr">
+                      <a:solidFill>
+                        <a:srgbClr val="C9D4E0"/>
+                      </a:solidFill>
+                      <a:prstDash val="solid"/>
+                      <a:round/>
+                      <a:headEnd type="none" w="med" len="med"/>
+                      <a:tailEnd type="none" w="med" len="med"/>
+                    </a:lnL>
+                    <a:lnR w="9525" cap="flat" cmpd="sng" algn="ctr">
+                      <a:solidFill>
+                        <a:srgbClr val="C9D4E0"/>
+                      </a:solidFill>
+                      <a:prstDash val="solid"/>
+                      <a:round/>
+                      <a:headEnd type="none" w="med" len="med"/>
+                      <a:tailEnd type="none" w="med" len="med"/>
+                    </a:lnR>
+                    <a:lnT w="9525" cap="flat" cmpd="sng" algn="ctr">
+                      <a:solidFill>
+                        <a:srgbClr val="C9D4E0"/>
+                      </a:solidFill>
+                      <a:prstDash val="solid"/>
+                      <a:round/>
+                      <a:headEnd type="none" w="med" len="med"/>
+                      <a:tailEnd type="none" w="med" len="med"/>
+                    </a:lnT>
+                    <a:lnB w="9525" cap="flat" cmpd="sng" algn="ctr">
+                      <a:solidFill>
+                        <a:srgbClr val="C9D4E0"/>
+                      </a:solidFill>
+                      <a:prstDash val="solid"/>
+                      <a:round/>
+                      <a:headEnd type="none" w="med" len="med"/>
+                      <a:tailEnd type="none" w="med" len="med"/>
+                    </a:lnB>
+                    <a:solidFill>
+                      <a:srgbClr val="FFFFFF"/>
+                    </a:solidFill>
+                  </a:tcPr>
+                </a:tc>
+                <a:tc>
+                  <a:txBody>
+                    <a:bodyPr/>
+                    <a:lstStyle/>
+                    <a:p>
+                      <a:pPr indent="0" marL="0">
+                        <a:buNone/>
+                      </a:pPr>
+                      <a:r>
+                        <a:rPr lang="en-US" sz="1100" dirty="0">
+                          <a:solidFill>
+                            <a:srgbClr val="1A1A1A"/>
+                          </a:solidFill>
+                          <a:latin typeface="Calibri" pitchFamily="34" charset="0"/>
+                          <a:ea typeface="Calibri" pitchFamily="34" charset="-122"/>
+                          <a:cs typeface="Calibri" pitchFamily="34" charset="-120"/>
+                        </a:rPr>
+                        <a:t>Loss of professional purpose; limited autonomy over the work; professional standing; exposure to parental complaint and legal risk</a:t>
+                      </a:r>
+                      <a:endParaRPr lang="en-US" sz="1100" dirty="0">
+                        <a:latin typeface="Calibri" charset="0"/>
+                        <a:ea typeface="Calibri" charset="0"/>
+                        <a:cs typeface="Calibri" charset="0"/>
+                      </a:endParaRPr>
+                    </a:p>
+                  </a:txBody>
+                  <a:tcPr marL="91440" marR="91440" marT="54864" marB="54864" anchor="ctr">
+                    <a:lnL w="9525" cap="flat" cmpd="sng" algn="ctr">
+                      <a:solidFill>
+                        <a:srgbClr val="C9D4E0"/>
+                      </a:solidFill>
+                      <a:prstDash val="solid"/>
+                      <a:round/>
+                      <a:headEnd type="none" w="med" len="med"/>
+                      <a:tailEnd type="none" w="med" len="med"/>
+                    </a:lnL>
+                    <a:lnR w="9525" cap="flat" cmpd="sng" algn="ctr">
+                      <a:solidFill>
+                        <a:srgbClr val="C9D4E0"/>
+                      </a:solidFill>
+                      <a:prstDash val="solid"/>
+                      <a:round/>
+                      <a:headEnd type="none" w="med" len="med"/>
+                      <a:tailEnd type="none" w="med" len="med"/>
+                    </a:lnR>
+                    <a:lnT w="9525" cap="flat" cmpd="sng" algn="ctr">
+                      <a:solidFill>
+                        <a:srgbClr val="C9D4E0"/>
+                      </a:solidFill>
+                      <a:prstDash val="solid"/>
+                      <a:round/>
+                      <a:headEnd type="none" w="med" len="med"/>
+                      <a:tailEnd type="none" w="med" len="med"/>
+                    </a:lnT>
+                    <a:lnB w="9525" cap="flat" cmpd="sng" algn="ctr">
+                      <a:solidFill>
+                        <a:srgbClr val="C9D4E0"/>
+                      </a:solidFill>
+                      <a:prstDash val="solid"/>
+                      <a:round/>
+                      <a:headEnd type="none" w="med" len="med"/>
+                      <a:tailEnd type="none" w="med" len="med"/>
+                    </a:lnB>
+                    <a:solidFill>
+                      <a:srgbClr val="FFFFFF"/>
+                    </a:solidFill>
+                  </a:tcPr>
+                </a:tc>
+              </a:tr>
+              <a:tr h="0">
+                <a:tc>
+                  <a:txBody>
+                    <a:bodyPr/>
+                    <a:lstStyle/>
+                    <a:p>
+                      <a:pPr indent="0" marL="0">
+                        <a:buNone/>
+                      </a:pPr>
+                      <a:r>
+                        <a:rPr lang="en-US" sz="1150" b="1" dirty="0">
+                          <a:solidFill>
+                            <a:srgbClr val="1F3864"/>
+                          </a:solidFill>
+                          <a:latin typeface="Calibri" pitchFamily="34" charset="0"/>
+                          <a:ea typeface="Calibri" pitchFamily="34" charset="-122"/>
+                          <a:cs typeface="Calibri" pitchFamily="34" charset="-120"/>
+                        </a:rPr>
+                        <a:t>Working conditions</a:t>
+                      </a:r>
+                      <a:endParaRPr lang="en-US" sz="1150" dirty="0">
+                        <a:latin typeface="Calibri" charset="0"/>
+                        <a:ea typeface="Calibri" charset="0"/>
+                        <a:cs typeface="Calibri" charset="0"/>
+                      </a:endParaRPr>
+                    </a:p>
+                  </a:txBody>
+                  <a:tcPr marL="91440" marR="91440" marT="54864" marB="54864" anchor="ctr">
+                    <a:lnL w="9525" cap="flat" cmpd="sng" algn="ctr">
+                      <a:solidFill>
+                        <a:srgbClr val="C9D4E0"/>
+                      </a:solidFill>
+                      <a:prstDash val="solid"/>
+                      <a:round/>
+                      <a:headEnd type="none" w="med" len="med"/>
+                      <a:tailEnd type="none" w="med" len="med"/>
+                    </a:lnL>
+                    <a:lnR w="9525" cap="flat" cmpd="sng" algn="ctr">
+                      <a:solidFill>
+                        <a:srgbClr val="C9D4E0"/>
+                      </a:solidFill>
+                      <a:prstDash val="solid"/>
+                      <a:round/>
+                      <a:headEnd type="none" w="med" len="med"/>
+                      <a:tailEnd type="none" w="med" len="med"/>
+                    </a:lnR>
+                    <a:lnT w="9525" cap="flat" cmpd="sng" algn="ctr">
+                      <a:solidFill>
+                        <a:srgbClr val="C9D4E0"/>
+                      </a:solidFill>
+                      <a:prstDash val="solid"/>
+                      <a:round/>
+                      <a:headEnd type="none" w="med" len="med"/>
+                      <a:tailEnd type="none" w="med" len="med"/>
+                    </a:lnT>
+                    <a:lnB w="9525" cap="flat" cmpd="sng" algn="ctr">
+                      <a:solidFill>
+                        <a:srgbClr val="C9D4E0"/>
+                      </a:solidFill>
+                      <a:prstDash val="solid"/>
+                      <a:round/>
+                      <a:headEnd type="none" w="med" len="med"/>
+                      <a:tailEnd type="none" w="med" len="med"/>
+                    </a:lnB>
+                    <a:solidFill>
+                      <a:srgbClr val="F2F6FA"/>
+                    </a:solidFill>
+                  </a:tcPr>
+                </a:tc>
+                <a:tc>
+                  <a:txBody>
+                    <a:bodyPr/>
+                    <a:lstStyle/>
+                    <a:p>
+                      <a:pPr indent="0" marL="0">
+                        <a:buNone/>
+                      </a:pPr>
+                      <a:r>
+                        <a:rPr lang="en-US" sz="1100" dirty="0">
+                          <a:solidFill>
+                            <a:srgbClr val="1A1A1A"/>
+                          </a:solidFill>
+                          <a:latin typeface="Calibri" pitchFamily="34" charset="0"/>
+                          <a:ea typeface="Calibri" pitchFamily="34" charset="-122"/>
+                          <a:cs typeface="Calibri" pitchFamily="34" charset="-120"/>
+                        </a:rPr>
+                        <a:t>Hours and total workload; pupil behaviour and classroom discipline; administrative demands; limited access to reduced hours; burnout</a:t>
+                      </a:r>
+                      <a:endParaRPr lang="en-US" sz="1100" dirty="0">
+                        <a:latin typeface="Calibri" charset="0"/>
+                        <a:ea typeface="Calibri" charset="0"/>
+                        <a:cs typeface="Calibri" charset="0"/>
+                      </a:endParaRPr>
+                    </a:p>
+                  </a:txBody>
+                  <a:tcPr marL="91440" marR="91440" marT="54864" marB="54864" anchor="ctr">
+                    <a:lnL w="9525" cap="flat" cmpd="sng" algn="ctr">
+                      <a:solidFill>
+                        <a:srgbClr val="C9D4E0"/>
+                      </a:solidFill>
+                      <a:prstDash val="solid"/>
+                      <a:round/>
+                      <a:headEnd type="none" w="med" len="med"/>
+                      <a:tailEnd type="none" w="med" len="med"/>
+                    </a:lnL>
+                    <a:lnR w="9525" cap="flat" cmpd="sng" algn="ctr">
+                      <a:solidFill>
+                        <a:srgbClr val="C9D4E0"/>
+                      </a:solidFill>
+                      <a:prstDash val="solid"/>
+                      <a:round/>
+                      <a:headEnd type="none" w="med" len="med"/>
+                      <a:tailEnd type="none" w="med" len="med"/>
+                    </a:lnR>
+                    <a:lnT w="9525" cap="flat" cmpd="sng" algn="ctr">
+                      <a:solidFill>
+                        <a:srgbClr val="C9D4E0"/>
+                      </a:solidFill>
+                      <a:prstDash val="solid"/>
+                      <a:round/>
+                      <a:headEnd type="none" w="med" len="med"/>
+                      <a:tailEnd type="none" w="med" len="med"/>
+                    </a:lnT>
+                    <a:lnB w="9525" cap="flat" cmpd="sng" algn="ctr">
+                      <a:solidFill>
+                        <a:srgbClr val="C9D4E0"/>
+                      </a:solidFill>
+                      <a:prstDash val="solid"/>
+                      <a:round/>
+                      <a:headEnd type="none" w="med" len="med"/>
+                      <a:tailEnd type="none" w="med" len="med"/>
+                    </a:lnB>
+                    <a:solidFill>
+                      <a:srgbClr val="F2F6FA"/>
+                    </a:solidFill>
+                  </a:tcPr>
+                </a:tc>
+              </a:tr>
+              <a:tr h="0">
+                <a:tc>
+                  <a:txBody>
+                    <a:bodyPr/>
+                    <a:lstStyle/>
+                    <a:p>
+                      <a:pPr indent="0" marL="0">
+                        <a:buNone/>
+                      </a:pPr>
+                      <a:r>
+                        <a:rPr lang="en-US" sz="1150" b="1" dirty="0">
+                          <a:solidFill>
+                            <a:srgbClr val="1F3864"/>
+                          </a:solidFill>
+                          <a:latin typeface="Calibri" pitchFamily="34" charset="0"/>
+                          <a:ea typeface="Calibri" pitchFamily="34" charset="-122"/>
+                          <a:cs typeface="Calibri" pitchFamily="34" charset="-120"/>
+                        </a:rPr>
+                        <a:t>Organisational factors</a:t>
+                      </a:r>
+                      <a:endParaRPr lang="en-US" sz="1150" dirty="0">
+                        <a:latin typeface="Calibri" charset="0"/>
+                        <a:ea typeface="Calibri" charset="0"/>
+                        <a:cs typeface="Calibri" charset="0"/>
+                      </a:endParaRPr>
+                    </a:p>
+                  </a:txBody>
+                  <a:tcPr marL="91440" marR="91440" marT="54864" marB="54864" anchor="ctr">
+                    <a:lnL w="9525" cap="flat" cmpd="sng" algn="ctr">
+                      <a:solidFill>
+                        <a:srgbClr val="C9D4E0"/>
+                      </a:solidFill>
+                      <a:prstDash val="solid"/>
+                      <a:round/>
+                      <a:headEnd type="none" w="med" len="med"/>
+                      <a:tailEnd type="none" w="med" len="med"/>
+                    </a:lnL>
+                    <a:lnR w="9525" cap="flat" cmpd="sng" algn="ctr">
+                      <a:solidFill>
+                        <a:srgbClr val="C9D4E0"/>
+                      </a:solidFill>
+                      <a:prstDash val="solid"/>
+                      <a:round/>
+                      <a:headEnd type="none" w="med" len="med"/>
+                      <a:tailEnd type="none" w="med" len="med"/>
+                    </a:lnR>
+                    <a:lnT w="9525" cap="flat" cmpd="sng" algn="ctr">
+                      <a:solidFill>
+                        <a:srgbClr val="C9D4E0"/>
+                      </a:solidFill>
+                      <a:prstDash val="solid"/>
+                      <a:round/>
+                      <a:headEnd type="none" w="med" len="med"/>
+                      <a:tailEnd type="none" w="med" len="med"/>
+                    </a:lnT>
+                    <a:lnB w="9525" cap="flat" cmpd="sng" algn="ctr">
+                      <a:solidFill>
+                        <a:srgbClr val="C9D4E0"/>
+                      </a:solidFill>
+                      <a:prstDash val="solid"/>
+                      <a:round/>
+                      <a:headEnd type="none" w="med" len="med"/>
+                      <a:tailEnd type="none" w="med" len="med"/>
+                    </a:lnB>
+                    <a:solidFill>
+                      <a:srgbClr val="FFFFFF"/>
+                    </a:solidFill>
+                  </a:tcPr>
+                </a:tc>
+                <a:tc>
+                  <a:txBody>
+                    <a:bodyPr/>
+                    <a:lstStyle/>
+                    <a:p>
+                      <a:pPr indent="0" marL="0">
+                        <a:buNone/>
+                      </a:pPr>
+                      <a:r>
+                        <a:rPr lang="en-US" sz="1100" dirty="0">
+                          <a:solidFill>
+                            <a:srgbClr val="1A1A1A"/>
+                          </a:solidFill>
+                          <a:latin typeface="Calibri" pitchFamily="34" charset="0"/>
+                          <a:ea typeface="Calibri" pitchFamily="34" charset="-122"/>
+                          <a:cs typeface="Calibri" pitchFamily="34" charset="-120"/>
+                        </a:rPr>
+                        <a:t>School leadership; collegial support and team structure</a:t>
+                      </a:r>
+                      <a:endParaRPr lang="en-US" sz="1100" dirty="0">
+                        <a:latin typeface="Calibri" charset="0"/>
+                        <a:ea typeface="Calibri" charset="0"/>
+                        <a:cs typeface="Calibri" charset="0"/>
+                      </a:endParaRPr>
+                    </a:p>
+                  </a:txBody>
+                  <a:tcPr marL="91440" marR="91440" marT="54864" marB="54864" anchor="ctr">
+                    <a:lnL w="9525" cap="flat" cmpd="sng" algn="ctr">
+                      <a:solidFill>
+                        <a:srgbClr val="C9D4E0"/>
+                      </a:solidFill>
+                      <a:prstDash val="solid"/>
+                      <a:round/>
+                      <a:headEnd type="none" w="med" len="med"/>
+                      <a:tailEnd type="none" w="med" len="med"/>
+                    </a:lnL>
+                    <a:lnR w="9525" cap="flat" cmpd="sng" algn="ctr">
+                      <a:solidFill>
+                        <a:srgbClr val="C9D4E0"/>
+                      </a:solidFill>
+                      <a:prstDash val="solid"/>
+                      <a:round/>
+                      <a:headEnd type="none" w="med" len="med"/>
+                      <a:tailEnd type="none" w="med" len="med"/>
+                    </a:lnR>
+                    <a:lnT w="9525" cap="flat" cmpd="sng" algn="ctr">
+                      <a:solidFill>
+                        <a:srgbClr val="C9D4E0"/>
+                      </a:solidFill>
+                      <a:prstDash val="solid"/>
+                      <a:round/>
+                      <a:headEnd type="none" w="med" len="med"/>
+                      <a:tailEnd type="none" w="med" len="med"/>
+                    </a:lnT>
+                    <a:lnB w="9525" cap="flat" cmpd="sng" algn="ctr">
+                      <a:solidFill>
+                        <a:srgbClr val="C9D4E0"/>
+                      </a:solidFill>
+                      <a:prstDash val="solid"/>
+                      <a:round/>
+                      <a:headEnd type="none" w="med" len="med"/>
+                      <a:tailEnd type="none" w="med" len="med"/>
+                    </a:lnB>
+                    <a:solidFill>
+                      <a:srgbClr val="FFFFFF"/>
+                    </a:solidFill>
+                  </a:tcPr>
+                </a:tc>
+              </a:tr>
+              <a:tr h="0">
+                <a:tc>
+                  <a:txBody>
+                    <a:bodyPr/>
+                    <a:lstStyle/>
+                    <a:p>
+                      <a:pPr indent="0" marL="0">
+                        <a:buNone/>
+                      </a:pPr>
+                      <a:r>
+                        <a:rPr lang="en-US" sz="1150" b="1" dirty="0">
+                          <a:solidFill>
+                            <a:srgbClr val="1F3864"/>
+                          </a:solidFill>
+                          <a:latin typeface="Calibri" pitchFamily="34" charset="0"/>
+                          <a:ea typeface="Calibri" pitchFamily="34" charset="-122"/>
+                          <a:cs typeface="Calibri" pitchFamily="34" charset="-120"/>
+                        </a:rPr>
+                        <a:t>Accountability and regulation</a:t>
+                      </a:r>
+                      <a:endParaRPr lang="en-US" sz="1150" dirty="0">
+                        <a:latin typeface="Calibri" charset="0"/>
+                        <a:ea typeface="Calibri" charset="0"/>
+                        <a:cs typeface="Calibri" charset="0"/>
+                      </a:endParaRPr>
+                    </a:p>
+                  </a:txBody>
+                  <a:tcPr marL="91440" marR="91440" marT="54864" marB="54864" anchor="ctr">
+                    <a:lnL w="9525" cap="flat" cmpd="sng" algn="ctr">
+                      <a:solidFill>
+                        <a:srgbClr val="C9D4E0"/>
+                      </a:solidFill>
+                      <a:prstDash val="solid"/>
+                      <a:round/>
+                      <a:headEnd type="none" w="med" len="med"/>
+                      <a:tailEnd type="none" w="med" len="med"/>
+                    </a:lnL>
+                    <a:lnR w="9525" cap="flat" cmpd="sng" algn="ctr">
+                      <a:solidFill>
+                        <a:srgbClr val="C9D4E0"/>
+                      </a:solidFill>
+                      <a:prstDash val="solid"/>
+                      <a:round/>
+                      <a:headEnd type="none" w="med" len="med"/>
+                      <a:tailEnd type="none" w="med" len="med"/>
+                    </a:lnR>
+                    <a:lnT w="9525" cap="flat" cmpd="sng" algn="ctr">
+                      <a:solidFill>
+                        <a:srgbClr val="C9D4E0"/>
+                      </a:solidFill>
+                      <a:prstDash val="solid"/>
+                      <a:round/>
+                      <a:headEnd type="none" w="med" len="med"/>
+                      <a:tailEnd type="none" w="med" len="med"/>
+                    </a:lnT>
+                    <a:lnB w="9525" cap="flat" cmpd="sng" algn="ctr">
+                      <a:solidFill>
+                        <a:srgbClr val="C9D4E0"/>
+                      </a:solidFill>
+                      <a:prstDash val="solid"/>
+                      <a:round/>
+                      <a:headEnd type="none" w="med" len="med"/>
+                      <a:tailEnd type="none" w="med" len="med"/>
+                    </a:lnB>
+                    <a:solidFill>
+                      <a:srgbClr val="F2F6FA"/>
+                    </a:solidFill>
+                  </a:tcPr>
+                </a:tc>
+                <a:tc>
+                  <a:txBody>
+                    <a:bodyPr/>
+                    <a:lstStyle/>
+                    <a:p>
+                      <a:pPr indent="0" marL="0">
+                        <a:buNone/>
+                      </a:pPr>
+                      <a:r>
+                        <a:rPr lang="en-US" sz="1100" dirty="0">
+                          <a:solidFill>
+                            <a:srgbClr val="1A1A1A"/>
+                          </a:solidFill>
+                          <a:latin typeface="Calibri" pitchFamily="34" charset="0"/>
+                          <a:ea typeface="Calibri" pitchFamily="34" charset="-122"/>
+                          <a:cs typeface="Calibri" pitchFamily="34" charset="-120"/>
+                        </a:rPr>
+                        <a:t>External inspection and its consequences; certification and licensing requirements</a:t>
+                      </a:r>
+                      <a:endParaRPr lang="en-US" sz="1100" dirty="0">
+                        <a:latin typeface="Calibri" charset="0"/>
+                        <a:ea typeface="Calibri" charset="0"/>
+                        <a:cs typeface="Calibri" charset="0"/>
+                      </a:endParaRPr>
+                    </a:p>
+                  </a:txBody>
+                  <a:tcPr marL="91440" marR="91440" marT="54864" marB="54864" anchor="ctr">
+                    <a:lnL w="9525" cap="flat" cmpd="sng" algn="ctr">
+                      <a:solidFill>
+                        <a:srgbClr val="C9D4E0"/>
+                      </a:solidFill>
+                      <a:prstDash val="solid"/>
+                      <a:round/>
+                      <a:headEnd type="none" w="med" len="med"/>
+                      <a:tailEnd type="none" w="med" len="med"/>
+                    </a:lnL>
+                    <a:lnR w="9525" cap="flat" cmpd="sng" algn="ctr">
+                      <a:solidFill>
+                        <a:srgbClr val="C9D4E0"/>
+                      </a:solidFill>
+                      <a:prstDash val="solid"/>
+                      <a:round/>
+                      <a:headEnd type="none" w="med" len="med"/>
+                      <a:tailEnd type="none" w="med" len="med"/>
+                    </a:lnR>
+                    <a:lnT w="9525" cap="flat" cmpd="sng" algn="ctr">
+                      <a:solidFill>
+                        <a:srgbClr val="C9D4E0"/>
+                      </a:solidFill>
+                      <a:prstDash val="solid"/>
+                      <a:round/>
+                      <a:headEnd type="none" w="med" len="med"/>
+                      <a:tailEnd type="none" w="med" len="med"/>
+                    </a:lnT>
+                    <a:lnB w="9525" cap="flat" cmpd="sng" algn="ctr">
+                      <a:solidFill>
+                        <a:srgbClr val="C9D4E0"/>
+                      </a:solidFill>
+                      <a:prstDash val="solid"/>
+                      <a:round/>
+                      <a:headEnd type="none" w="med" len="med"/>
+                      <a:tailEnd type="none" w="med" len="med"/>
+                    </a:lnB>
+                    <a:solidFill>
+                      <a:srgbClr val="F2F6FA"/>
+                    </a:solidFill>
+                  </a:tcPr>
+                </a:tc>
+              </a:tr>
+              <a:tr h="0">
+                <a:tc>
+                  <a:txBody>
+                    <a:bodyPr/>
+                    <a:lstStyle/>
+                    <a:p>
+                      <a:pPr indent="0" marL="0">
+                        <a:buNone/>
+                      </a:pPr>
+                      <a:r>
+                        <a:rPr lang="en-US" sz="1150" b="1" dirty="0">
+                          <a:solidFill>
+                            <a:srgbClr val="1F3864"/>
+                          </a:solidFill>
+                          <a:latin typeface="Calibri" pitchFamily="34" charset="0"/>
+                          <a:ea typeface="Calibri" pitchFamily="34" charset="-122"/>
+                          <a:cs typeface="Calibri" pitchFamily="34" charset="-120"/>
+                        </a:rPr>
+                        <a:t>Financial factors</a:t>
+                      </a:r>
+                      <a:endParaRPr lang="en-US" sz="1150" dirty="0">
+                        <a:latin typeface="Calibri" charset="0"/>
+                        <a:ea typeface="Calibri" charset="0"/>
+                        <a:cs typeface="Calibri" charset="0"/>
+                      </a:endParaRPr>
+                    </a:p>
+                  </a:txBody>
+                  <a:tcPr marL="91440" marR="91440" marT="54864" marB="54864" anchor="ctr">
+                    <a:lnL w="9525" cap="flat" cmpd="sng" algn="ctr">
+                      <a:solidFill>
+                        <a:srgbClr val="C9D4E0"/>
+                      </a:solidFill>
+                      <a:prstDash val="solid"/>
+                      <a:round/>
+                      <a:headEnd type="none" w="med" len="med"/>
+                      <a:tailEnd type="none" w="med" len="med"/>
+                    </a:lnL>
+                    <a:lnR w="9525" cap="flat" cmpd="sng" algn="ctr">
+                      <a:solidFill>
+                        <a:srgbClr val="C9D4E0"/>
+                      </a:solidFill>
+                      <a:prstDash val="solid"/>
+                      <a:round/>
+                      <a:headEnd type="none" w="med" len="med"/>
+                      <a:tailEnd type="none" w="med" len="med"/>
+                    </a:lnR>
+                    <a:lnT w="9525" cap="flat" cmpd="sng" algn="ctr">
+                      <a:solidFill>
+                        <a:srgbClr val="C9D4E0"/>
+                      </a:solidFill>
+                      <a:prstDash val="solid"/>
+                      <a:round/>
+                      <a:headEnd type="none" w="med" len="med"/>
+                      <a:tailEnd type="none" w="med" len="med"/>
+                    </a:lnT>
+                    <a:lnB w="9525" cap="flat" cmpd="sng" algn="ctr">
+                      <a:solidFill>
+                        <a:srgbClr val="C9D4E0"/>
+                      </a:solidFill>
+                      <a:prstDash val="solid"/>
+                      <a:round/>
+                      <a:headEnd type="none" w="med" len="med"/>
+                      <a:tailEnd type="none" w="med" len="med"/>
+                    </a:lnB>
+                    <a:solidFill>
+                      <a:srgbClr val="FFFFFF"/>
+                    </a:solidFill>
+                  </a:tcPr>
+                </a:tc>
+                <a:tc>
+                  <a:txBody>
+                    <a:bodyPr/>
+                    <a:lstStyle/>
+                    <a:p>
+                      <a:pPr indent="0" marL="0">
+                        <a:buNone/>
+                      </a:pPr>
+                      <a:r>
+                        <a:rPr lang="en-US" sz="1100" dirty="0">
+                          <a:solidFill>
+                            <a:srgbClr val="1A1A1A"/>
+                          </a:solidFill>
+                          <a:latin typeface="Calibri" pitchFamily="34" charset="0"/>
+                          <a:ea typeface="Calibri" pitchFamily="34" charset="-122"/>
+                          <a:cs typeface="Calibri" pitchFamily="34" charset="-120"/>
+                        </a:rPr>
+                        <a:t>Salary relative to outside options; pension design and its timing incentives; contract insecurity</a:t>
+                      </a:r>
+                      <a:endParaRPr lang="en-US" sz="1100" dirty="0">
+                        <a:latin typeface="Calibri" charset="0"/>
+                        <a:ea typeface="Calibri" charset="0"/>
+                        <a:cs typeface="Calibri" charset="0"/>
+                      </a:endParaRPr>
+                    </a:p>
+                  </a:txBody>
+                  <a:tcPr marL="91440" marR="91440" marT="54864" marB="54864" anchor="ctr">
+                    <a:lnL w="9525" cap="flat" cmpd="sng" algn="ctr">
+                      <a:solidFill>
+                        <a:srgbClr val="C9D4E0"/>
+                      </a:solidFill>
+                      <a:prstDash val="solid"/>
+                      <a:round/>
+                      <a:headEnd type="none" w="med" len="med"/>
+                      <a:tailEnd type="none" w="med" len="med"/>
+                    </a:lnL>
+                    <a:lnR w="9525" cap="flat" cmpd="sng" algn="ctr">
+                      <a:solidFill>
+                        <a:srgbClr val="C9D4E0"/>
+                      </a:solidFill>
+                      <a:prstDash val="solid"/>
+                      <a:round/>
+                      <a:headEnd type="none" w="med" len="med"/>
+                      <a:tailEnd type="none" w="med" len="med"/>
+                    </a:lnR>
+                    <a:lnT w="9525" cap="flat" cmpd="sng" algn="ctr">
+                      <a:solidFill>
+                        <a:srgbClr val="C9D4E0"/>
+                      </a:solidFill>
+                      <a:prstDash val="solid"/>
+                      <a:round/>
+                      <a:headEnd type="none" w="med" len="med"/>
+                      <a:tailEnd type="none" w="med" len="med"/>
+                    </a:lnT>
+                    <a:lnB w="9525" cap="flat" cmpd="sng" algn="ctr">
+                      <a:solidFill>
+                        <a:srgbClr val="C9D4E0"/>
+                      </a:solidFill>
+                      <a:prstDash val="solid"/>
+                      <a:round/>
+                      <a:headEnd type="none" w="med" len="med"/>
+                      <a:tailEnd type="none" w="med" len="med"/>
+                    </a:lnB>
+                    <a:solidFill>
+                      <a:srgbClr val="FFFFFF"/>
+                    </a:solidFill>
+                  </a:tcPr>
+                </a:tc>
+              </a:tr>
+              <a:tr h="0">
+                <a:tc>
+                  <a:txBody>
+                    <a:bodyPr/>
+                    <a:lstStyle/>
+                    <a:p>
+                      <a:pPr indent="0" marL="0">
+                        <a:buNone/>
+                      </a:pPr>
+                      <a:r>
+                        <a:rPr lang="en-US" sz="1150" b="1" dirty="0">
+                          <a:solidFill>
+                            <a:srgbClr val="1F3864"/>
+                          </a:solidFill>
+                          <a:latin typeface="Calibri" pitchFamily="34" charset="0"/>
+                          <a:ea typeface="Calibri" pitchFamily="34" charset="-122"/>
+                          <a:cs typeface="Calibri" pitchFamily="34" charset="-120"/>
+                        </a:rPr>
+                        <a:t>Personal and life-course factors</a:t>
+                      </a:r>
+                      <a:endParaRPr lang="en-US" sz="1150" dirty="0">
+                        <a:latin typeface="Calibri" charset="0"/>
+                        <a:ea typeface="Calibri" charset="0"/>
+                        <a:cs typeface="Calibri" charset="0"/>
+                      </a:endParaRPr>
+                    </a:p>
+                  </a:txBody>
+                  <a:tcPr marL="91440" marR="91440" marT="54864" marB="54864" anchor="ctr">
+                    <a:lnL w="9525" cap="flat" cmpd="sng" algn="ctr">
+                      <a:solidFill>
+                        <a:srgbClr val="C9D4E0"/>
+                      </a:solidFill>
+                      <a:prstDash val="solid"/>
+                      <a:round/>
+                      <a:headEnd type="none" w="med" len="med"/>
+                      <a:tailEnd type="none" w="med" len="med"/>
+                    </a:lnL>
+                    <a:lnR w="9525" cap="flat" cmpd="sng" algn="ctr">
+                      <a:solidFill>
+                        <a:srgbClr val="C9D4E0"/>
+                      </a:solidFill>
+                      <a:prstDash val="solid"/>
+                      <a:round/>
+                      <a:headEnd type="none" w="med" len="med"/>
+                      <a:tailEnd type="none" w="med" len="med"/>
+                    </a:lnR>
+                    <a:lnT w="9525" cap="flat" cmpd="sng" algn="ctr">
+                      <a:solidFill>
+                        <a:srgbClr val="C9D4E0"/>
+                      </a:solidFill>
+                      <a:prstDash val="solid"/>
+                      <a:round/>
+                      <a:headEnd type="none" w="med" len="med"/>
+                      <a:tailEnd type="none" w="med" len="med"/>
+                    </a:lnT>
+                    <a:lnB w="9525" cap="flat" cmpd="sng" algn="ctr">
+                      <a:solidFill>
+                        <a:srgbClr val="C9D4E0"/>
+                      </a:solidFill>
+                      <a:prstDash val="solid"/>
+                      <a:round/>
+                      <a:headEnd type="none" w="med" len="med"/>
+                      <a:tailEnd type="none" w="med" len="med"/>
+                    </a:lnB>
+                    <a:solidFill>
+                      <a:srgbClr val="F2F6FA"/>
+                    </a:solidFill>
+                  </a:tcPr>
+                </a:tc>
+                <a:tc>
+                  <a:txBody>
+                    <a:bodyPr/>
+                    <a:lstStyle/>
+                    <a:p>
+                      <a:pPr indent="0" marL="0">
+                        <a:buNone/>
+                      </a:pPr>
+                      <a:r>
+                        <a:rPr lang="en-US" sz="1100" dirty="0">
+                          <a:solidFill>
+                            <a:srgbClr val="1A1A1A"/>
+                          </a:solidFill>
+                          <a:latin typeface="Calibri" pitchFamily="34" charset="0"/>
+                          <a:ea typeface="Calibri" pitchFamily="34" charset="-122"/>
+                          <a:cs typeface="Calibri" pitchFamily="34" charset="-120"/>
+                        </a:rPr>
+                        <a:t>Family formation and care; childbirth; health and incapacity; relocation and a partner's circumstances; retirement and career stage</a:t>
+                      </a:r>
+                      <a:endParaRPr lang="en-US" sz="1100" dirty="0">
+                        <a:latin typeface="Calibri" charset="0"/>
+                        <a:ea typeface="Calibri" charset="0"/>
+                        <a:cs typeface="Calibri" charset="0"/>
+                      </a:endParaRPr>
+                    </a:p>
+                  </a:txBody>
+                  <a:tcPr marL="91440" marR="91440" marT="54864" marB="54864" anchor="ctr">
+                    <a:lnL w="9525" cap="flat" cmpd="sng" algn="ctr">
+                      <a:solidFill>
+                        <a:srgbClr val="C9D4E0"/>
+                      </a:solidFill>
+                      <a:prstDash val="solid"/>
+                      <a:round/>
+                      <a:headEnd type="none" w="med" len="med"/>
+                      <a:tailEnd type="none" w="med" len="med"/>
+                    </a:lnL>
+                    <a:lnR w="9525" cap="flat" cmpd="sng" algn="ctr">
+                      <a:solidFill>
+                        <a:srgbClr val="C9D4E0"/>
+                      </a:solidFill>
+                      <a:prstDash val="solid"/>
+                      <a:round/>
+                      <a:headEnd type="none" w="med" len="med"/>
+                      <a:tailEnd type="none" w="med" len="med"/>
+                    </a:lnR>
+                    <a:lnT w="9525" cap="flat" cmpd="sng" algn="ctr">
+                      <a:solidFill>
+                        <a:srgbClr val="C9D4E0"/>
+                      </a:solidFill>
+                      <a:prstDash val="solid"/>
+                      <a:round/>
+                      <a:headEnd type="none" w="med" len="med"/>
+                      <a:tailEnd type="none" w="med" len="med"/>
+                    </a:lnT>
+                    <a:lnB w="9525" cap="flat" cmpd="sng" algn="ctr">
+                      <a:solidFill>
+                        <a:srgbClr val="C9D4E0"/>
+                      </a:solidFill>
+                      <a:prstDash val="solid"/>
+                      <a:round/>
+                      <a:headEnd type="none" w="med" len="med"/>
+                      <a:tailEnd type="none" w="med" len="med"/>
+                    </a:lnB>
+                    <a:solidFill>
+                      <a:srgbClr val="F2F6FA"/>
+                    </a:solidFill>
+                  </a:tcPr>
+                </a:tc>
+              </a:tr>
+            </a:tbl>
+          </a:graphicData>
+        </a:graphic>
+      </p:graphicFrame>
+      <p:sp>
+        <p:nvSpPr>
+          <p:cNvPr id="4" name="Text 1"/>
           <p:cNvSpPr txBox="1"/>
           <p:nvPr/>
         </p:nvSpPr>
         <p:spPr>
           <a:xfrm>
-            <a:off x="594360" y="1371600"/>
-            <a:ext cx="7955280" cy="2743200"/>
+            <a:off x="640080" y="4736592"/>
+            <a:ext cx="7863840" cy="228600"/>
           </a:xfrm>
           <a:prstGeom prst="rect">
             <a:avLst/>
@@ -1905,216 +2782,24 @@
           <a:ln/>
         </p:spPr>
         <p:txBody>
-          <a:bodyPr wrap="square" lIns="0" tIns="0" rIns="0" bIns="0" rtlCol="0" anchor="t"/>
+          <a:bodyPr wrap="square" lIns="0" tIns="0" rIns="0" bIns="0" rtlCol="0" anchor="ctr"/>
           <a:lstStyle/>
           <a:p>
-            <a:pPr algn="l" marL="152400" indent="-152400">
-              <a:lnSpc>
-                <a:spcPts val="1900"/>
-              </a:lnSpc>
-              <a:buSzPct val="100000"/>
-              <a:buChar char="•"/>
+            <a:pPr indent="0" marL="0">
+              <a:buNone/>
             </a:pPr>
             <a:r>
-              <a:rPr lang="en-US" sz="1400" b="1" dirty="0">
+              <a:rPr lang="en-US" sz="950" dirty="0">
                 <a:solidFill>
-                  <a:srgbClr val="1A1A1A"/>
+                  <a:srgbClr val="76828E"/>
                 </a:solidFill>
                 <a:latin typeface="Calibri" pitchFamily="34" charset="0"/>
                 <a:ea typeface="Calibri" pitchFamily="34" charset="-122"/>
                 <a:cs typeface="Calibri" pitchFamily="34" charset="-120"/>
               </a:rPr>
-              <a:t>Switchers </a:t>
-            </a:r>
-            <a:pPr algn="l" marL="152400" indent="-152400">
-              <a:lnSpc>
-                <a:spcPts val="1900"/>
-              </a:lnSpc>
-              <a:spcAft>
-                <a:spcPts val="1400"/>
-              </a:spcAft>
-              <a:buSzPct val="100000"/>
-              <a:buChar char="•"/>
-            </a:pPr>
-            <a:r>
-              <a:rPr lang="en-US" sz="1400" dirty="0">
-                <a:solidFill>
-                  <a:srgbClr val="1A1A1A"/>
-                </a:solidFill>
-                <a:latin typeface="Calibri" pitchFamily="34" charset="0"/>
-                <a:ea typeface="Calibri" pitchFamily="34" charset="-122"/>
-                <a:cs typeface="Calibri" pitchFamily="34" charset="-120"/>
-              </a:rPr>
-              <a:t>resign from teaching to take up other employment. Central margins: salary, job satisfaction and working conditions.</a:t>
-            </a:r>
-            <a:endParaRPr lang="en-US" sz="1400" dirty="0"/>
-          </a:p>
-          <a:p>
-            <a:pPr algn="l" marL="152400" indent="-152400">
-              <a:lnSpc>
-                <a:spcPts val="1900"/>
-              </a:lnSpc>
-              <a:buSzPct val="100000"/>
-              <a:buChar char="•"/>
-            </a:pPr>
-            <a:r>
-              <a:rPr lang="en-US" sz="1400" b="1" dirty="0">
-                <a:solidFill>
-                  <a:srgbClr val="1A1A1A"/>
-                </a:solidFill>
-                <a:latin typeface="Calibri" pitchFamily="34" charset="0"/>
-                <a:ea typeface="Calibri" pitchFamily="34" charset="-122"/>
-                <a:cs typeface="Calibri" pitchFamily="34" charset="-120"/>
-              </a:rPr>
-              <a:t>Leavers </a:t>
-            </a:r>
-            <a:pPr algn="l" marL="152400" indent="-152400">
-              <a:lnSpc>
-                <a:spcPts val="1900"/>
-              </a:lnSpc>
-              <a:spcAft>
-                <a:spcPts val="1400"/>
-              </a:spcAft>
-              <a:buSzPct val="100000"/>
-              <a:buChar char="•"/>
-            </a:pPr>
-            <a:r>
-              <a:rPr lang="en-US" sz="1400" dirty="0">
-                <a:solidFill>
-                  <a:srgbClr val="1A1A1A"/>
-                </a:solidFill>
-                <a:latin typeface="Calibri" pitchFamily="34" charset="0"/>
-                <a:ea typeface="Calibri" pitchFamily="34" charset="-122"/>
-                <a:cs typeface="Calibri" pitchFamily="34" charset="-120"/>
-              </a:rPr>
-              <a:t>withdraw from the labour market. Central margins: household arrangements and flexibility.</a:t>
-            </a:r>
-            <a:endParaRPr lang="en-US" sz="1400" dirty="0"/>
-          </a:p>
-          <a:p>
-            <a:pPr algn="l" marL="152400" indent="-152400">
-              <a:lnSpc>
-                <a:spcPts val="1900"/>
-              </a:lnSpc>
-              <a:buSzPct val="100000"/>
-              <a:buChar char="•"/>
-            </a:pPr>
-            <a:r>
-              <a:rPr lang="en-US" sz="1400" b="1" dirty="0">
-                <a:solidFill>
-                  <a:srgbClr val="1A1A1A"/>
-                </a:solidFill>
-                <a:latin typeface="Calibri" pitchFamily="34" charset="0"/>
-                <a:ea typeface="Calibri" pitchFamily="34" charset="-122"/>
-                <a:cs typeface="Calibri" pitchFamily="34" charset="-120"/>
-              </a:rPr>
-              <a:t>Retired teachers </a:t>
-            </a:r>
-            <a:pPr algn="l" marL="152400" indent="-152400">
-              <a:lnSpc>
-                <a:spcPts val="1900"/>
-              </a:lnSpc>
-              <a:spcAft>
-                <a:spcPts val="1400"/>
-              </a:spcAft>
-              <a:buSzPct val="100000"/>
-              <a:buChar char="•"/>
-            </a:pPr>
-            <a:r>
-              <a:rPr lang="en-US" sz="1400" dirty="0">
-                <a:solidFill>
-                  <a:srgbClr val="1A1A1A"/>
-                </a:solidFill>
-                <a:latin typeface="Calibri" pitchFamily="34" charset="0"/>
-                <a:ea typeface="Calibri" pitchFamily="34" charset="-122"/>
-                <a:cs typeface="Calibri" pitchFamily="34" charset="-120"/>
-              </a:rPr>
-              <a:t>reach the end of their working lives. Central margins: pension rules and re-employment possibilities.</a:t>
-            </a:r>
-            <a:endParaRPr lang="en-US" sz="1400" dirty="0"/>
-          </a:p>
-          <a:p>
-            <a:pPr algn="l" marL="152400" indent="-152400">
-              <a:lnSpc>
-                <a:spcPts val="1900"/>
-              </a:lnSpc>
-              <a:spcAft>
-                <a:spcPts val="1400"/>
-              </a:spcAft>
-              <a:buSzPct val="100000"/>
-              <a:buChar char="•"/>
-            </a:pPr>
-            <a:r>
-              <a:rPr lang="en-US" sz="1400" dirty="0">
-                <a:solidFill>
-                  <a:srgbClr val="1A1A1A"/>
-                </a:solidFill>
-                <a:latin typeface="Calibri" pitchFamily="34" charset="0"/>
-                <a:ea typeface="Calibri" pitchFamily="34" charset="-122"/>
-                <a:cs typeface="Calibri" pitchFamily="34" charset="-120"/>
-              </a:rPr>
-              <a:t>The determinants of leaving and the opportunity cost of re-entry differ across the three profiles and are highly country dependent.</a:t>
-            </a:r>
-            <a:endParaRPr lang="en-US" sz="1400" dirty="0"/>
-          </a:p>
-        </p:txBody>
-      </p:sp>
-      <p:sp>
-        <p:nvSpPr>
-          <p:cNvPr id="4" name="Text 2"/>
-          <p:cNvSpPr txBox="1"/>
-          <p:nvPr/>
-        </p:nvSpPr>
-        <p:spPr>
-          <a:xfrm>
-            <a:off x="594360" y="4315968"/>
-            <a:ext cx="7955280" cy="566928"/>
-          </a:xfrm>
-          <a:prstGeom prst="rect">
-            <a:avLst/>
-          </a:prstGeom>
-          <a:noFill/>
-          <a:ln/>
-        </p:spPr>
-        <p:txBody>
-          <a:bodyPr wrap="square" lIns="0" tIns="0" rIns="0" bIns="0" rtlCol="0" anchor="t"/>
-          <a:lstStyle/>
-          <a:p>
-            <a:pPr algn="l" indent="0" marL="0">
-              <a:lnSpc>
-                <a:spcPts val="1700"/>
-              </a:lnSpc>
-              <a:buNone/>
-            </a:pPr>
-            <a:r>
-              <a:rPr lang="en-US" sz="1350" b="1" i="1" dirty="0">
-                <a:solidFill>
-                  <a:srgbClr val="1F3864"/>
-                </a:solidFill>
-                <a:latin typeface="Calibri" pitchFamily="34" charset="0"/>
-                <a:ea typeface="Calibri" pitchFamily="34" charset="-122"/>
-                <a:cs typeface="Calibri" pitchFamily="34" charset="-120"/>
-              </a:rPr>
-              <a:t>Policy implication. </a:t>
-            </a:r>
-            <a:pPr algn="l" indent="0" marL="0">
-              <a:lnSpc>
-                <a:spcPts val="1700"/>
-              </a:lnSpc>
-              <a:buNone/>
-            </a:pPr>
-            <a:r>
-              <a:rPr lang="en-US" sz="1350" i="1" dirty="0">
-                <a:solidFill>
-                  <a:srgbClr val="1F3864"/>
-                </a:solidFill>
-                <a:latin typeface="Calibri" pitchFamily="34" charset="0"/>
-                <a:ea typeface="Calibri" pitchFamily="34" charset="-122"/>
-                <a:cs typeface="Calibri" pitchFamily="34" charset="-120"/>
-              </a:rPr>
-              <a:t>instruments must match the profile of the teacher they aim to recover; no single policy fits the three groups.</a:t>
-            </a:r>
-            <a:endParaRPr lang="en-US" sz="1350" dirty="0"/>
+              <a:t>Source: authors' elaboration on the literature reviewed in section 2.</a:t>
+            </a:r>
+            <a:endParaRPr lang="en-US" sz="950" dirty="0"/>
           </a:p>
         </p:txBody>
       </p:sp>
@@ -2158,8 +2843,8 @@
         </p:nvSpPr>
         <p:spPr>
           <a:xfrm>
-            <a:off x="594360" y="384048"/>
-            <a:ext cx="7955280" cy="777240"/>
+            <a:off x="640080" y="438912"/>
+            <a:ext cx="7863840" cy="731520"/>
           </a:xfrm>
           <a:prstGeom prst="rect">
             <a:avLst/>
@@ -2175,7 +2860,7 @@
               <a:buNone/>
             </a:pPr>
             <a:r>
-              <a:rPr lang="en-US" sz="2600" b="1" dirty="0">
+              <a:rPr lang="en-US" sz="2700" b="1" dirty="0">
                 <a:solidFill>
                   <a:srgbClr val="1F3864"/>
                 </a:solidFill>
@@ -2183,9 +2868,9 @@
                 <a:ea typeface="Cambria" pitchFamily="34" charset="-122"/>
                 <a:cs typeface="Cambria" pitchFamily="34" charset="-120"/>
               </a:rPr>
-              <a:t>Working conditions and school organisation drive exits</a:t>
-            </a:r>
-            <a:endParaRPr lang="en-US" sz="2600" dirty="0"/>
+              <a:t>The hierarchy of motives</a:t>
+            </a:r>
+            <a:endParaRPr lang="en-US" sz="2700" dirty="0"/>
           </a:p>
         </p:txBody>
       </p:sp>
@@ -2197,8 +2882,8 @@
         </p:nvSpPr>
         <p:spPr>
           <a:xfrm>
-            <a:off x="594360" y="1298448"/>
-            <a:ext cx="7955280" cy="2926080"/>
+            <a:off x="640080" y="1600200"/>
+            <a:ext cx="7863840" cy="3108960"/>
           </a:xfrm>
           <a:prstGeom prst="rect">
             <a:avLst/>
@@ -2210,18 +2895,19 @@
           <a:bodyPr wrap="square" lIns="0" tIns="0" rIns="0" bIns="0" rtlCol="0" anchor="t"/>
           <a:lstStyle/>
           <a:p>
-            <a:pPr algn="l" marL="152400" indent="-152400">
+            <a:pPr algn="l" marL="228600" indent="-228600">
               <a:lnSpc>
-                <a:spcPts val="1800"/>
+                <a:spcPts val="2100"/>
               </a:lnSpc>
               <a:spcAft>
-                <a:spcPts val="900"/>
+                <a:spcPts val="2400"/>
               </a:spcAft>
               <a:buSzPct val="100000"/>
-              <a:buChar char="•"/>
+              <a:buFont typeface="+mj-lt"/>
+              <a:buAutoNum type="arabicPeriod" startAt="1"/>
             </a:pPr>
             <a:r>
-              <a:rPr lang="en-US" sz="1350" dirty="0">
+              <a:rPr lang="en-US" sz="1500" dirty="0">
                 <a:solidFill>
                   <a:srgbClr val="1A1A1A"/>
                 </a:solidFill>
@@ -2229,23 +2915,24 @@
                 <a:ea typeface="Calibri" pitchFamily="34" charset="-122"/>
                 <a:cs typeface="Calibri" pitchFamily="34" charset="-120"/>
               </a:rPr>
-              <a:t>Meta-analyses rank working conditions and organisational support above salary, accountability and personal characteristics (Nguyen et al., 2020; Gundlach, Slemp and Hattie, 2024).</a:t>
-            </a:r>
-            <a:endParaRPr lang="en-US" sz="1350" dirty="0"/>
-          </a:p>
-          <a:p>
-            <a:pPr algn="l" marL="152400" indent="-152400">
+              <a:t>Working conditions and the organisational features of the school are the most consistently important determinants of leaving, above financial incentives, accountability and personal characteristics (Nguyen et al., 2020; Gundlach, Slemp and Hattie, 2024).</a:t>
+            </a:r>
+            <a:endParaRPr lang="en-US" sz="1500" dirty="0"/>
+          </a:p>
+          <a:p>
+            <a:pPr algn="l" marL="228600" indent="-228600">
               <a:lnSpc>
-                <a:spcPts val="1800"/>
+                <a:spcPts val="2100"/>
               </a:lnSpc>
               <a:spcAft>
-                <a:spcPts val="900"/>
+                <a:spcPts val="2400"/>
               </a:spcAft>
               <a:buSzPct val="100000"/>
-              <a:buChar char="•"/>
+              <a:buFont typeface="+mj-lt"/>
+              <a:buAutoNum type="arabicPeriod" startAt="1"/>
             </a:pPr>
             <a:r>
-              <a:rPr lang="en-US" sz="1350" dirty="0">
+              <a:rPr lang="en-US" sz="1500" dirty="0">
                 <a:solidFill>
                   <a:srgbClr val="1A1A1A"/>
                 </a:solidFill>
@@ -2253,23 +2940,24 @@
                 <a:ea typeface="Calibri" pitchFamily="34" charset="-122"/>
                 <a:cs typeface="Calibri" pitchFamily="34" charset="-120"/>
               </a:rPr>
-              <a:t>A one standard deviation improvement in school discipline climate halves the probability of leaving; contracted hours do not predict departures (Sims and Jerrim, 2020).</a:t>
-            </a:r>
-            <a:endParaRPr lang="en-US" sz="1350" dirty="0"/>
-          </a:p>
-          <a:p>
-            <a:pPr algn="l" marL="152400" indent="-152400">
+              <a:t>High workload, stress and weak organisational support raise exits substantially; salary and regulation matter, but with smaller effects across determinants.</a:t>
+            </a:r>
+            <a:endParaRPr lang="en-US" sz="1500" dirty="0"/>
+          </a:p>
+          <a:p>
+            <a:pPr algn="l" marL="228600" indent="-228600">
               <a:lnSpc>
-                <a:spcPts val="1800"/>
+                <a:spcPts val="2100"/>
               </a:lnSpc>
               <a:spcAft>
-                <a:spcPts val="900"/>
+                <a:spcPts val="2400"/>
               </a:spcAft>
               <a:buSzPct val="100000"/>
-              <a:buChar char="•"/>
+              <a:buFont typeface="+mj-lt"/>
+              <a:buAutoNum type="arabicPeriod" startAt="1"/>
             </a:pPr>
             <a:r>
-              <a:rPr lang="en-US" sz="1350" dirty="0">
+              <a:rPr lang="en-US" sz="1500" dirty="0">
                 <a:solidFill>
                   <a:srgbClr val="1A1A1A"/>
                 </a:solidFill>
@@ -2277,92 +2965,9 @@
                 <a:ea typeface="Calibri" pitchFamily="34" charset="-122"/>
                 <a:cs typeface="Calibri" pitchFamily="34" charset="-120"/>
               </a:rPr>
-              <a:t>Dissatisfaction with school leadership is among the most cited predictors of departure (Boyd et al., 2011; Ladd, 2011; Simon and Johnson, 2015); when leadership improves, turnover falls (Kraft, Marinell and Shen-Wei Yee, 2016).</a:t>
-            </a:r>
-            <a:endParaRPr lang="en-US" sz="1350" dirty="0"/>
-          </a:p>
-          <a:p>
-            <a:pPr algn="l" marL="152400" indent="-152400">
-              <a:lnSpc>
-                <a:spcPts val="1800"/>
-              </a:lnSpc>
-              <a:spcAft>
-                <a:spcPts val="900"/>
-              </a:spcAft>
-              <a:buSzPct val="100000"/>
-              <a:buChar char="•"/>
-            </a:pPr>
-            <a:r>
-              <a:rPr lang="en-US" sz="1350" dirty="0">
-                <a:solidFill>
-                  <a:srgbClr val="1A1A1A"/>
-                </a:solidFill>
-                <a:latin typeface="Calibri" pitchFamily="34" charset="0"/>
-                <a:ea typeface="Calibri" pitchFamily="34" charset="-122"/>
-                <a:cs typeface="Calibri" pitchFamily="34" charset="-120"/>
-              </a:rPr>
-              <a:t>Only 26% of teachers feel the profession is valued and only 22% of novices have an assigned mentor; recognition and induction support reduce departures (OECD, 2020; OECD, 2025c; Walker et al., 2024).</a:t>
-            </a:r>
-            <a:endParaRPr lang="en-US" sz="1350" dirty="0"/>
-          </a:p>
-        </p:txBody>
-      </p:sp>
-      <p:sp>
-        <p:nvSpPr>
-          <p:cNvPr id="4" name="Text 2"/>
-          <p:cNvSpPr txBox="1"/>
-          <p:nvPr/>
-        </p:nvSpPr>
-        <p:spPr>
-          <a:xfrm>
-            <a:off x="594360" y="4315968"/>
-            <a:ext cx="7955280" cy="566928"/>
-          </a:xfrm>
-          <a:prstGeom prst="rect">
-            <a:avLst/>
-          </a:prstGeom>
-          <a:noFill/>
-          <a:ln/>
-        </p:spPr>
-        <p:txBody>
-          <a:bodyPr wrap="square" lIns="0" tIns="0" rIns="0" bIns="0" rtlCol="0" anchor="t"/>
-          <a:lstStyle/>
-          <a:p>
-            <a:pPr algn="l" indent="0" marL="0">
-              <a:lnSpc>
-                <a:spcPts val="1700"/>
-              </a:lnSpc>
-              <a:buNone/>
-            </a:pPr>
-            <a:r>
-              <a:rPr lang="en-US" sz="1350" b="1" i="1" dirty="0">
-                <a:solidFill>
-                  <a:srgbClr val="1F3864"/>
-                </a:solidFill>
-                <a:latin typeface="Calibri" pitchFamily="34" charset="0"/>
-                <a:ea typeface="Calibri" pitchFamily="34" charset="-122"/>
-                <a:cs typeface="Calibri" pitchFamily="34" charset="-120"/>
-              </a:rPr>
-              <a:t>Policy implication. </a:t>
-            </a:r>
-            <a:pPr algn="l" indent="0" marL="0">
-              <a:lnSpc>
-                <a:spcPts val="1700"/>
-              </a:lnSpc>
-              <a:buNone/>
-            </a:pPr>
-            <a:r>
-              <a:rPr lang="en-US" sz="1350" i="1" dirty="0">
-                <a:solidFill>
-                  <a:srgbClr val="1F3864"/>
-                </a:solidFill>
-                <a:latin typeface="Calibri" pitchFamily="34" charset="0"/>
-                <a:ea typeface="Calibri" pitchFamily="34" charset="-122"/>
-                <a:cs typeface="Calibri" pitchFamily="34" charset="-120"/>
-              </a:rPr>
-              <a:t>place returners in schools with strong leadership and orderly climates; a weak school reproduces the first exit.</a:t>
-            </a:r>
-            <a:endParaRPr lang="en-US" sz="1350" dirty="0"/>
+              <a:t>The conditions under which teaching takes place are the main institutional margin through which systems can influence retention.</a:t>
+            </a:r>
+            <a:endParaRPr lang="en-US" sz="1500" dirty="0"/>
           </a:p>
         </p:txBody>
       </p:sp>
@@ -2406,8 +3011,8 @@
         </p:nvSpPr>
         <p:spPr>
           <a:xfrm>
-            <a:off x="594360" y="384048"/>
-            <a:ext cx="7955280" cy="777240"/>
+            <a:off x="640080" y="438912"/>
+            <a:ext cx="7863840" cy="731520"/>
           </a:xfrm>
           <a:prstGeom prst="rect">
             <a:avLst/>
@@ -2423,7 +3028,7 @@
               <a:buNone/>
             </a:pPr>
             <a:r>
-              <a:rPr lang="en-US" sz="2600" b="1" dirty="0">
+              <a:rPr lang="en-US" sz="2700" b="1" dirty="0">
                 <a:solidFill>
                   <a:srgbClr val="1F3864"/>
                 </a:solidFill>
@@ -2431,9 +3036,9 @@
                 <a:ea typeface="Cambria" pitchFamily="34" charset="-122"/>
                 <a:cs typeface="Cambria" pitchFamily="34" charset="-120"/>
               </a:rPr>
-              <a:t>Financial incentives retain only while they last</a:t>
-            </a:r>
-            <a:endParaRPr lang="en-US" sz="2600" dirty="0"/>
+              <a:t>What each motive teaches re-entry policy</a:t>
+            </a:r>
+            <a:endParaRPr lang="en-US" sz="2700" dirty="0"/>
           </a:p>
         </p:txBody>
       </p:sp>
@@ -2445,8 +3050,8 @@
         </p:nvSpPr>
         <p:spPr>
           <a:xfrm>
-            <a:off x="594360" y="1325880"/>
-            <a:ext cx="7955280" cy="2880360"/>
+            <a:off x="640080" y="1600200"/>
+            <a:ext cx="7863840" cy="3108960"/>
           </a:xfrm>
           <a:prstGeom prst="rect">
             <a:avLst/>
@@ -2458,18 +3063,16 @@
           <a:bodyPr wrap="square" lIns="0" tIns="0" rIns="0" bIns="0" rtlCol="0" anchor="t"/>
           <a:lstStyle/>
           <a:p>
-            <a:pPr algn="l" marL="152400" indent="-152400">
+            <a:pPr algn="l" marL="228600" indent="-228600">
               <a:lnSpc>
-                <a:spcPts val="1900"/>
+                <a:spcPts val="2100"/>
               </a:lnSpc>
-              <a:spcAft>
-                <a:spcPts val="1200"/>
-              </a:spcAft>
               <a:buSzPct val="100000"/>
-              <a:buChar char="•"/>
+              <a:buFont typeface="+mj-lt"/>
+              <a:buAutoNum type="arabicPeriod" startAt="1"/>
             </a:pPr>
             <a:r>
-              <a:rPr lang="en-US" sz="1400" dirty="0">
+              <a:rPr lang="en-US" sz="1500" b="1" dirty="0">
                 <a:solidFill>
                   <a:srgbClr val="1A1A1A"/>
                 </a:solidFill>
@@ -2477,23 +3080,21 @@
                 <a:ea typeface="Calibri" pitchFamily="34" charset="-122"/>
                 <a:cs typeface="Calibri" pitchFamily="34" charset="-120"/>
               </a:rPr>
-              <a:t>Actual primary teacher salaries average 83% of the earnings of tertiary educated workers across the OECD; only four systems pay at or above parity (OECD, 2025d).</a:t>
-            </a:r>
-            <a:endParaRPr lang="en-US" sz="1400" dirty="0"/>
-          </a:p>
-          <a:p>
-            <a:pPr algn="l" marL="152400" indent="-152400">
+              <a:t>Professional factors. </a:t>
+            </a:r>
+            <a:pPr algn="l" marL="228600" indent="-228600">
               <a:lnSpc>
-                <a:spcPts val="1900"/>
+                <a:spcPts val="2100"/>
               </a:lnSpc>
               <a:spcAft>
-                <a:spcPts val="1200"/>
+                <a:spcPts val="2200"/>
               </a:spcAft>
               <a:buSzPct val="100000"/>
-              <a:buChar char="•"/>
+              <a:buFont typeface="+mj-lt"/>
+              <a:buAutoNum type="arabicPeriod" startAt="1"/>
             </a:pPr>
             <a:r>
-              <a:rPr lang="en-US" sz="1400" dirty="0">
+              <a:rPr lang="en-US" sz="1500" dirty="0">
                 <a:solidFill>
                   <a:srgbClr val="1A1A1A"/>
                 </a:solidFill>
@@ -2501,23 +3102,21 @@
                 <a:ea typeface="Calibri" pitchFamily="34" charset="-122"/>
                 <a:cs typeface="Calibri" pitchFamily="34" charset="-120"/>
               </a:rPr>
-              <a:t>Targeted payments cut departures by 9% to 23% in Norway, England and North Carolina (Falch, 2011; Sims and Benhenda, 2022; Clotfelter et al., 2008).</a:t>
-            </a:r>
-            <a:endParaRPr lang="en-US" sz="1400" dirty="0"/>
-          </a:p>
-          <a:p>
-            <a:pPr algn="l" marL="152400" indent="-152400">
+              <a:t>Recognise previous service, create roles that use returners' experience, give them voice in decisions about their own work.</a:t>
+            </a:r>
+            <a:endParaRPr lang="en-US" sz="1500" dirty="0"/>
+          </a:p>
+          <a:p>
+            <a:pPr algn="l" marL="228600" indent="-228600">
               <a:lnSpc>
-                <a:spcPts val="1900"/>
+                <a:spcPts val="2100"/>
               </a:lnSpc>
-              <a:spcAft>
-                <a:spcPts val="1200"/>
-              </a:spcAft>
               <a:buSzPct val="100000"/>
-              <a:buChar char="•"/>
+              <a:buFont typeface="+mj-lt"/>
+              <a:buAutoNum type="arabicPeriod" startAt="1"/>
             </a:pPr>
             <a:r>
-              <a:rPr lang="en-US" sz="1400" dirty="0">
+              <a:rPr lang="en-US" sz="1500" b="1" dirty="0">
                 <a:solidFill>
                   <a:srgbClr val="1A1A1A"/>
                 </a:solidFill>
@@ -2525,23 +3124,21 @@
                 <a:ea typeface="Calibri" pitchFamily="34" charset="-122"/>
                 <a:cs typeface="Calibri" pitchFamily="34" charset="-120"/>
               </a:rPr>
-              <a:t>The retention effect lasts only as long as the payment itself (See et al., 2020).</a:t>
-            </a:r>
-            <a:endParaRPr lang="en-US" sz="1400" dirty="0"/>
-          </a:p>
-          <a:p>
-            <a:pPr algn="l" marL="152400" indent="-152400">
+              <a:t>Working conditions. </a:t>
+            </a:r>
+            <a:pPr algn="l" marL="228600" indent="-228600">
               <a:lnSpc>
-                <a:spcPts val="1900"/>
+                <a:spcPts val="2100"/>
               </a:lnSpc>
               <a:spcAft>
-                <a:spcPts val="1200"/>
+                <a:spcPts val="2200"/>
               </a:spcAft>
               <a:buSzPct val="100000"/>
-              <a:buChar char="•"/>
+              <a:buFont typeface="+mj-lt"/>
+              <a:buAutoNum type="arabicPeriod" startAt="1"/>
             </a:pPr>
             <a:r>
-              <a:rPr lang="en-US" sz="1400" dirty="0">
+              <a:rPr lang="en-US" sz="1500" dirty="0">
                 <a:solidFill>
                   <a:srgbClr val="1A1A1A"/>
                 </a:solidFill>
@@ -2549,68 +3146,53 @@
                 <a:ea typeface="Calibri" pitchFamily="34" charset="-122"/>
                 <a:cs typeface="Calibri" pitchFamily="34" charset="-120"/>
               </a:rPr>
-              <a:t>Defined benefit pensions concentrate retirement around the full pension age; actuarially neutral schemes spread it (Costrell and Podgursky, 2009; OECD, 2025e).</a:t>
-            </a:r>
-            <a:endParaRPr lang="en-US" sz="1400" dirty="0"/>
-          </a:p>
-        </p:txBody>
-      </p:sp>
-      <p:sp>
-        <p:nvSpPr>
-          <p:cNvPr id="4" name="Text 2"/>
-          <p:cNvSpPr txBox="1"/>
-          <p:nvPr/>
-        </p:nvSpPr>
-        <p:spPr>
-          <a:xfrm>
-            <a:off x="594360" y="4315968"/>
-            <a:ext cx="7955280" cy="566928"/>
-          </a:xfrm>
-          <a:prstGeom prst="rect">
-            <a:avLst/>
-          </a:prstGeom>
-          <a:noFill/>
-          <a:ln/>
-        </p:spPr>
-        <p:txBody>
-          <a:bodyPr wrap="square" lIns="0" tIns="0" rIns="0" bIns="0" rtlCol="0" anchor="t"/>
-          <a:lstStyle/>
-          <a:p>
-            <a:pPr algn="l" indent="0" marL="0">
+              <a:t>Attend to the discipline climate of the receiving school and the teaching load offered; shortages concentrate where the climate is worst.</a:t>
+            </a:r>
+            <a:endParaRPr lang="en-US" sz="1500" dirty="0"/>
+          </a:p>
+          <a:p>
+            <a:pPr algn="l" marL="228600" indent="-228600">
               <a:lnSpc>
-                <a:spcPts val="1700"/>
+                <a:spcPts val="2100"/>
               </a:lnSpc>
-              <a:buNone/>
+              <a:buSzPct val="100000"/>
+              <a:buFont typeface="+mj-lt"/>
+              <a:buAutoNum type="arabicPeriod" startAt="1"/>
             </a:pPr>
             <a:r>
-              <a:rPr lang="en-US" sz="1350" b="1" i="1" dirty="0">
+              <a:rPr lang="en-US" sz="1500" b="1" dirty="0">
                 <a:solidFill>
-                  <a:srgbClr val="1F3864"/>
+                  <a:srgbClr val="1A1A1A"/>
                 </a:solidFill>
                 <a:latin typeface="Calibri" pitchFamily="34" charset="0"/>
                 <a:ea typeface="Calibri" pitchFamily="34" charset="-122"/>
                 <a:cs typeface="Calibri" pitchFamily="34" charset="-120"/>
               </a:rPr>
-              <a:t>Policy implication. </a:t>
-            </a:r>
-            <a:pPr algn="l" indent="0" marL="0">
+              <a:t>Organisational factors. </a:t>
+            </a:r>
+            <a:pPr algn="l" marL="228600" indent="-228600">
               <a:lnSpc>
-                <a:spcPts val="1700"/>
+                <a:spcPts val="2100"/>
               </a:lnSpc>
-              <a:buNone/>
+              <a:spcAft>
+                <a:spcPts val="2200"/>
+              </a:spcAft>
+              <a:buSzPct val="100000"/>
+              <a:buFont typeface="+mj-lt"/>
+              <a:buAutoNum type="arabicPeriod" startAt="1"/>
             </a:pPr>
             <a:r>
-              <a:rPr lang="en-US" sz="1350" i="1" dirty="0">
+              <a:rPr lang="en-US" sz="1500" dirty="0">
                 <a:solidFill>
-                  <a:srgbClr val="1F3864"/>
+                  <a:srgbClr val="1A1A1A"/>
                 </a:solidFill>
                 <a:latin typeface="Calibri" pitchFamily="34" charset="0"/>
                 <a:ea typeface="Calibri" pitchFamily="34" charset="-122"/>
                 <a:cs typeface="Calibri" pitchFamily="34" charset="-120"/>
               </a:rPr>
-              <a:t>pay can reopen the door but does not sustain retention on its own; treat it as a bridge, not a fix.</a:t>
-            </a:r>
-            <a:endParaRPr lang="en-US" sz="1350" dirty="0"/>
+              <a:t>Placement is decisive: weak leadership reproduces the first exit. Retired teachers can return as dedicated mentors.</a:t>
+            </a:r>
+            <a:endParaRPr lang="en-US" sz="1500" dirty="0"/>
           </a:p>
         </p:txBody>
       </p:sp>
@@ -2654,8 +3236,8 @@
         </p:nvSpPr>
         <p:spPr>
           <a:xfrm>
-            <a:off x="594360" y="384048"/>
-            <a:ext cx="7955280" cy="777240"/>
+            <a:off x="640080" y="438912"/>
+            <a:ext cx="7863840" cy="731520"/>
           </a:xfrm>
           <a:prstGeom prst="rect">
             <a:avLst/>
@@ -2671,7 +3253,7 @@
               <a:buNone/>
             </a:pPr>
             <a:r>
-              <a:rPr lang="en-US" sz="2600" b="1" dirty="0">
+              <a:rPr lang="en-US" sz="2700" b="1" dirty="0">
                 <a:solidFill>
                   <a:srgbClr val="1F3864"/>
                 </a:solidFill>
@@ -2679,9 +3261,9 @@
                 <a:ea typeface="Cambria" pitchFamily="34" charset="-122"/>
                 <a:cs typeface="Cambria" pitchFamily="34" charset="-120"/>
               </a:rPr>
-              <a:t>Personal and life-course factors follow their own logic</a:t>
-            </a:r>
-            <a:endParaRPr lang="en-US" sz="2600" dirty="0"/>
+              <a:t>What each motive teaches re-entry policy</a:t>
+            </a:r>
+            <a:endParaRPr lang="en-US" sz="2700" dirty="0"/>
           </a:p>
         </p:txBody>
       </p:sp>
@@ -2693,8 +3275,8 @@
         </p:nvSpPr>
         <p:spPr>
           <a:xfrm>
-            <a:off x="594360" y="1325880"/>
-            <a:ext cx="7955280" cy="2880360"/>
+            <a:off x="640080" y="1600200"/>
+            <a:ext cx="7863840" cy="3108960"/>
           </a:xfrm>
           <a:prstGeom prst="rect">
             <a:avLst/>
@@ -2706,18 +3288,16 @@
           <a:bodyPr wrap="square" lIns="0" tIns="0" rIns="0" bIns="0" rtlCol="0" anchor="t"/>
           <a:lstStyle/>
           <a:p>
-            <a:pPr algn="l" marL="152400" indent="-152400">
+            <a:pPr algn="l" marL="228600" indent="-228600">
               <a:lnSpc>
-                <a:spcPts val="1900"/>
+                <a:spcPts val="2100"/>
               </a:lnSpc>
-              <a:spcAft>
-                <a:spcPts val="1200"/>
-              </a:spcAft>
               <a:buSzPct val="100000"/>
-              <a:buChar char="•"/>
+              <a:buFont typeface="+mj-lt"/>
+              <a:buAutoNum type="arabicPeriod" startAt="4"/>
             </a:pPr>
             <a:r>
-              <a:rPr lang="en-US" sz="1400" dirty="0">
+              <a:rPr lang="en-US" sz="1500" b="1" dirty="0">
                 <a:solidFill>
                   <a:srgbClr val="1A1A1A"/>
                 </a:solidFill>
@@ -2725,23 +3305,21 @@
                 <a:ea typeface="Calibri" pitchFamily="34" charset="-122"/>
                 <a:cs typeface="Calibri" pitchFamily="34" charset="-120"/>
               </a:rPr>
-              <a:t>The leaving rate is U shaped over the career: high among novices and near retirement, stable in between (Nguyen et al., 2020; Guarino, Santibañez and Daley, 2006).</a:t>
-            </a:r>
-            <a:endParaRPr lang="en-US" sz="1400" dirty="0"/>
-          </a:p>
-          <a:p>
-            <a:pPr algn="l" marL="152400" indent="-152400">
+              <a:t>Accountability and regulation. </a:t>
+            </a:r>
+            <a:pPr algn="l" marL="228600" indent="-228600">
               <a:lnSpc>
-                <a:spcPts val="1900"/>
+                <a:spcPts val="2100"/>
               </a:lnSpc>
               <a:spcAft>
-                <a:spcPts val="1200"/>
+                <a:spcPts val="2200"/>
               </a:spcAft>
               <a:buSzPct val="100000"/>
-              <a:buChar char="•"/>
+              <a:buFont typeface="+mj-lt"/>
+              <a:buAutoNum type="arabicPeriod" startAt="4"/>
             </a:pPr>
             <a:r>
-              <a:rPr lang="en-US" sz="1400" dirty="0">
+              <a:rPr lang="en-US" sz="1500" dirty="0">
                 <a:solidFill>
                   <a:srgbClr val="1A1A1A"/>
                 </a:solidFill>
@@ -2749,23 +3327,21 @@
                 <a:ea typeface="Calibri" pitchFamily="34" charset="-122"/>
                 <a:cs typeface="Calibri" pitchFamily="34" charset="-120"/>
               </a:rPr>
-              <a:t>In England, 17% to 20% of teachers returning from maternity leave exit within a year, double the rate of comparable teachers (Department for Education, 2023).</a:t>
-            </a:r>
-            <a:endParaRPr lang="en-US" sz="1400" dirty="0"/>
-          </a:p>
-          <a:p>
-            <a:pPr algn="l" marL="152400" indent="-152400">
+              <a:t>The cost of recertification deserves attention; keep such burdens as low as regulatory purposes allow.</a:t>
+            </a:r>
+            <a:endParaRPr lang="en-US" sz="1500" dirty="0"/>
+          </a:p>
+          <a:p>
+            <a:pPr algn="l" marL="228600" indent="-228600">
               <a:lnSpc>
-                <a:spcPts val="1900"/>
+                <a:spcPts val="2100"/>
               </a:lnSpc>
-              <a:spcAft>
-                <a:spcPts val="1200"/>
-              </a:spcAft>
               <a:buSzPct val="100000"/>
-              <a:buChar char="•"/>
+              <a:buFont typeface="+mj-lt"/>
+              <a:buAutoNum type="arabicPeriod" startAt="4"/>
             </a:pPr>
             <a:r>
-              <a:rPr lang="en-US" sz="1400" dirty="0">
+              <a:rPr lang="en-US" sz="1500" b="1" dirty="0">
                 <a:solidFill>
                   <a:srgbClr val="1A1A1A"/>
                 </a:solidFill>
@@ -2773,23 +3349,21 @@
                 <a:ea typeface="Calibri" pitchFamily="34" charset="-122"/>
                 <a:cs typeface="Calibri" pitchFamily="34" charset="-120"/>
               </a:rPr>
-              <a:t>Personal reasons, covering health, childcare and the care of relatives, are the main non-retirement motive among voluntary leavers in the United States and Sweden (NCES, 2024; Statistics Sweden, 2023).</a:t>
-            </a:r>
-            <a:endParaRPr lang="en-US" sz="1400" dirty="0"/>
-          </a:p>
-          <a:p>
-            <a:pPr algn="l" marL="152400" indent="-152400">
+              <a:t>Financial factors. </a:t>
+            </a:r>
+            <a:pPr algn="l" marL="228600" indent="-228600">
               <a:lnSpc>
-                <a:spcPts val="1900"/>
+                <a:spcPts val="2100"/>
               </a:lnSpc>
               <a:spcAft>
-                <a:spcPts val="1200"/>
+                <a:spcPts val="2200"/>
               </a:spcAft>
               <a:buSzPct val="100000"/>
-              <a:buChar char="•"/>
+              <a:buFont typeface="+mj-lt"/>
+              <a:buAutoNum type="arabicPeriod" startAt="4"/>
             </a:pPr>
             <a:r>
-              <a:rPr lang="en-US" sz="1400" dirty="0">
+              <a:rPr lang="en-US" sz="1500" dirty="0">
                 <a:solidFill>
                   <a:srgbClr val="1A1A1A"/>
                 </a:solidFill>
@@ -2797,68 +3371,53 @@
                 <a:ea typeface="Calibri" pitchFamily="34" charset="-122"/>
                 <a:cs typeface="Calibri" pitchFamily="34" charset="-120"/>
               </a:rPr>
-              <a:t>Only about one in five United States leavers between 2000 and 2019 returned; re-entry is no longer predicted by gender or child rearing (Moyer, 2022; Grissom and Reininger, 2012).</a:t>
-            </a:r>
-            <a:endParaRPr lang="en-US" sz="1400" dirty="0"/>
-          </a:p>
-        </p:txBody>
-      </p:sp>
-      <p:sp>
-        <p:nvSpPr>
-          <p:cNvPr id="4" name="Text 2"/>
-          <p:cNvSpPr txBox="1"/>
-          <p:nvPr/>
-        </p:nvSpPr>
-        <p:spPr>
-          <a:xfrm>
-            <a:off x="594360" y="4315968"/>
-            <a:ext cx="7955280" cy="566928"/>
-          </a:xfrm>
-          <a:prstGeom prst="rect">
-            <a:avLst/>
-          </a:prstGeom>
-          <a:noFill/>
-          <a:ln/>
-        </p:spPr>
-        <p:txBody>
-          <a:bodyPr wrap="square" lIns="0" tIns="0" rIns="0" bIns="0" rtlCol="0" anchor="t"/>
-          <a:lstStyle/>
-          <a:p>
-            <a:pPr algn="l" indent="0" marL="0">
+              <a:t>Targeted pay retains, but only as long as the payment lasts; the paper draws no further policy lesson in this area.</a:t>
+            </a:r>
+            <a:endParaRPr lang="en-US" sz="1500" dirty="0"/>
+          </a:p>
+          <a:p>
+            <a:pPr algn="l" marL="228600" indent="-228600">
               <a:lnSpc>
-                <a:spcPts val="1700"/>
+                <a:spcPts val="2100"/>
               </a:lnSpc>
-              <a:buNone/>
+              <a:buSzPct val="100000"/>
+              <a:buFont typeface="+mj-lt"/>
+              <a:buAutoNum type="arabicPeriod" startAt="4"/>
             </a:pPr>
             <a:r>
-              <a:rPr lang="en-US" sz="1350" b="1" i="1" dirty="0">
+              <a:rPr lang="en-US" sz="1500" b="1" dirty="0">
                 <a:solidFill>
-                  <a:srgbClr val="1F3864"/>
+                  <a:srgbClr val="1A1A1A"/>
                 </a:solidFill>
                 <a:latin typeface="Calibri" pitchFamily="34" charset="0"/>
                 <a:ea typeface="Calibri" pitchFamily="34" charset="-122"/>
                 <a:cs typeface="Calibri" pitchFamily="34" charset="-120"/>
               </a:rPr>
-              <a:t>Policy implication. </a:t>
-            </a:r>
-            <a:pPr algn="l" indent="0" marL="0">
+              <a:t>Personal and life-course factors. </a:t>
+            </a:r>
+            <a:pPr algn="l" marL="228600" indent="-228600">
               <a:lnSpc>
-                <a:spcPts val="1700"/>
+                <a:spcPts val="2100"/>
               </a:lnSpc>
-              <a:buNone/>
+              <a:spcAft>
+                <a:spcPts val="2200"/>
+              </a:spcAft>
+              <a:buSzPct val="100000"/>
+              <a:buFont typeface="+mj-lt"/>
+              <a:buAutoNum type="arabicPeriod" startAt="4"/>
             </a:pPr>
             <a:r>
-              <a:rPr lang="en-US" sz="1350" i="1" dirty="0">
+              <a:rPr lang="en-US" sz="1500" dirty="0">
                 <a:solidFill>
-                  <a:srgbClr val="1F3864"/>
+                  <a:srgbClr val="1A1A1A"/>
                 </a:solidFill>
                 <a:latin typeface="Calibri" pitchFamily="34" charset="0"/>
                 <a:ea typeface="Calibri" pitchFamily="34" charset="-122"/>
                 <a:cs typeface="Calibri" pitchFamily="34" charset="-120"/>
               </a:rPr>
-              <a:t>these exits are not about the school; flexibility through part-time work, phased returns and predictable timetables is the lever.</a:t>
-            </a:r>
-            <a:endParaRPr lang="en-US" sz="1350" dirty="0"/>
+              <a:t>These exits are not about the school and can ease with time; focus on flexibility through part-time and phased returns, predictable timetables and care-compatible placements.</a:t>
+            </a:r>
+            <a:endParaRPr lang="en-US" sz="1500" dirty="0"/>
           </a:p>
         </p:txBody>
       </p:sp>
@@ -2902,8 +3461,8 @@
         </p:nvSpPr>
         <p:spPr>
           <a:xfrm>
-            <a:off x="594360" y="384048"/>
-            <a:ext cx="7955280" cy="777240"/>
+            <a:off x="640080" y="438912"/>
+            <a:ext cx="7863840" cy="731520"/>
           </a:xfrm>
           <a:prstGeom prst="rect">
             <a:avLst/>
@@ -2919,7 +3478,7 @@
               <a:buNone/>
             </a:pPr>
             <a:r>
-              <a:rPr lang="en-US" sz="2600" b="1" dirty="0">
+              <a:rPr lang="en-US" sz="2700" b="1" dirty="0">
                 <a:solidFill>
                   <a:srgbClr val="1F3864"/>
                 </a:solidFill>
@@ -2927,9 +3486,9 @@
                 <a:ea typeface="Cambria" pitchFamily="34" charset="-122"/>
                 <a:cs typeface="Cambria" pitchFamily="34" charset="-120"/>
               </a:rPr>
-              <a:t>Implications for re-entry policy</a:t>
-            </a:r>
-            <a:endParaRPr lang="en-US" sz="2600" dirty="0"/>
+              <a:t>The message for policy</a:t>
+            </a:r>
+            <a:endParaRPr lang="en-US" sz="2700" dirty="0"/>
           </a:p>
         </p:txBody>
       </p:sp>
@@ -2941,8 +3500,8 @@
         </p:nvSpPr>
         <p:spPr>
           <a:xfrm>
-            <a:off x="594360" y="1325880"/>
-            <a:ext cx="7955280" cy="2788920"/>
+            <a:off x="640080" y="1600200"/>
+            <a:ext cx="7863840" cy="3108960"/>
           </a:xfrm>
           <a:prstGeom prst="rect">
             <a:avLst/>
@@ -2954,18 +3513,19 @@
           <a:bodyPr wrap="square" lIns="0" tIns="0" rIns="0" bIns="0" rtlCol="0" anchor="t"/>
           <a:lstStyle/>
           <a:p>
-            <a:pPr algn="l" marL="152400" indent="-152400">
+            <a:pPr algn="l" marL="228600" indent="-228600">
               <a:lnSpc>
-                <a:spcPts val="1800"/>
+                <a:spcPts val="2100"/>
               </a:lnSpc>
               <a:spcAft>
-                <a:spcPts val="1000"/>
+                <a:spcPts val="2400"/>
               </a:spcAft>
               <a:buSzPct val="100000"/>
-              <a:buChar char="•"/>
+              <a:buFont typeface="+mj-lt"/>
+              <a:buAutoNum type="arabicPeriod" startAt="1"/>
             </a:pPr>
             <a:r>
-              <a:rPr lang="en-US" sz="1350" dirty="0">
+              <a:rPr lang="en-US" sz="1500" dirty="0">
                 <a:solidFill>
                   <a:srgbClr val="1A1A1A"/>
                 </a:solidFill>
@@ -2973,23 +3533,24 @@
                 <a:ea typeface="Calibri" pitchFamily="34" charset="-122"/>
                 <a:cs typeface="Calibri" pitchFamily="34" charset="-120"/>
               </a:rPr>
-              <a:t>Bringing a teacher back without changing the conditions behind the first exit risks repeating it; re-entry policy concerns the quality of the match, not only the cost of returning.</a:t>
-            </a:r>
-            <a:endParaRPr lang="en-US" sz="1350" dirty="0"/>
-          </a:p>
-          <a:p>
-            <a:pPr algn="l" marL="152400" indent="-152400">
+              <a:t>Bringing a teacher back without changing the conditions behind the first exit risks reproducing the same decision.</a:t>
+            </a:r>
+            <a:endParaRPr lang="en-US" sz="1500" dirty="0"/>
+          </a:p>
+          <a:p>
+            <a:pPr algn="l" marL="228600" indent="-228600">
               <a:lnSpc>
-                <a:spcPts val="1800"/>
+                <a:spcPts val="2100"/>
               </a:lnSpc>
               <a:spcAft>
-                <a:spcPts val="1000"/>
+                <a:spcPts val="2400"/>
               </a:spcAft>
               <a:buSzPct val="100000"/>
-              <a:buChar char="•"/>
+              <a:buFont typeface="+mj-lt"/>
+              <a:buAutoNum type="arabicPeriod" startAt="1"/>
             </a:pPr>
             <a:r>
-              <a:rPr lang="en-US" sz="1350" dirty="0">
+              <a:rPr lang="en-US" sz="1500" dirty="0">
                 <a:solidFill>
                   <a:srgbClr val="1A1A1A"/>
                 </a:solidFill>
@@ -2997,23 +3558,24 @@
                 <a:ea typeface="Calibri" pitchFamily="34" charset="-122"/>
                 <a:cs typeface="Calibri" pitchFamily="34" charset="-120"/>
               </a:rPr>
-              <a:t>Placement matters: the leadership, collegial support and classroom climate of the receiving school are decisive.</a:t>
-            </a:r>
-            <a:endParaRPr lang="en-US" sz="1350" dirty="0"/>
-          </a:p>
-          <a:p>
-            <a:pPr algn="l" marL="152400" indent="-152400">
+              <a:t>Re-entry policy is an opportunity to improve the match between teachers and schools: workload, leadership, collegial environment, classroom conditions and flexibility.</a:t>
+            </a:r>
+            <a:endParaRPr lang="en-US" sz="1500" dirty="0"/>
+          </a:p>
+          <a:p>
+            <a:pPr algn="l" marL="228600" indent="-228600">
               <a:lnSpc>
-                <a:spcPts val="1800"/>
+                <a:spcPts val="2100"/>
               </a:lnSpc>
               <a:spcAft>
-                <a:spcPts val="1000"/>
+                <a:spcPts val="2400"/>
               </a:spcAft>
               <a:buSzPct val="100000"/>
-              <a:buChar char="•"/>
+              <a:buFont typeface="+mj-lt"/>
+              <a:buAutoNum type="arabicPeriod" startAt="1"/>
             </a:pPr>
             <a:r>
-              <a:rPr lang="en-US" sz="1350" dirty="0">
+              <a:rPr lang="en-US" sz="1500" i="1" dirty="0">
                 <a:solidFill>
                   <a:srgbClr val="1A1A1A"/>
                 </a:solidFill>
@@ -3021,99 +3583,9 @@
                 <a:ea typeface="Calibri" pitchFamily="34" charset="-122"/>
                 <a:cs typeface="Calibri" pitchFamily="34" charset="-120"/>
               </a:rPr>
-              <a:t>Offer flexibility to family driven leavers: part-time positions, phased returns and predictable schedules.</a:t>
-            </a:r>
-            <a:endParaRPr lang="en-US" sz="1350" dirty="0"/>
-          </a:p>
-          <a:p>
-            <a:pPr algn="l" marL="152400" indent="-152400">
-              <a:lnSpc>
-                <a:spcPts val="1800"/>
-              </a:lnSpc>
-              <a:spcAft>
-                <a:spcPts val="1000"/>
-              </a:spcAft>
-              <a:buSzPct val="100000"/>
-              <a:buChar char="•"/>
-            </a:pPr>
-            <a:r>
-              <a:rPr lang="en-US" sz="1350" dirty="0">
-                <a:solidFill>
-                  <a:srgbClr val="1A1A1A"/>
-                </a:solidFill>
-                <a:latin typeface="Calibri" pitchFamily="34" charset="0"/>
-                <a:ea typeface="Calibri" pitchFamily="34" charset="-122"/>
-                <a:cs typeface="Calibri" pitchFamily="34" charset="-120"/>
-              </a:rPr>
-              <a:t>Keep recertification burdens as low as regulatory purposes allow.</a:t>
-            </a:r>
-            <a:endParaRPr lang="en-US" sz="1350" dirty="0"/>
-          </a:p>
-          <a:p>
-            <a:pPr algn="l" marL="152400" indent="-152400">
-              <a:lnSpc>
-                <a:spcPts val="1800"/>
-              </a:lnSpc>
-              <a:spcAft>
-                <a:spcPts val="1000"/>
-              </a:spcAft>
-              <a:buSzPct val="100000"/>
-              <a:buChar char="•"/>
-            </a:pPr>
-            <a:r>
-              <a:rPr lang="en-US" sz="1350" dirty="0">
-                <a:solidFill>
-                  <a:srgbClr val="1A1A1A"/>
-                </a:solidFill>
-                <a:latin typeface="Calibri" pitchFamily="34" charset="0"/>
-                <a:ea typeface="Calibri" pitchFamily="34" charset="-122"/>
-                <a:cs typeface="Calibri" pitchFamily="34" charset="-120"/>
-              </a:rPr>
-              <a:t>Use retired teachers as mentors and tutors; both roles have experimental support (DeCesare et al., 2017; Nickow, Oreopoulos and Quan, 2024; Papay et al., 2020).</a:t>
-            </a:r>
-            <a:endParaRPr lang="en-US" sz="1350" dirty="0"/>
-          </a:p>
-        </p:txBody>
-      </p:sp>
-      <p:sp>
-        <p:nvSpPr>
-          <p:cNvPr id="4" name="Text 2"/>
-          <p:cNvSpPr txBox="1"/>
-          <p:nvPr/>
-        </p:nvSpPr>
-        <p:spPr>
-          <a:xfrm>
-            <a:off x="594360" y="4279392"/>
-            <a:ext cx="7955280" cy="566928"/>
-          </a:xfrm>
-          <a:prstGeom prst="rect">
-            <a:avLst/>
-          </a:prstGeom>
-          <a:noFill/>
-          <a:ln/>
-        </p:spPr>
-        <p:txBody>
-          <a:bodyPr wrap="square" lIns="0" tIns="0" rIns="0" bIns="0" rtlCol="0" anchor="ctr"/>
-          <a:lstStyle/>
-          <a:p>
-            <a:pPr indent="0" marL="0">
-              <a:lnSpc>
-                <a:spcPts val="1700"/>
-              </a:lnSpc>
-              <a:buNone/>
-            </a:pPr>
-            <a:r>
-              <a:rPr lang="en-US" sz="1350" i="1" dirty="0">
-                <a:solidFill>
-                  <a:srgbClr val="1F3864"/>
-                </a:solidFill>
-                <a:latin typeface="Calibri" pitchFamily="34" charset="0"/>
-                <a:ea typeface="Calibri" pitchFamily="34" charset="-122"/>
-                <a:cs typeface="Calibri" pitchFamily="34" charset="-120"/>
-              </a:rPr>
               <a:t>The relevant question is not how to make former teachers return, but whether the system can offer them a different set of conditions once they do.</a:t>
             </a:r>
-            <a:endParaRPr lang="en-US" sz="1350" dirty="0"/>
+            <a:endParaRPr lang="en-US" sz="1500" dirty="0"/>
           </a:p>
         </p:txBody>
       </p:sp>

</xml_diff>

<commit_message>
Make deck action-oriented and lighter: one-line what-to-do per motive
Six-slide version: navy cover and closing, three short numbered messages
per content slide, the six-motive table, and a single aligned slide with
one imperative action per motive.

Co-Authored-By: Claude Fable 5 <noreply@anthropic.com>
Claude-Session: https://claude.ai/code/session_018LPM7UjuT86VaNxhN3T3Ra
</commit_message>
<xml_diff>
--- a/Former_Teachers_key_messages.pptx
+++ b/Former_Teachers_key_messages.pptx
@@ -11,10 +11,9 @@
     <p:sldId id="259" r:id="rId5"/>
     <p:sldId id="260" r:id="rId6"/>
     <p:sldId id="261" r:id="rId7"/>
-    <p:sldId id="262" r:id="rId8"/>
   </p:sldIdLst>
   <p:notesMasterIdLst>
-    <p:notesMasterId r:id="rId9"/>
+    <p:notesMasterId r:id="rId8"/>
   </p:notesMasterIdLst>
   <p:sldSz cx="9144000" cy="5143500"/>
   <p:notesSz cx="5143500" cy="9144000"/>
@@ -972,94 +971,6 @@
             <a:fld id="{F7021451-1387-4CA6-816F-3879F97B5CBC}" type="slidenum">
               <a:rPr lang="en-US"/>
               <a:t>6</a:t>
-            </a:fld>
-            <a:endParaRPr lang="en-US"/>
-          </a:p>
-        </p:txBody>
-      </p:sp>
-    </p:spTree>
-    <p:extLst>
-      <p:ext uri="{BB962C8B-B14F-4D97-AF65-F5344CB8AC3E}">
-        <p14:creationId xmlns:p14="http://schemas.microsoft.com/office/powerpoint/2010/main" val="1024086991"/>
-      </p:ext>
-    </p:extLst>
-  </p:cSld>
-  <p:clrMapOvr>
-    <a:masterClrMapping/>
-  </p:clrMapOvr>
-</p:notes>
-</file>
-
-<file path=ppt/notesSlides/notesSlide7.xml><?xml version="1.0" encoding="utf-8"?>
-<p:notes xmlns:a="http://schemas.openxmlformats.org/drawingml/2006/main" xmlns:r="http://schemas.openxmlformats.org/officeDocument/2006/relationships" xmlns:p="http://schemas.openxmlformats.org/presentationml/2006/main">
-  <p:cSld>
-    <p:spTree>
-      <p:nvGrpSpPr>
-        <p:cNvPr id="1" name=""/>
-        <p:cNvGrpSpPr/>
-        <p:nvPr/>
-      </p:nvGrpSpPr>
-      <p:grpSpPr>
-        <a:xfrm>
-          <a:off x="0" y="0"/>
-          <a:ext cx="0" cy="0"/>
-          <a:chOff x="0" y="0"/>
-          <a:chExt cx="0" cy="0"/>
-        </a:xfrm>
-      </p:grpSpPr>
-      <p:sp>
-        <p:nvSpPr>
-          <p:cNvPr id="2" name="Slide Image Placeholder 1"/>
-          <p:cNvSpPr>
-            <a:spLocks noGrp="1" noRot="1" noChangeAspect="1"/>
-          </p:cNvSpPr>
-          <p:nvPr>
-            <p:ph type="sldImg"/>
-          </p:nvPr>
-        </p:nvSpPr>
-        <p:spPr/>
-      </p:sp>
-      <p:sp>
-        <p:nvSpPr>
-          <p:cNvPr id="3" name="Notes Placeholder 2"/>
-          <p:cNvSpPr>
-            <a:spLocks noGrp="1"/>
-          </p:cNvSpPr>
-          <p:nvPr>
-            <p:ph type="body" idx="1"/>
-          </p:nvPr>
-        </p:nvSpPr>
-        <p:spPr/>
-        <p:txBody>
-          <a:bodyPr/>
-          <a:lstStyle/>
-          <a:p>
-            <a:r>
-              <a:rPr lang="en-US" dirty="0"/>
-              <a:t/>
-            </a:r>
-            <a:endParaRPr lang="en-US" dirty="0"/>
-          </a:p>
-        </p:txBody>
-      </p:sp>
-      <p:sp>
-        <p:nvSpPr>
-          <p:cNvPr id="4" name="Slide Number Placeholder 3"/>
-          <p:cNvSpPr>
-            <a:spLocks noGrp="1"/>
-          </p:cNvSpPr>
-          <p:nvPr>
-            <p:ph type="sldNum" sz="quarter" idx="10"/>
-          </p:nvPr>
-        </p:nvSpPr>
-        <p:spPr/>
-        <p:txBody>
-          <a:bodyPr/>
-          <a:lstStyle/>
-          <a:p>
-            <a:fld id="{F7021451-1387-4CA6-816F-3879F97B5CBC}" type="slidenum">
-              <a:rPr lang="en-US"/>
-              <a:t>7</a:t>
             </a:fld>
             <a:endParaRPr lang="en-US"/>
           </a:p>
@@ -1417,7 +1328,7 @@
         </p:nvSpPr>
         <p:spPr>
           <a:xfrm>
-            <a:off x="822960" y="1234440"/>
+            <a:off x="822960" y="1280160"/>
             <a:ext cx="7498080" cy="1691640"/>
           </a:xfrm>
           <a:prstGeom prst="rect">
@@ -1459,8 +1370,8 @@
         </p:nvSpPr>
         <p:spPr>
           <a:xfrm>
-            <a:off x="822960" y="3063240"/>
-            <a:ext cx="7498080" cy="411480"/>
+            <a:off x="822960" y="3108960"/>
+            <a:ext cx="7498080" cy="365760"/>
           </a:xfrm>
           <a:prstGeom prst="rect">
             <a:avLst/>
@@ -1476,7 +1387,7 @@
               <a:buNone/>
             </a:pPr>
             <a:r>
-              <a:rPr lang="en-US" sz="1600" dirty="0">
+              <a:rPr lang="en-US" sz="1500" dirty="0">
                 <a:solidFill>
                   <a:srgbClr val="C7D3E2"/>
                 </a:solidFill>
@@ -1486,7 +1397,7 @@
               </a:rPr>
               <a:t>Teacher leaving: what the research says and what it means for policy</a:t>
             </a:r>
-            <a:endParaRPr lang="en-US" sz="1600" dirty="0"/>
+            <a:endParaRPr lang="en-US" sz="1500" dirty="0"/>
           </a:p>
         </p:txBody>
       </p:sp>
@@ -1498,7 +1409,7 @@
         </p:nvSpPr>
         <p:spPr>
           <a:xfrm>
-            <a:off x="822960" y="4206240"/>
+            <a:off x="822960" y="4251960"/>
             <a:ext cx="7498080" cy="274320"/>
           </a:xfrm>
           <a:prstGeom prst="rect">
@@ -1515,7 +1426,7 @@
               <a:buNone/>
             </a:pPr>
             <a:r>
-              <a:rPr lang="en-US" sz="1100" dirty="0">
+              <a:rPr lang="en-US" sz="1050" dirty="0">
                 <a:solidFill>
                   <a:srgbClr val="8FA2B8"/>
                 </a:solidFill>
@@ -1525,7 +1436,7 @@
               </a:rPr>
               <a:t>Section 2. Working draft. Directorate for Education and Skills.</a:t>
             </a:r>
-            <a:endParaRPr lang="en-US" sz="1100" dirty="0"/>
+            <a:endParaRPr lang="en-US" sz="1050" dirty="0"/>
           </a:p>
         </p:txBody>
       </p:sp>
@@ -1569,8 +1480,8 @@
         </p:nvSpPr>
         <p:spPr>
           <a:xfrm>
-            <a:off x="640080" y="438912"/>
-            <a:ext cx="7863840" cy="731520"/>
+            <a:off x="640080" y="475488"/>
+            <a:ext cx="7863840" cy="548640"/>
           </a:xfrm>
           <a:prstGeom prst="rect">
             <a:avLst/>
@@ -1582,7 +1493,7 @@
           <a:bodyPr wrap="square" lIns="0" tIns="0" rIns="0" bIns="0" rtlCol="0" anchor="t"/>
           <a:lstStyle/>
           <a:p>
-            <a:pPr algn="l" indent="0" marL="0">
+            <a:pPr indent="0" marL="0">
               <a:buNone/>
             </a:pPr>
             <a:r>
@@ -1608,8 +1519,8 @@
         </p:nvSpPr>
         <p:spPr>
           <a:xfrm>
-            <a:off x="640080" y="1600200"/>
-            <a:ext cx="7863840" cy="3108960"/>
+            <a:off x="640080" y="1828800"/>
+            <a:ext cx="7863840" cy="2926080"/>
           </a:xfrm>
           <a:prstGeom prst="rect">
             <a:avLst/>
@@ -1621,79 +1532,79 @@
           <a:bodyPr wrap="square" lIns="0" tIns="0" rIns="0" bIns="0" rtlCol="0" anchor="t"/>
           <a:lstStyle/>
           <a:p>
-            <a:pPr algn="l" marL="228600" indent="-228600">
+            <a:pPr marL="254000" indent="-254000">
               <a:lnSpc>
-                <a:spcPts val="2100"/>
+                <a:spcPts val="2200"/>
               </a:lnSpc>
               <a:spcAft>
-                <a:spcPts val="2400"/>
+                <a:spcPts val="2600"/>
               </a:spcAft>
               <a:buSzPct val="100000"/>
               <a:buFont typeface="+mj-lt"/>
               <a:buAutoNum type="arabicPeriod" startAt="1"/>
             </a:pPr>
             <a:r>
-              <a:rPr lang="en-US" sz="1500" dirty="0">
+              <a:rPr lang="en-US" sz="1600" dirty="0">
                 <a:solidFill>
-                  <a:srgbClr val="1A1A1A"/>
+                  <a:srgbClr val="222222"/>
                 </a:solidFill>
                 <a:latin typeface="Calibri" pitchFamily="34" charset="0"/>
                 <a:ea typeface="Calibri" pitchFamily="34" charset="-122"/>
                 <a:cs typeface="Calibri" pitchFamily="34" charset="-120"/>
               </a:rPr>
-              <a:t>Re-attracting former teachers relieves shortages in the short run, above all in the disadvantaged and rural schools where they concentrate. It does not close the gap on its own.</a:t>
-            </a:r>
-            <a:endParaRPr lang="en-US" sz="1500" dirty="0"/>
-          </a:p>
-          <a:p>
-            <a:pPr algn="l" marL="228600" indent="-228600">
+              <a:t>It relieves shortages in the short run, where they bite: disadvantaged and rural schools.</a:t>
+            </a:r>
+            <a:endParaRPr lang="en-US" sz="1600" dirty="0"/>
+          </a:p>
+          <a:p>
+            <a:pPr marL="254000" indent="-254000">
               <a:lnSpc>
-                <a:spcPts val="2100"/>
+                <a:spcPts val="2200"/>
               </a:lnSpc>
               <a:spcAft>
-                <a:spcPts val="2400"/>
+                <a:spcPts val="2600"/>
               </a:spcAft>
               <a:buSzPct val="100000"/>
               <a:buFont typeface="+mj-lt"/>
               <a:buAutoNum type="arabicPeriod" startAt="1"/>
             </a:pPr>
             <a:r>
-              <a:rPr lang="en-US" sz="1500" dirty="0">
+              <a:rPr lang="en-US" sz="1600" dirty="0">
                 <a:solidFill>
-                  <a:srgbClr val="1A1A1A"/>
+                  <a:srgbClr val="222222"/>
                 </a:solidFill>
                 <a:latin typeface="Calibri" pitchFamily="34" charset="0"/>
                 <a:ea typeface="Calibri" pitchFamily="34" charset="-122"/>
                 <a:cs typeface="Calibri" pitchFamily="34" charset="-120"/>
               </a:rPr>
-              <a:t>The margin is bounded: where leaving is almost all retirement (France, Greece, Ireland, Israel), the recoverable pool is small.</a:t>
-            </a:r>
-            <a:endParaRPr lang="en-US" sz="1500" dirty="0"/>
-          </a:p>
-          <a:p>
-            <a:pPr algn="l" marL="228600" indent="-228600">
+              <a:t>It cannot close the gap alone; where leaving is mostly retirement, the margin is small.</a:t>
+            </a:r>
+            <a:endParaRPr lang="en-US" sz="1600" dirty="0"/>
+          </a:p>
+          <a:p>
+            <a:pPr marL="254000" indent="-254000">
               <a:lnSpc>
-                <a:spcPts val="2100"/>
+                <a:spcPts val="2200"/>
               </a:lnSpc>
               <a:spcAft>
-                <a:spcPts val="2400"/>
+                <a:spcPts val="2600"/>
               </a:spcAft>
               <a:buSzPct val="100000"/>
               <a:buFont typeface="+mj-lt"/>
               <a:buAutoNum type="arabicPeriod" startAt="1"/>
             </a:pPr>
             <a:r>
-              <a:rPr lang="en-US" sz="1500" dirty="0">
+              <a:rPr lang="en-US" sz="1600" dirty="0">
                 <a:solidFill>
-                  <a:srgbClr val="1A1A1A"/>
+                  <a:srgbClr val="222222"/>
                 </a:solidFill>
                 <a:latin typeface="Calibri" pitchFamily="34" charset="0"/>
                 <a:ea typeface="Calibri" pitchFamily="34" charset="-122"/>
                 <a:cs typeface="Calibri" pitchFamily="34" charset="-120"/>
               </a:rPr>
-              <a:t>Returners and retirees add value of their own: experience spillovers to colleagues, mentorship for beginners, tutoring roles with experimental backing.</a:t>
-            </a:r>
-            <a:endParaRPr lang="en-US" sz="1500" dirty="0"/>
+              <a:t>Returners bring experience spillovers, mentorship and tutoring capacity.</a:t>
+            </a:r>
+            <a:endParaRPr lang="en-US" sz="1600" dirty="0"/>
           </a:p>
         </p:txBody>
       </p:sp>
@@ -1737,8 +1648,8 @@
         </p:nvSpPr>
         <p:spPr>
           <a:xfrm>
-            <a:off x="640080" y="438912"/>
-            <a:ext cx="7863840" cy="731520"/>
+            <a:off x="640080" y="475488"/>
+            <a:ext cx="7863840" cy="548640"/>
           </a:xfrm>
           <a:prstGeom prst="rect">
             <a:avLst/>
@@ -1750,7 +1661,7 @@
           <a:bodyPr wrap="square" lIns="0" tIns="0" rIns="0" bIns="0" rtlCol="0" anchor="t"/>
           <a:lstStyle/>
           <a:p>
-            <a:pPr algn="l" indent="0" marL="0">
+            <a:pPr indent="0" marL="0">
               <a:buNone/>
             </a:pPr>
             <a:r>
@@ -1783,7 +1694,7 @@
           </p:nvPr>
         </p:nvGraphicFramePr>
         <p:xfrm>
-          <a:off x="640080" y="1298448"/>
+          <a:off x="640080" y="1371600"/>
           <a:ext cx="7863840" cy="914400"/>
         </p:xfrm>
         <a:graphic>
@@ -1821,10 +1732,10 @@
                       </a:endParaRPr>
                     </a:p>
                   </a:txBody>
-                  <a:tcPr marL="91440" marR="91440" marT="54864" marB="54864" anchor="ctr">
+                  <a:tcPr marL="109728" marR="109728" marT="73152" marB="73152" anchor="ctr">
                     <a:lnL w="9525" cap="flat" cmpd="sng" algn="ctr">
                       <a:solidFill>
-                        <a:srgbClr val="C9D4E0"/>
+                        <a:srgbClr val="CBD6E2"/>
                       </a:solidFill>
                       <a:prstDash val="solid"/>
                       <a:round/>
@@ -1833,7 +1744,7 @@
                     </a:lnL>
                     <a:lnR w="9525" cap="flat" cmpd="sng" algn="ctr">
                       <a:solidFill>
-                        <a:srgbClr val="C9D4E0"/>
+                        <a:srgbClr val="CBD6E2"/>
                       </a:solidFill>
                       <a:prstDash val="solid"/>
                       <a:round/>
@@ -1842,7 +1753,7 @@
                     </a:lnR>
                     <a:lnT w="9525" cap="flat" cmpd="sng" algn="ctr">
                       <a:solidFill>
-                        <a:srgbClr val="C9D4E0"/>
+                        <a:srgbClr val="CBD6E2"/>
                       </a:solidFill>
                       <a:prstDash val="solid"/>
                       <a:round/>
@@ -1851,7 +1762,7 @@
                     </a:lnT>
                     <a:lnB w="9525" cap="flat" cmpd="sng" algn="ctr">
                       <a:solidFill>
-                        <a:srgbClr val="C9D4E0"/>
+                        <a:srgbClr val="CBD6E2"/>
                       </a:solidFill>
                       <a:prstDash val="solid"/>
                       <a:round/>
@@ -1889,10 +1800,10 @@
                       </a:endParaRPr>
                     </a:p>
                   </a:txBody>
-                  <a:tcPr marL="91440" marR="91440" marT="54864" marB="54864" anchor="ctr">
+                  <a:tcPr marL="109728" marR="109728" marT="73152" marB="73152" anchor="ctr">
                     <a:lnL w="9525" cap="flat" cmpd="sng" algn="ctr">
                       <a:solidFill>
-                        <a:srgbClr val="C9D4E0"/>
+                        <a:srgbClr val="CBD6E2"/>
                       </a:solidFill>
                       <a:prstDash val="solid"/>
                       <a:round/>
@@ -1901,7 +1812,7 @@
                     </a:lnL>
                     <a:lnR w="9525" cap="flat" cmpd="sng" algn="ctr">
                       <a:solidFill>
-                        <a:srgbClr val="C9D4E0"/>
+                        <a:srgbClr val="CBD6E2"/>
                       </a:solidFill>
                       <a:prstDash val="solid"/>
                       <a:round/>
@@ -1910,7 +1821,7 @@
                     </a:lnR>
                     <a:lnT w="9525" cap="flat" cmpd="sng" algn="ctr">
                       <a:solidFill>
-                        <a:srgbClr val="C9D4E0"/>
+                        <a:srgbClr val="CBD6E2"/>
                       </a:solidFill>
                       <a:prstDash val="solid"/>
                       <a:round/>
@@ -1919,7 +1830,7 @@
                     </a:lnT>
                     <a:lnB w="9525" cap="flat" cmpd="sng" algn="ctr">
                       <a:solidFill>
-                        <a:srgbClr val="C9D4E0"/>
+                        <a:srgbClr val="CBD6E2"/>
                       </a:solidFill>
                       <a:prstDash val="solid"/>
                       <a:round/>
@@ -1959,10 +1870,10 @@
                       </a:endParaRPr>
                     </a:p>
                   </a:txBody>
-                  <a:tcPr marL="91440" marR="91440" marT="54864" marB="54864" anchor="ctr">
+                  <a:tcPr marL="109728" marR="109728" marT="73152" marB="73152" anchor="ctr">
                     <a:lnL w="9525" cap="flat" cmpd="sng" algn="ctr">
                       <a:solidFill>
-                        <a:srgbClr val="C9D4E0"/>
+                        <a:srgbClr val="CBD6E2"/>
                       </a:solidFill>
                       <a:prstDash val="solid"/>
                       <a:round/>
@@ -1971,7 +1882,7 @@
                     </a:lnL>
                     <a:lnR w="9525" cap="flat" cmpd="sng" algn="ctr">
                       <a:solidFill>
-                        <a:srgbClr val="C9D4E0"/>
+                        <a:srgbClr val="CBD6E2"/>
                       </a:solidFill>
                       <a:prstDash val="solid"/>
                       <a:round/>
@@ -1980,7 +1891,7 @@
                     </a:lnR>
                     <a:lnT w="9525" cap="flat" cmpd="sng" algn="ctr">
                       <a:solidFill>
-                        <a:srgbClr val="C9D4E0"/>
+                        <a:srgbClr val="CBD6E2"/>
                       </a:solidFill>
                       <a:prstDash val="solid"/>
                       <a:round/>
@@ -1989,7 +1900,7 @@
                     </a:lnT>
                     <a:lnB w="9525" cap="flat" cmpd="sng" algn="ctr">
                       <a:solidFill>
-                        <a:srgbClr val="C9D4E0"/>
+                        <a:srgbClr val="CBD6E2"/>
                       </a:solidFill>
                       <a:prstDash val="solid"/>
                       <a:round/>
@@ -2012,13 +1923,13 @@
                       <a:r>
                         <a:rPr lang="en-US" sz="1100" dirty="0">
                           <a:solidFill>
-                            <a:srgbClr val="1A1A1A"/>
+                            <a:srgbClr val="222222"/>
                           </a:solidFill>
                           <a:latin typeface="Calibri" pitchFamily="34" charset="0"/>
                           <a:ea typeface="Calibri" pitchFamily="34" charset="-122"/>
                           <a:cs typeface="Calibri" pitchFamily="34" charset="-120"/>
                         </a:rPr>
-                        <a:t>Loss of professional purpose; limited autonomy over the work; professional standing; exposure to parental complaint and legal risk</a:t>
+                        <a:t>Loss of professional purpose; limited autonomy; professional standing; exposure to parental complaint and legal risk</a:t>
                       </a:r>
                       <a:endParaRPr lang="en-US" sz="1100" dirty="0">
                         <a:latin typeface="Calibri" charset="0"/>
@@ -2027,10 +1938,10 @@
                       </a:endParaRPr>
                     </a:p>
                   </a:txBody>
-                  <a:tcPr marL="91440" marR="91440" marT="54864" marB="54864" anchor="ctr">
+                  <a:tcPr marL="109728" marR="109728" marT="73152" marB="73152" anchor="ctr">
                     <a:lnL w="9525" cap="flat" cmpd="sng" algn="ctr">
                       <a:solidFill>
-                        <a:srgbClr val="C9D4E0"/>
+                        <a:srgbClr val="CBD6E2"/>
                       </a:solidFill>
                       <a:prstDash val="solid"/>
                       <a:round/>
@@ -2039,7 +1950,7 @@
                     </a:lnL>
                     <a:lnR w="9525" cap="flat" cmpd="sng" algn="ctr">
                       <a:solidFill>
-                        <a:srgbClr val="C9D4E0"/>
+                        <a:srgbClr val="CBD6E2"/>
                       </a:solidFill>
                       <a:prstDash val="solid"/>
                       <a:round/>
@@ -2048,7 +1959,7 @@
                     </a:lnR>
                     <a:lnT w="9525" cap="flat" cmpd="sng" algn="ctr">
                       <a:solidFill>
-                        <a:srgbClr val="C9D4E0"/>
+                        <a:srgbClr val="CBD6E2"/>
                       </a:solidFill>
                       <a:prstDash val="solid"/>
                       <a:round/>
@@ -2057,7 +1968,7 @@
                     </a:lnT>
                     <a:lnB w="9525" cap="flat" cmpd="sng" algn="ctr">
                       <a:solidFill>
-                        <a:srgbClr val="C9D4E0"/>
+                        <a:srgbClr val="CBD6E2"/>
                       </a:solidFill>
                       <a:prstDash val="solid"/>
                       <a:round/>
@@ -2097,10 +2008,10 @@
                       </a:endParaRPr>
                     </a:p>
                   </a:txBody>
-                  <a:tcPr marL="91440" marR="91440" marT="54864" marB="54864" anchor="ctr">
+                  <a:tcPr marL="109728" marR="109728" marT="73152" marB="73152" anchor="ctr">
                     <a:lnL w="9525" cap="flat" cmpd="sng" algn="ctr">
                       <a:solidFill>
-                        <a:srgbClr val="C9D4E0"/>
+                        <a:srgbClr val="CBD6E2"/>
                       </a:solidFill>
                       <a:prstDash val="solid"/>
                       <a:round/>
@@ -2109,7 +2020,7 @@
                     </a:lnL>
                     <a:lnR w="9525" cap="flat" cmpd="sng" algn="ctr">
                       <a:solidFill>
-                        <a:srgbClr val="C9D4E0"/>
+                        <a:srgbClr val="CBD6E2"/>
                       </a:solidFill>
                       <a:prstDash val="solid"/>
                       <a:round/>
@@ -2118,7 +2029,7 @@
                     </a:lnR>
                     <a:lnT w="9525" cap="flat" cmpd="sng" algn="ctr">
                       <a:solidFill>
-                        <a:srgbClr val="C9D4E0"/>
+                        <a:srgbClr val="CBD6E2"/>
                       </a:solidFill>
                       <a:prstDash val="solid"/>
                       <a:round/>
@@ -2127,7 +2038,7 @@
                     </a:lnT>
                     <a:lnB w="9525" cap="flat" cmpd="sng" algn="ctr">
                       <a:solidFill>
-                        <a:srgbClr val="C9D4E0"/>
+                        <a:srgbClr val="CBD6E2"/>
                       </a:solidFill>
                       <a:prstDash val="solid"/>
                       <a:round/>
@@ -2150,13 +2061,13 @@
                       <a:r>
                         <a:rPr lang="en-US" sz="1100" dirty="0">
                           <a:solidFill>
-                            <a:srgbClr val="1A1A1A"/>
+                            <a:srgbClr val="222222"/>
                           </a:solidFill>
                           <a:latin typeface="Calibri" pitchFamily="34" charset="0"/>
                           <a:ea typeface="Calibri" pitchFamily="34" charset="-122"/>
                           <a:cs typeface="Calibri" pitchFamily="34" charset="-120"/>
                         </a:rPr>
-                        <a:t>Hours and total workload; pupil behaviour and classroom discipline; administrative demands; limited access to reduced hours; burnout</a:t>
+                        <a:t>Hours and workload; pupil behaviour and discipline; administrative demands; limited access to reduced hours; burnout</a:t>
                       </a:r>
                       <a:endParaRPr lang="en-US" sz="1100" dirty="0">
                         <a:latin typeface="Calibri" charset="0"/>
@@ -2165,10 +2076,10 @@
                       </a:endParaRPr>
                     </a:p>
                   </a:txBody>
-                  <a:tcPr marL="91440" marR="91440" marT="54864" marB="54864" anchor="ctr">
+                  <a:tcPr marL="109728" marR="109728" marT="73152" marB="73152" anchor="ctr">
                     <a:lnL w="9525" cap="flat" cmpd="sng" algn="ctr">
                       <a:solidFill>
-                        <a:srgbClr val="C9D4E0"/>
+                        <a:srgbClr val="CBD6E2"/>
                       </a:solidFill>
                       <a:prstDash val="solid"/>
                       <a:round/>
@@ -2177,7 +2088,7 @@
                     </a:lnL>
                     <a:lnR w="9525" cap="flat" cmpd="sng" algn="ctr">
                       <a:solidFill>
-                        <a:srgbClr val="C9D4E0"/>
+                        <a:srgbClr val="CBD6E2"/>
                       </a:solidFill>
                       <a:prstDash val="solid"/>
                       <a:round/>
@@ -2186,7 +2097,7 @@
                     </a:lnR>
                     <a:lnT w="9525" cap="flat" cmpd="sng" algn="ctr">
                       <a:solidFill>
-                        <a:srgbClr val="C9D4E0"/>
+                        <a:srgbClr val="CBD6E2"/>
                       </a:solidFill>
                       <a:prstDash val="solid"/>
                       <a:round/>
@@ -2195,7 +2106,7 @@
                     </a:lnT>
                     <a:lnB w="9525" cap="flat" cmpd="sng" algn="ctr">
                       <a:solidFill>
-                        <a:srgbClr val="C9D4E0"/>
+                        <a:srgbClr val="CBD6E2"/>
                       </a:solidFill>
                       <a:prstDash val="solid"/>
                       <a:round/>
@@ -2235,10 +2146,10 @@
                       </a:endParaRPr>
                     </a:p>
                   </a:txBody>
-                  <a:tcPr marL="91440" marR="91440" marT="54864" marB="54864" anchor="ctr">
+                  <a:tcPr marL="109728" marR="109728" marT="73152" marB="73152" anchor="ctr">
                     <a:lnL w="9525" cap="flat" cmpd="sng" algn="ctr">
                       <a:solidFill>
-                        <a:srgbClr val="C9D4E0"/>
+                        <a:srgbClr val="CBD6E2"/>
                       </a:solidFill>
                       <a:prstDash val="solid"/>
                       <a:round/>
@@ -2247,7 +2158,7 @@
                     </a:lnL>
                     <a:lnR w="9525" cap="flat" cmpd="sng" algn="ctr">
                       <a:solidFill>
-                        <a:srgbClr val="C9D4E0"/>
+                        <a:srgbClr val="CBD6E2"/>
                       </a:solidFill>
                       <a:prstDash val="solid"/>
                       <a:round/>
@@ -2256,7 +2167,7 @@
                     </a:lnR>
                     <a:lnT w="9525" cap="flat" cmpd="sng" algn="ctr">
                       <a:solidFill>
-                        <a:srgbClr val="C9D4E0"/>
+                        <a:srgbClr val="CBD6E2"/>
                       </a:solidFill>
                       <a:prstDash val="solid"/>
                       <a:round/>
@@ -2265,7 +2176,7 @@
                     </a:lnT>
                     <a:lnB w="9525" cap="flat" cmpd="sng" algn="ctr">
                       <a:solidFill>
-                        <a:srgbClr val="C9D4E0"/>
+                        <a:srgbClr val="CBD6E2"/>
                       </a:solidFill>
                       <a:prstDash val="solid"/>
                       <a:round/>
@@ -2288,7 +2199,7 @@
                       <a:r>
                         <a:rPr lang="en-US" sz="1100" dirty="0">
                           <a:solidFill>
-                            <a:srgbClr val="1A1A1A"/>
+                            <a:srgbClr val="222222"/>
                           </a:solidFill>
                           <a:latin typeface="Calibri" pitchFamily="34" charset="0"/>
                           <a:ea typeface="Calibri" pitchFamily="34" charset="-122"/>
@@ -2303,10 +2214,10 @@
                       </a:endParaRPr>
                     </a:p>
                   </a:txBody>
-                  <a:tcPr marL="91440" marR="91440" marT="54864" marB="54864" anchor="ctr">
+                  <a:tcPr marL="109728" marR="109728" marT="73152" marB="73152" anchor="ctr">
                     <a:lnL w="9525" cap="flat" cmpd="sng" algn="ctr">
                       <a:solidFill>
-                        <a:srgbClr val="C9D4E0"/>
+                        <a:srgbClr val="CBD6E2"/>
                       </a:solidFill>
                       <a:prstDash val="solid"/>
                       <a:round/>
@@ -2315,7 +2226,7 @@
                     </a:lnL>
                     <a:lnR w="9525" cap="flat" cmpd="sng" algn="ctr">
                       <a:solidFill>
-                        <a:srgbClr val="C9D4E0"/>
+                        <a:srgbClr val="CBD6E2"/>
                       </a:solidFill>
                       <a:prstDash val="solid"/>
                       <a:round/>
@@ -2324,7 +2235,7 @@
                     </a:lnR>
                     <a:lnT w="9525" cap="flat" cmpd="sng" algn="ctr">
                       <a:solidFill>
-                        <a:srgbClr val="C9D4E0"/>
+                        <a:srgbClr val="CBD6E2"/>
                       </a:solidFill>
                       <a:prstDash val="solid"/>
                       <a:round/>
@@ -2333,7 +2244,7 @@
                     </a:lnT>
                     <a:lnB w="9525" cap="flat" cmpd="sng" algn="ctr">
                       <a:solidFill>
-                        <a:srgbClr val="C9D4E0"/>
+                        <a:srgbClr val="CBD6E2"/>
                       </a:solidFill>
                       <a:prstDash val="solid"/>
                       <a:round/>
@@ -2373,10 +2284,10 @@
                       </a:endParaRPr>
                     </a:p>
                   </a:txBody>
-                  <a:tcPr marL="91440" marR="91440" marT="54864" marB="54864" anchor="ctr">
+                  <a:tcPr marL="109728" marR="109728" marT="73152" marB="73152" anchor="ctr">
                     <a:lnL w="9525" cap="flat" cmpd="sng" algn="ctr">
                       <a:solidFill>
-                        <a:srgbClr val="C9D4E0"/>
+                        <a:srgbClr val="CBD6E2"/>
                       </a:solidFill>
                       <a:prstDash val="solid"/>
                       <a:round/>
@@ -2385,7 +2296,7 @@
                     </a:lnL>
                     <a:lnR w="9525" cap="flat" cmpd="sng" algn="ctr">
                       <a:solidFill>
-                        <a:srgbClr val="C9D4E0"/>
+                        <a:srgbClr val="CBD6E2"/>
                       </a:solidFill>
                       <a:prstDash val="solid"/>
                       <a:round/>
@@ -2394,7 +2305,7 @@
                     </a:lnR>
                     <a:lnT w="9525" cap="flat" cmpd="sng" algn="ctr">
                       <a:solidFill>
-                        <a:srgbClr val="C9D4E0"/>
+                        <a:srgbClr val="CBD6E2"/>
                       </a:solidFill>
                       <a:prstDash val="solid"/>
                       <a:round/>
@@ -2403,7 +2314,7 @@
                     </a:lnT>
                     <a:lnB w="9525" cap="flat" cmpd="sng" algn="ctr">
                       <a:solidFill>
-                        <a:srgbClr val="C9D4E0"/>
+                        <a:srgbClr val="CBD6E2"/>
                       </a:solidFill>
                       <a:prstDash val="solid"/>
                       <a:round/>
@@ -2426,7 +2337,7 @@
                       <a:r>
                         <a:rPr lang="en-US" sz="1100" dirty="0">
                           <a:solidFill>
-                            <a:srgbClr val="1A1A1A"/>
+                            <a:srgbClr val="222222"/>
                           </a:solidFill>
                           <a:latin typeface="Calibri" pitchFamily="34" charset="0"/>
                           <a:ea typeface="Calibri" pitchFamily="34" charset="-122"/>
@@ -2441,10 +2352,10 @@
                       </a:endParaRPr>
                     </a:p>
                   </a:txBody>
-                  <a:tcPr marL="91440" marR="91440" marT="54864" marB="54864" anchor="ctr">
+                  <a:tcPr marL="109728" marR="109728" marT="73152" marB="73152" anchor="ctr">
                     <a:lnL w="9525" cap="flat" cmpd="sng" algn="ctr">
                       <a:solidFill>
-                        <a:srgbClr val="C9D4E0"/>
+                        <a:srgbClr val="CBD6E2"/>
                       </a:solidFill>
                       <a:prstDash val="solid"/>
                       <a:round/>
@@ -2453,7 +2364,7 @@
                     </a:lnL>
                     <a:lnR w="9525" cap="flat" cmpd="sng" algn="ctr">
                       <a:solidFill>
-                        <a:srgbClr val="C9D4E0"/>
+                        <a:srgbClr val="CBD6E2"/>
                       </a:solidFill>
                       <a:prstDash val="solid"/>
                       <a:round/>
@@ -2462,7 +2373,7 @@
                     </a:lnR>
                     <a:lnT w="9525" cap="flat" cmpd="sng" algn="ctr">
                       <a:solidFill>
-                        <a:srgbClr val="C9D4E0"/>
+                        <a:srgbClr val="CBD6E2"/>
                       </a:solidFill>
                       <a:prstDash val="solid"/>
                       <a:round/>
@@ -2471,7 +2382,7 @@
                     </a:lnT>
                     <a:lnB w="9525" cap="flat" cmpd="sng" algn="ctr">
                       <a:solidFill>
-                        <a:srgbClr val="C9D4E0"/>
+                        <a:srgbClr val="CBD6E2"/>
                       </a:solidFill>
                       <a:prstDash val="solid"/>
                       <a:round/>
@@ -2511,10 +2422,10 @@
                       </a:endParaRPr>
                     </a:p>
                   </a:txBody>
-                  <a:tcPr marL="91440" marR="91440" marT="54864" marB="54864" anchor="ctr">
+                  <a:tcPr marL="109728" marR="109728" marT="73152" marB="73152" anchor="ctr">
                     <a:lnL w="9525" cap="flat" cmpd="sng" algn="ctr">
                       <a:solidFill>
-                        <a:srgbClr val="C9D4E0"/>
+                        <a:srgbClr val="CBD6E2"/>
                       </a:solidFill>
                       <a:prstDash val="solid"/>
                       <a:round/>
@@ -2523,7 +2434,7 @@
                     </a:lnL>
                     <a:lnR w="9525" cap="flat" cmpd="sng" algn="ctr">
                       <a:solidFill>
-                        <a:srgbClr val="C9D4E0"/>
+                        <a:srgbClr val="CBD6E2"/>
                       </a:solidFill>
                       <a:prstDash val="solid"/>
                       <a:round/>
@@ -2532,7 +2443,7 @@
                     </a:lnR>
                     <a:lnT w="9525" cap="flat" cmpd="sng" algn="ctr">
                       <a:solidFill>
-                        <a:srgbClr val="C9D4E0"/>
+                        <a:srgbClr val="CBD6E2"/>
                       </a:solidFill>
                       <a:prstDash val="solid"/>
                       <a:round/>
@@ -2541,7 +2452,7 @@
                     </a:lnT>
                     <a:lnB w="9525" cap="flat" cmpd="sng" algn="ctr">
                       <a:solidFill>
-                        <a:srgbClr val="C9D4E0"/>
+                        <a:srgbClr val="CBD6E2"/>
                       </a:solidFill>
                       <a:prstDash val="solid"/>
                       <a:round/>
@@ -2564,7 +2475,7 @@
                       <a:r>
                         <a:rPr lang="en-US" sz="1100" dirty="0">
                           <a:solidFill>
-                            <a:srgbClr val="1A1A1A"/>
+                            <a:srgbClr val="222222"/>
                           </a:solidFill>
                           <a:latin typeface="Calibri" pitchFamily="34" charset="0"/>
                           <a:ea typeface="Calibri" pitchFamily="34" charset="-122"/>
@@ -2579,10 +2490,10 @@
                       </a:endParaRPr>
                     </a:p>
                   </a:txBody>
-                  <a:tcPr marL="91440" marR="91440" marT="54864" marB="54864" anchor="ctr">
+                  <a:tcPr marL="109728" marR="109728" marT="73152" marB="73152" anchor="ctr">
                     <a:lnL w="9525" cap="flat" cmpd="sng" algn="ctr">
                       <a:solidFill>
-                        <a:srgbClr val="C9D4E0"/>
+                        <a:srgbClr val="CBD6E2"/>
                       </a:solidFill>
                       <a:prstDash val="solid"/>
                       <a:round/>
@@ -2591,7 +2502,7 @@
                     </a:lnL>
                     <a:lnR w="9525" cap="flat" cmpd="sng" algn="ctr">
                       <a:solidFill>
-                        <a:srgbClr val="C9D4E0"/>
+                        <a:srgbClr val="CBD6E2"/>
                       </a:solidFill>
                       <a:prstDash val="solid"/>
                       <a:round/>
@@ -2600,7 +2511,7 @@
                     </a:lnR>
                     <a:lnT w="9525" cap="flat" cmpd="sng" algn="ctr">
                       <a:solidFill>
-                        <a:srgbClr val="C9D4E0"/>
+                        <a:srgbClr val="CBD6E2"/>
                       </a:solidFill>
                       <a:prstDash val="solid"/>
                       <a:round/>
@@ -2609,7 +2520,7 @@
                     </a:lnT>
                     <a:lnB w="9525" cap="flat" cmpd="sng" algn="ctr">
                       <a:solidFill>
-                        <a:srgbClr val="C9D4E0"/>
+                        <a:srgbClr val="CBD6E2"/>
                       </a:solidFill>
                       <a:prstDash val="solid"/>
                       <a:round/>
@@ -2649,10 +2560,10 @@
                       </a:endParaRPr>
                     </a:p>
                   </a:txBody>
-                  <a:tcPr marL="91440" marR="91440" marT="54864" marB="54864" anchor="ctr">
+                  <a:tcPr marL="109728" marR="109728" marT="73152" marB="73152" anchor="ctr">
                     <a:lnL w="9525" cap="flat" cmpd="sng" algn="ctr">
                       <a:solidFill>
-                        <a:srgbClr val="C9D4E0"/>
+                        <a:srgbClr val="CBD6E2"/>
                       </a:solidFill>
                       <a:prstDash val="solid"/>
                       <a:round/>
@@ -2661,7 +2572,7 @@
                     </a:lnL>
                     <a:lnR w="9525" cap="flat" cmpd="sng" algn="ctr">
                       <a:solidFill>
-                        <a:srgbClr val="C9D4E0"/>
+                        <a:srgbClr val="CBD6E2"/>
                       </a:solidFill>
                       <a:prstDash val="solid"/>
                       <a:round/>
@@ -2670,7 +2581,7 @@
                     </a:lnR>
                     <a:lnT w="9525" cap="flat" cmpd="sng" algn="ctr">
                       <a:solidFill>
-                        <a:srgbClr val="C9D4E0"/>
+                        <a:srgbClr val="CBD6E2"/>
                       </a:solidFill>
                       <a:prstDash val="solid"/>
                       <a:round/>
@@ -2679,7 +2590,7 @@
                     </a:lnT>
                     <a:lnB w="9525" cap="flat" cmpd="sng" algn="ctr">
                       <a:solidFill>
-                        <a:srgbClr val="C9D4E0"/>
+                        <a:srgbClr val="CBD6E2"/>
                       </a:solidFill>
                       <a:prstDash val="solid"/>
                       <a:round/>
@@ -2702,13 +2613,13 @@
                       <a:r>
                         <a:rPr lang="en-US" sz="1100" dirty="0">
                           <a:solidFill>
-                            <a:srgbClr val="1A1A1A"/>
+                            <a:srgbClr val="222222"/>
                           </a:solidFill>
                           <a:latin typeface="Calibri" pitchFamily="34" charset="0"/>
                           <a:ea typeface="Calibri" pitchFamily="34" charset="-122"/>
                           <a:cs typeface="Calibri" pitchFamily="34" charset="-120"/>
                         </a:rPr>
-                        <a:t>Family formation and care; childbirth; health and incapacity; relocation and a partner's circumstances; retirement and career stage</a:t>
+                        <a:t>Family formation and care; childbirth; health; relocation and a partner's circumstances; retirement and career stage</a:t>
                       </a:r>
                       <a:endParaRPr lang="en-US" sz="1100" dirty="0">
                         <a:latin typeface="Calibri" charset="0"/>
@@ -2717,10 +2628,10 @@
                       </a:endParaRPr>
                     </a:p>
                   </a:txBody>
-                  <a:tcPr marL="91440" marR="91440" marT="54864" marB="54864" anchor="ctr">
+                  <a:tcPr marL="109728" marR="109728" marT="73152" marB="73152" anchor="ctr">
                     <a:lnL w="9525" cap="flat" cmpd="sng" algn="ctr">
                       <a:solidFill>
-                        <a:srgbClr val="C9D4E0"/>
+                        <a:srgbClr val="CBD6E2"/>
                       </a:solidFill>
                       <a:prstDash val="solid"/>
                       <a:round/>
@@ -2729,7 +2640,7 @@
                     </a:lnL>
                     <a:lnR w="9525" cap="flat" cmpd="sng" algn="ctr">
                       <a:solidFill>
-                        <a:srgbClr val="C9D4E0"/>
+                        <a:srgbClr val="CBD6E2"/>
                       </a:solidFill>
                       <a:prstDash val="solid"/>
                       <a:round/>
@@ -2738,7 +2649,7 @@
                     </a:lnR>
                     <a:lnT w="9525" cap="flat" cmpd="sng" algn="ctr">
                       <a:solidFill>
-                        <a:srgbClr val="C9D4E0"/>
+                        <a:srgbClr val="CBD6E2"/>
                       </a:solidFill>
                       <a:prstDash val="solid"/>
                       <a:round/>
@@ -2747,7 +2658,7 @@
                     </a:lnT>
                     <a:lnB w="9525" cap="flat" cmpd="sng" algn="ctr">
                       <a:solidFill>
-                        <a:srgbClr val="C9D4E0"/>
+                        <a:srgbClr val="CBD6E2"/>
                       </a:solidFill>
                       <a:prstDash val="solid"/>
                       <a:round/>
@@ -2772,7 +2683,7 @@
         </p:nvSpPr>
         <p:spPr>
           <a:xfrm>
-            <a:off x="640080" y="4736592"/>
+            <a:off x="640080" y="4754880"/>
             <a:ext cx="7863840" cy="228600"/>
           </a:xfrm>
           <a:prstGeom prst="rect">
@@ -2843,8 +2754,8 @@
         </p:nvSpPr>
         <p:spPr>
           <a:xfrm>
-            <a:off x="640080" y="438912"/>
-            <a:ext cx="7863840" cy="731520"/>
+            <a:off x="640080" y="475488"/>
+            <a:ext cx="7863840" cy="548640"/>
           </a:xfrm>
           <a:prstGeom prst="rect">
             <a:avLst/>
@@ -2856,7 +2767,7 @@
           <a:bodyPr wrap="square" lIns="0" tIns="0" rIns="0" bIns="0" rtlCol="0" anchor="t"/>
           <a:lstStyle/>
           <a:p>
-            <a:pPr algn="l" indent="0" marL="0">
+            <a:pPr indent="0" marL="0">
               <a:buNone/>
             </a:pPr>
             <a:r>
@@ -2882,8 +2793,8 @@
         </p:nvSpPr>
         <p:spPr>
           <a:xfrm>
-            <a:off x="640080" y="1600200"/>
-            <a:ext cx="7863840" cy="3108960"/>
+            <a:off x="640080" y="1828800"/>
+            <a:ext cx="7863840" cy="2926080"/>
           </a:xfrm>
           <a:prstGeom prst="rect">
             <a:avLst/>
@@ -2895,79 +2806,79 @@
           <a:bodyPr wrap="square" lIns="0" tIns="0" rIns="0" bIns="0" rtlCol="0" anchor="t"/>
           <a:lstStyle/>
           <a:p>
-            <a:pPr algn="l" marL="228600" indent="-228600">
+            <a:pPr marL="254000" indent="-254000">
               <a:lnSpc>
-                <a:spcPts val="2100"/>
+                <a:spcPts val="2200"/>
               </a:lnSpc>
               <a:spcAft>
-                <a:spcPts val="2400"/>
+                <a:spcPts val="2600"/>
               </a:spcAft>
               <a:buSzPct val="100000"/>
               <a:buFont typeface="+mj-lt"/>
               <a:buAutoNum type="arabicPeriod" startAt="1"/>
             </a:pPr>
             <a:r>
-              <a:rPr lang="en-US" sz="1500" dirty="0">
+              <a:rPr lang="en-US" sz="1600" dirty="0">
                 <a:solidFill>
-                  <a:srgbClr val="1A1A1A"/>
+                  <a:srgbClr val="222222"/>
                 </a:solidFill>
                 <a:latin typeface="Calibri" pitchFamily="34" charset="0"/>
                 <a:ea typeface="Calibri" pitchFamily="34" charset="-122"/>
                 <a:cs typeface="Calibri" pitchFamily="34" charset="-120"/>
               </a:rPr>
-              <a:t>Working conditions and the organisational features of the school are the most consistently important determinants of leaving, above financial incentives, accountability and personal characteristics (Nguyen et al., 2020; Gundlach, Slemp and Hattie, 2024).</a:t>
-            </a:r>
-            <a:endParaRPr lang="en-US" sz="1500" dirty="0"/>
-          </a:p>
-          <a:p>
-            <a:pPr algn="l" marL="228600" indent="-228600">
+              <a:t>Working conditions and school organisation weigh most; pay, accountability and personal traits weigh less (Nguyen et al., 2020; Gundlach, Slemp and Hattie, 2024).</a:t>
+            </a:r>
+            <a:endParaRPr lang="en-US" sz="1600" dirty="0"/>
+          </a:p>
+          <a:p>
+            <a:pPr marL="254000" indent="-254000">
               <a:lnSpc>
-                <a:spcPts val="2100"/>
+                <a:spcPts val="2200"/>
               </a:lnSpc>
               <a:spcAft>
-                <a:spcPts val="2400"/>
+                <a:spcPts val="2600"/>
               </a:spcAft>
               <a:buSzPct val="100000"/>
               <a:buFont typeface="+mj-lt"/>
               <a:buAutoNum type="arabicPeriod" startAt="1"/>
             </a:pPr>
             <a:r>
-              <a:rPr lang="en-US" sz="1500" dirty="0">
+              <a:rPr lang="en-US" sz="1600" dirty="0">
                 <a:solidFill>
-                  <a:srgbClr val="1A1A1A"/>
+                  <a:srgbClr val="222222"/>
                 </a:solidFill>
                 <a:latin typeface="Calibri" pitchFamily="34" charset="0"/>
                 <a:ea typeface="Calibri" pitchFamily="34" charset="-122"/>
                 <a:cs typeface="Calibri" pitchFamily="34" charset="-120"/>
               </a:rPr>
-              <a:t>High workload, stress and weak organisational support raise exits substantially; salary and regulation matter, but with smaller effects across determinants.</a:t>
-            </a:r>
-            <a:endParaRPr lang="en-US" sz="1500" dirty="0"/>
-          </a:p>
-          <a:p>
-            <a:pPr algn="l" marL="228600" indent="-228600">
+              <a:t>Workload, stress and weak organisational support are what push teachers out.</a:t>
+            </a:r>
+            <a:endParaRPr lang="en-US" sz="1600" dirty="0"/>
+          </a:p>
+          <a:p>
+            <a:pPr marL="254000" indent="-254000">
               <a:lnSpc>
-                <a:spcPts val="2100"/>
+                <a:spcPts val="2200"/>
               </a:lnSpc>
               <a:spcAft>
-                <a:spcPts val="2400"/>
+                <a:spcPts val="2600"/>
               </a:spcAft>
               <a:buSzPct val="100000"/>
               <a:buFont typeface="+mj-lt"/>
               <a:buAutoNum type="arabicPeriod" startAt="1"/>
             </a:pPr>
             <a:r>
-              <a:rPr lang="en-US" sz="1500" dirty="0">
+              <a:rPr lang="en-US" sz="1600" dirty="0">
                 <a:solidFill>
-                  <a:srgbClr val="1A1A1A"/>
+                  <a:srgbClr val="222222"/>
                 </a:solidFill>
                 <a:latin typeface="Calibri" pitchFamily="34" charset="0"/>
                 <a:ea typeface="Calibri" pitchFamily="34" charset="-122"/>
                 <a:cs typeface="Calibri" pitchFamily="34" charset="-120"/>
               </a:rPr>
-              <a:t>The conditions under which teaching takes place are the main institutional margin through which systems can influence retention.</a:t>
-            </a:r>
-            <a:endParaRPr lang="en-US" sz="1500" dirty="0"/>
+              <a:t>The conditions of teaching are the main margin systems can act on.</a:t>
+            </a:r>
+            <a:endParaRPr lang="en-US" sz="1600" dirty="0"/>
           </a:p>
         </p:txBody>
       </p:sp>
@@ -3011,8 +2922,8 @@
         </p:nvSpPr>
         <p:spPr>
           <a:xfrm>
-            <a:off x="640080" y="438912"/>
-            <a:ext cx="7863840" cy="731520"/>
+            <a:off x="640080" y="475488"/>
+            <a:ext cx="7863840" cy="548640"/>
           </a:xfrm>
           <a:prstGeom prst="rect">
             <a:avLst/>
@@ -3024,7 +2935,7 @@
           <a:bodyPr wrap="square" lIns="0" tIns="0" rIns="0" bIns="0" rtlCol="0" anchor="t"/>
           <a:lstStyle/>
           <a:p>
-            <a:pPr algn="l" indent="0" marL="0">
+            <a:pPr indent="0" marL="0">
               <a:buNone/>
             </a:pPr>
             <a:r>
@@ -3036,7 +2947,7 @@
                 <a:ea typeface="Cambria" pitchFamily="34" charset="-122"/>
                 <a:cs typeface="Cambria" pitchFamily="34" charset="-120"/>
               </a:rPr>
-              <a:t>What each motive teaches re-entry policy</a:t>
+              <a:t>What to do, motive by motive</a:t>
             </a:r>
             <a:endParaRPr lang="en-US" sz="2700" dirty="0"/>
           </a:p>
@@ -3050,8 +2961,8 @@
         </p:nvSpPr>
         <p:spPr>
           <a:xfrm>
-            <a:off x="640080" y="1600200"/>
-            <a:ext cx="7863840" cy="3108960"/>
+            <a:off x="640080" y="1536192"/>
+            <a:ext cx="2514600" cy="457200"/>
           </a:xfrm>
           <a:prstGeom prst="rect">
             <a:avLst/>
@@ -3063,136 +2974,486 @@
           <a:bodyPr wrap="square" lIns="0" tIns="0" rIns="0" bIns="0" rtlCol="0" anchor="t"/>
           <a:lstStyle/>
           <a:p>
-            <a:pPr algn="l" marL="228600" indent="-228600">
+            <a:pPr indent="0" marL="0">
               <a:lnSpc>
-                <a:spcPts val="2100"/>
+                <a:spcPts val="1500"/>
               </a:lnSpc>
-              <a:buSzPct val="100000"/>
-              <a:buFont typeface="+mj-lt"/>
-              <a:buAutoNum type="arabicPeriod" startAt="1"/>
+              <a:buNone/>
             </a:pPr>
             <a:r>
-              <a:rPr lang="en-US" sz="1500" b="1" dirty="0">
+              <a:rPr lang="en-US" sz="1300" b="1" dirty="0">
                 <a:solidFill>
-                  <a:srgbClr val="1A1A1A"/>
+                  <a:srgbClr val="1F3864"/>
                 </a:solidFill>
                 <a:latin typeface="Calibri" pitchFamily="34" charset="0"/>
                 <a:ea typeface="Calibri" pitchFamily="34" charset="-122"/>
                 <a:cs typeface="Calibri" pitchFamily="34" charset="-120"/>
               </a:rPr>
-              <a:t>Professional factors. </a:t>
-            </a:r>
-            <a:pPr algn="l" marL="228600" indent="-228600">
+              <a:t>Professional factors</a:t>
+            </a:r>
+            <a:endParaRPr lang="en-US" sz="1300" dirty="0"/>
+          </a:p>
+        </p:txBody>
+      </p:sp>
+      <p:sp>
+        <p:nvSpPr>
+          <p:cNvPr id="4" name="Text 2"/>
+          <p:cNvSpPr txBox="1"/>
+          <p:nvPr/>
+        </p:nvSpPr>
+        <p:spPr>
+          <a:xfrm>
+            <a:off x="3154680" y="1536192"/>
+            <a:ext cx="5440680" cy="457200"/>
+          </a:xfrm>
+          <a:prstGeom prst="rect">
+            <a:avLst/>
+          </a:prstGeom>
+          <a:noFill/>
+          <a:ln/>
+        </p:spPr>
+        <p:txBody>
+          <a:bodyPr wrap="square" lIns="0" tIns="0" rIns="0" bIns="0" rtlCol="0" anchor="t"/>
+          <a:lstStyle/>
+          <a:p>
+            <a:pPr indent="0" marL="0">
               <a:lnSpc>
-                <a:spcPts val="2100"/>
+                <a:spcPts val="1700"/>
               </a:lnSpc>
-              <a:spcAft>
-                <a:spcPts val="2200"/>
-              </a:spcAft>
-              <a:buSzPct val="100000"/>
-              <a:buFont typeface="+mj-lt"/>
-              <a:buAutoNum type="arabicPeriod" startAt="1"/>
+              <a:buNone/>
             </a:pPr>
             <a:r>
-              <a:rPr lang="en-US" sz="1500" dirty="0">
+              <a:rPr lang="en-US" sz="1350" dirty="0">
                 <a:solidFill>
-                  <a:srgbClr val="1A1A1A"/>
+                  <a:srgbClr val="222222"/>
                 </a:solidFill>
                 <a:latin typeface="Calibri" pitchFamily="34" charset="0"/>
                 <a:ea typeface="Calibri" pitchFamily="34" charset="-122"/>
                 <a:cs typeface="Calibri" pitchFamily="34" charset="-120"/>
               </a:rPr>
-              <a:t>Recognise previous service, create roles that use returners' experience, give them voice in decisions about their own work.</a:t>
-            </a:r>
-            <a:endParaRPr lang="en-US" sz="1500" dirty="0"/>
-          </a:p>
-          <a:p>
-            <a:pPr algn="l" marL="228600" indent="-228600">
+              <a:t>Recognise prior service; give returners roles and voice.</a:t>
+            </a:r>
+            <a:endParaRPr lang="en-US" sz="1350" dirty="0"/>
+          </a:p>
+        </p:txBody>
+      </p:sp>
+      <p:sp>
+        <p:nvSpPr>
+          <p:cNvPr id="5" name="Text 3"/>
+          <p:cNvSpPr txBox="1"/>
+          <p:nvPr/>
+        </p:nvSpPr>
+        <p:spPr>
+          <a:xfrm>
+            <a:off x="640080" y="2048256"/>
+            <a:ext cx="2514600" cy="457200"/>
+          </a:xfrm>
+          <a:prstGeom prst="rect">
+            <a:avLst/>
+          </a:prstGeom>
+          <a:noFill/>
+          <a:ln/>
+        </p:spPr>
+        <p:txBody>
+          <a:bodyPr wrap="square" lIns="0" tIns="0" rIns="0" bIns="0" rtlCol="0" anchor="t"/>
+          <a:lstStyle/>
+          <a:p>
+            <a:pPr indent="0" marL="0">
               <a:lnSpc>
-                <a:spcPts val="2100"/>
+                <a:spcPts val="1500"/>
               </a:lnSpc>
-              <a:buSzPct val="100000"/>
-              <a:buFont typeface="+mj-lt"/>
-              <a:buAutoNum type="arabicPeriod" startAt="1"/>
+              <a:buNone/>
             </a:pPr>
             <a:r>
-              <a:rPr lang="en-US" sz="1500" b="1" dirty="0">
+              <a:rPr lang="en-US" sz="1300" b="1" dirty="0">
                 <a:solidFill>
-                  <a:srgbClr val="1A1A1A"/>
+                  <a:srgbClr val="1F3864"/>
                 </a:solidFill>
                 <a:latin typeface="Calibri" pitchFamily="34" charset="0"/>
                 <a:ea typeface="Calibri" pitchFamily="34" charset="-122"/>
                 <a:cs typeface="Calibri" pitchFamily="34" charset="-120"/>
               </a:rPr>
-              <a:t>Working conditions. </a:t>
-            </a:r>
-            <a:pPr algn="l" marL="228600" indent="-228600">
+              <a:t>Working conditions</a:t>
+            </a:r>
+            <a:endParaRPr lang="en-US" sz="1300" dirty="0"/>
+          </a:p>
+        </p:txBody>
+      </p:sp>
+      <p:sp>
+        <p:nvSpPr>
+          <p:cNvPr id="6" name="Text 4"/>
+          <p:cNvSpPr txBox="1"/>
+          <p:nvPr/>
+        </p:nvSpPr>
+        <p:spPr>
+          <a:xfrm>
+            <a:off x="3154680" y="2048256"/>
+            <a:ext cx="5440680" cy="457200"/>
+          </a:xfrm>
+          <a:prstGeom prst="rect">
+            <a:avLst/>
+          </a:prstGeom>
+          <a:noFill/>
+          <a:ln/>
+        </p:spPr>
+        <p:txBody>
+          <a:bodyPr wrap="square" lIns="0" tIns="0" rIns="0" bIns="0" rtlCol="0" anchor="t"/>
+          <a:lstStyle/>
+          <a:p>
+            <a:pPr indent="0" marL="0">
               <a:lnSpc>
-                <a:spcPts val="2100"/>
+                <a:spcPts val="1700"/>
               </a:lnSpc>
-              <a:spcAft>
-                <a:spcPts val="2200"/>
-              </a:spcAft>
-              <a:buSzPct val="100000"/>
-              <a:buFont typeface="+mj-lt"/>
-              <a:buAutoNum type="arabicPeriod" startAt="1"/>
+              <a:buNone/>
             </a:pPr>
             <a:r>
-              <a:rPr lang="en-US" sz="1500" dirty="0">
+              <a:rPr lang="en-US" sz="1350" dirty="0">
                 <a:solidFill>
-                  <a:srgbClr val="1A1A1A"/>
+                  <a:srgbClr val="222222"/>
                 </a:solidFill>
                 <a:latin typeface="Calibri" pitchFamily="34" charset="0"/>
                 <a:ea typeface="Calibri" pitchFamily="34" charset="-122"/>
                 <a:cs typeface="Calibri" pitchFamily="34" charset="-120"/>
               </a:rPr>
-              <a:t>Attend to the discipline climate of the receiving school and the teaching load offered; shortages concentrate where the climate is worst.</a:t>
-            </a:r>
-            <a:endParaRPr lang="en-US" sz="1500" dirty="0"/>
-          </a:p>
-          <a:p>
-            <a:pPr algn="l" marL="228600" indent="-228600">
+              <a:t>Watch the receiving school: discipline climate, teaching load.</a:t>
+            </a:r>
+            <a:endParaRPr lang="en-US" sz="1350" dirty="0"/>
+          </a:p>
+        </p:txBody>
+      </p:sp>
+      <p:sp>
+        <p:nvSpPr>
+          <p:cNvPr id="7" name="Text 5"/>
+          <p:cNvSpPr txBox="1"/>
+          <p:nvPr/>
+        </p:nvSpPr>
+        <p:spPr>
+          <a:xfrm>
+            <a:off x="640080" y="2560320"/>
+            <a:ext cx="2514600" cy="457200"/>
+          </a:xfrm>
+          <a:prstGeom prst="rect">
+            <a:avLst/>
+          </a:prstGeom>
+          <a:noFill/>
+          <a:ln/>
+        </p:spPr>
+        <p:txBody>
+          <a:bodyPr wrap="square" lIns="0" tIns="0" rIns="0" bIns="0" rtlCol="0" anchor="t"/>
+          <a:lstStyle/>
+          <a:p>
+            <a:pPr indent="0" marL="0">
               <a:lnSpc>
-                <a:spcPts val="2100"/>
+                <a:spcPts val="1500"/>
               </a:lnSpc>
-              <a:buSzPct val="100000"/>
-              <a:buFont typeface="+mj-lt"/>
-              <a:buAutoNum type="arabicPeriod" startAt="1"/>
+              <a:buNone/>
             </a:pPr>
             <a:r>
-              <a:rPr lang="en-US" sz="1500" b="1" dirty="0">
+              <a:rPr lang="en-US" sz="1300" b="1" dirty="0">
                 <a:solidFill>
-                  <a:srgbClr val="1A1A1A"/>
+                  <a:srgbClr val="1F3864"/>
                 </a:solidFill>
                 <a:latin typeface="Calibri" pitchFamily="34" charset="0"/>
                 <a:ea typeface="Calibri" pitchFamily="34" charset="-122"/>
                 <a:cs typeface="Calibri" pitchFamily="34" charset="-120"/>
               </a:rPr>
-              <a:t>Organisational factors. </a:t>
-            </a:r>
-            <a:pPr algn="l" marL="228600" indent="-228600">
+              <a:t>Organisational factors</a:t>
+            </a:r>
+            <a:endParaRPr lang="en-US" sz="1300" dirty="0"/>
+          </a:p>
+        </p:txBody>
+      </p:sp>
+      <p:sp>
+        <p:nvSpPr>
+          <p:cNvPr id="8" name="Text 6"/>
+          <p:cNvSpPr txBox="1"/>
+          <p:nvPr/>
+        </p:nvSpPr>
+        <p:spPr>
+          <a:xfrm>
+            <a:off x="3154680" y="2560320"/>
+            <a:ext cx="5440680" cy="457200"/>
+          </a:xfrm>
+          <a:prstGeom prst="rect">
+            <a:avLst/>
+          </a:prstGeom>
+          <a:noFill/>
+          <a:ln/>
+        </p:spPr>
+        <p:txBody>
+          <a:bodyPr wrap="square" lIns="0" tIns="0" rIns="0" bIns="0" rtlCol="0" anchor="t"/>
+          <a:lstStyle/>
+          <a:p>
+            <a:pPr indent="0" marL="0">
               <a:lnSpc>
-                <a:spcPts val="2100"/>
+                <a:spcPts val="1700"/>
               </a:lnSpc>
-              <a:spcAft>
-                <a:spcPts val="2200"/>
-              </a:spcAft>
-              <a:buSzPct val="100000"/>
-              <a:buFont typeface="+mj-lt"/>
-              <a:buAutoNum type="arabicPeriod" startAt="1"/>
+              <a:buNone/>
             </a:pPr>
             <a:r>
-              <a:rPr lang="en-US" sz="1500" dirty="0">
+              <a:rPr lang="en-US" sz="1350" dirty="0">
                 <a:solidFill>
-                  <a:srgbClr val="1A1A1A"/>
+                  <a:srgbClr val="222222"/>
                 </a:solidFill>
                 <a:latin typeface="Calibri" pitchFamily="34" charset="0"/>
                 <a:ea typeface="Calibri" pitchFamily="34" charset="-122"/>
                 <a:cs typeface="Calibri" pitchFamily="34" charset="-120"/>
               </a:rPr>
-              <a:t>Placement is decisive: weak leadership reproduces the first exit. Retired teachers can return as dedicated mentors.</a:t>
-            </a:r>
-            <a:endParaRPr lang="en-US" sz="1500" dirty="0"/>
+              <a:t>Place returners under strong leadership; retirees as mentors.</a:t>
+            </a:r>
+            <a:endParaRPr lang="en-US" sz="1350" dirty="0"/>
+          </a:p>
+        </p:txBody>
+      </p:sp>
+      <p:sp>
+        <p:nvSpPr>
+          <p:cNvPr id="9" name="Text 7"/>
+          <p:cNvSpPr txBox="1"/>
+          <p:nvPr/>
+        </p:nvSpPr>
+        <p:spPr>
+          <a:xfrm>
+            <a:off x="640080" y="3072384"/>
+            <a:ext cx="2514600" cy="457200"/>
+          </a:xfrm>
+          <a:prstGeom prst="rect">
+            <a:avLst/>
+          </a:prstGeom>
+          <a:noFill/>
+          <a:ln/>
+        </p:spPr>
+        <p:txBody>
+          <a:bodyPr wrap="square" lIns="0" tIns="0" rIns="0" bIns="0" rtlCol="0" anchor="t"/>
+          <a:lstStyle/>
+          <a:p>
+            <a:pPr indent="0" marL="0">
+              <a:lnSpc>
+                <a:spcPts val="1500"/>
+              </a:lnSpc>
+              <a:buNone/>
+            </a:pPr>
+            <a:r>
+              <a:rPr lang="en-US" sz="1300" b="1" dirty="0">
+                <a:solidFill>
+                  <a:srgbClr val="1F3864"/>
+                </a:solidFill>
+                <a:latin typeface="Calibri" pitchFamily="34" charset="0"/>
+                <a:ea typeface="Calibri" pitchFamily="34" charset="-122"/>
+                <a:cs typeface="Calibri" pitchFamily="34" charset="-120"/>
+              </a:rPr>
+              <a:t>Accountability and regulation</a:t>
+            </a:r>
+            <a:endParaRPr lang="en-US" sz="1300" dirty="0"/>
+          </a:p>
+        </p:txBody>
+      </p:sp>
+      <p:sp>
+        <p:nvSpPr>
+          <p:cNvPr id="10" name="Text 8"/>
+          <p:cNvSpPr txBox="1"/>
+          <p:nvPr/>
+        </p:nvSpPr>
+        <p:spPr>
+          <a:xfrm>
+            <a:off x="3154680" y="3072384"/>
+            <a:ext cx="5440680" cy="457200"/>
+          </a:xfrm>
+          <a:prstGeom prst="rect">
+            <a:avLst/>
+          </a:prstGeom>
+          <a:noFill/>
+          <a:ln/>
+        </p:spPr>
+        <p:txBody>
+          <a:bodyPr wrap="square" lIns="0" tIns="0" rIns="0" bIns="0" rtlCol="0" anchor="t"/>
+          <a:lstStyle/>
+          <a:p>
+            <a:pPr indent="0" marL="0">
+              <a:lnSpc>
+                <a:spcPts val="1700"/>
+              </a:lnSpc>
+              <a:buNone/>
+            </a:pPr>
+            <a:r>
+              <a:rPr lang="en-US" sz="1350" dirty="0">
+                <a:solidFill>
+                  <a:srgbClr val="222222"/>
+                </a:solidFill>
+                <a:latin typeface="Calibri" pitchFamily="34" charset="0"/>
+                <a:ea typeface="Calibri" pitchFamily="34" charset="-122"/>
+                <a:cs typeface="Calibri" pitchFamily="34" charset="-120"/>
+              </a:rPr>
+              <a:t>Cut recertification to the regulatory minimum.</a:t>
+            </a:r>
+            <a:endParaRPr lang="en-US" sz="1350" dirty="0"/>
+          </a:p>
+        </p:txBody>
+      </p:sp>
+      <p:sp>
+        <p:nvSpPr>
+          <p:cNvPr id="11" name="Text 9"/>
+          <p:cNvSpPr txBox="1"/>
+          <p:nvPr/>
+        </p:nvSpPr>
+        <p:spPr>
+          <a:xfrm>
+            <a:off x="640080" y="3584448"/>
+            <a:ext cx="2514600" cy="457200"/>
+          </a:xfrm>
+          <a:prstGeom prst="rect">
+            <a:avLst/>
+          </a:prstGeom>
+          <a:noFill/>
+          <a:ln/>
+        </p:spPr>
+        <p:txBody>
+          <a:bodyPr wrap="square" lIns="0" tIns="0" rIns="0" bIns="0" rtlCol="0" anchor="t"/>
+          <a:lstStyle/>
+          <a:p>
+            <a:pPr indent="0" marL="0">
+              <a:lnSpc>
+                <a:spcPts val="1500"/>
+              </a:lnSpc>
+              <a:buNone/>
+            </a:pPr>
+            <a:r>
+              <a:rPr lang="en-US" sz="1300" b="1" dirty="0">
+                <a:solidFill>
+                  <a:srgbClr val="1F3864"/>
+                </a:solidFill>
+                <a:latin typeface="Calibri" pitchFamily="34" charset="0"/>
+                <a:ea typeface="Calibri" pitchFamily="34" charset="-122"/>
+                <a:cs typeface="Calibri" pitchFamily="34" charset="-120"/>
+              </a:rPr>
+              <a:t>Financial factors</a:t>
+            </a:r>
+            <a:endParaRPr lang="en-US" sz="1300" dirty="0"/>
+          </a:p>
+        </p:txBody>
+      </p:sp>
+      <p:sp>
+        <p:nvSpPr>
+          <p:cNvPr id="12" name="Text 10"/>
+          <p:cNvSpPr txBox="1"/>
+          <p:nvPr/>
+        </p:nvSpPr>
+        <p:spPr>
+          <a:xfrm>
+            <a:off x="3154680" y="3584448"/>
+            <a:ext cx="5440680" cy="457200"/>
+          </a:xfrm>
+          <a:prstGeom prst="rect">
+            <a:avLst/>
+          </a:prstGeom>
+          <a:noFill/>
+          <a:ln/>
+        </p:spPr>
+        <p:txBody>
+          <a:bodyPr wrap="square" lIns="0" tIns="0" rIns="0" bIns="0" rtlCol="0" anchor="t"/>
+          <a:lstStyle/>
+          <a:p>
+            <a:pPr indent="0" marL="0">
+              <a:lnSpc>
+                <a:spcPts val="1700"/>
+              </a:lnSpc>
+              <a:buNone/>
+            </a:pPr>
+            <a:r>
+              <a:rPr lang="en-US" sz="1350" dirty="0">
+                <a:solidFill>
+                  <a:srgbClr val="222222"/>
+                </a:solidFill>
+                <a:latin typeface="Calibri" pitchFamily="34" charset="0"/>
+                <a:ea typeface="Calibri" pitchFamily="34" charset="-122"/>
+                <a:cs typeface="Calibri" pitchFamily="34" charset="-120"/>
+              </a:rPr>
+              <a:t>Use targeted pay as a bridge, not as the fix.</a:t>
+            </a:r>
+            <a:endParaRPr lang="en-US" sz="1350" dirty="0"/>
+          </a:p>
+        </p:txBody>
+      </p:sp>
+      <p:sp>
+        <p:nvSpPr>
+          <p:cNvPr id="13" name="Text 11"/>
+          <p:cNvSpPr txBox="1"/>
+          <p:nvPr/>
+        </p:nvSpPr>
+        <p:spPr>
+          <a:xfrm>
+            <a:off x="640080" y="4096512"/>
+            <a:ext cx="2514600" cy="457200"/>
+          </a:xfrm>
+          <a:prstGeom prst="rect">
+            <a:avLst/>
+          </a:prstGeom>
+          <a:noFill/>
+          <a:ln/>
+        </p:spPr>
+        <p:txBody>
+          <a:bodyPr wrap="square" lIns="0" tIns="0" rIns="0" bIns="0" rtlCol="0" anchor="t"/>
+          <a:lstStyle/>
+          <a:p>
+            <a:pPr indent="0" marL="0">
+              <a:lnSpc>
+                <a:spcPts val="1500"/>
+              </a:lnSpc>
+              <a:buNone/>
+            </a:pPr>
+            <a:r>
+              <a:rPr lang="en-US" sz="1300" b="1" dirty="0">
+                <a:solidFill>
+                  <a:srgbClr val="1F3864"/>
+                </a:solidFill>
+                <a:latin typeface="Calibri" pitchFamily="34" charset="0"/>
+                <a:ea typeface="Calibri" pitchFamily="34" charset="-122"/>
+                <a:cs typeface="Calibri" pitchFamily="34" charset="-120"/>
+              </a:rPr>
+              <a:t>Personal and life-course</a:t>
+            </a:r>
+            <a:endParaRPr lang="en-US" sz="1300" dirty="0"/>
+          </a:p>
+        </p:txBody>
+      </p:sp>
+      <p:sp>
+        <p:nvSpPr>
+          <p:cNvPr id="14" name="Text 12"/>
+          <p:cNvSpPr txBox="1"/>
+          <p:nvPr/>
+        </p:nvSpPr>
+        <p:spPr>
+          <a:xfrm>
+            <a:off x="3154680" y="4096512"/>
+            <a:ext cx="5440680" cy="457200"/>
+          </a:xfrm>
+          <a:prstGeom prst="rect">
+            <a:avLst/>
+          </a:prstGeom>
+          <a:noFill/>
+          <a:ln/>
+        </p:spPr>
+        <p:txBody>
+          <a:bodyPr wrap="square" lIns="0" tIns="0" rIns="0" bIns="0" rtlCol="0" anchor="t"/>
+          <a:lstStyle/>
+          <a:p>
+            <a:pPr indent="0" marL="0">
+              <a:lnSpc>
+                <a:spcPts val="1700"/>
+              </a:lnSpc>
+              <a:buNone/>
+            </a:pPr>
+            <a:r>
+              <a:rPr lang="en-US" sz="1350" dirty="0">
+                <a:solidFill>
+                  <a:srgbClr val="222222"/>
+                </a:solidFill>
+                <a:latin typeface="Calibri" pitchFamily="34" charset="0"/>
+                <a:ea typeface="Calibri" pitchFamily="34" charset="-122"/>
+                <a:cs typeface="Calibri" pitchFamily="34" charset="-120"/>
+              </a:rPr>
+              <a:t>Offer part-time, phased returns, predictable timetables.</a:t>
+            </a:r>
+            <a:endParaRPr lang="en-US" sz="1350" dirty="0"/>
           </a:p>
         </p:txBody>
       </p:sp>
@@ -3210,7 +3471,7 @@
     <p:bg>
       <p:bgPr>
         <a:solidFill>
-          <a:srgbClr val="FFFFFF"/>
+          <a:srgbClr val="1F3864"/>
         </a:solidFill>
       </p:bgPr>
     </p:bg>
@@ -3236,8 +3497,8 @@
         </p:nvSpPr>
         <p:spPr>
           <a:xfrm>
-            <a:off x="640080" y="438912"/>
-            <a:ext cx="7863840" cy="731520"/>
+            <a:off x="640080" y="475488"/>
+            <a:ext cx="7863840" cy="548640"/>
           </a:xfrm>
           <a:prstGeom prst="rect">
             <a:avLst/>
@@ -3249,19 +3510,19 @@
           <a:bodyPr wrap="square" lIns="0" tIns="0" rIns="0" bIns="0" rtlCol="0" anchor="t"/>
           <a:lstStyle/>
           <a:p>
-            <a:pPr algn="l" indent="0" marL="0">
+            <a:pPr indent="0" marL="0">
               <a:buNone/>
             </a:pPr>
             <a:r>
               <a:rPr lang="en-US" sz="2700" b="1" dirty="0">
                 <a:solidFill>
-                  <a:srgbClr val="1F3864"/>
+                  <a:srgbClr val="FFFFFF"/>
                 </a:solidFill>
                 <a:latin typeface="Cambria" pitchFamily="34" charset="0"/>
                 <a:ea typeface="Cambria" pitchFamily="34" charset="-122"/>
                 <a:cs typeface="Cambria" pitchFamily="34" charset="-120"/>
               </a:rPr>
-              <a:t>What each motive teaches re-entry policy</a:t>
+              <a:t>The message for policy</a:t>
             </a:r>
             <a:endParaRPr lang="en-US" sz="2700" dirty="0"/>
           </a:p>
@@ -3275,8 +3536,8 @@
         </p:nvSpPr>
         <p:spPr>
           <a:xfrm>
-            <a:off x="640080" y="1600200"/>
-            <a:ext cx="7863840" cy="3108960"/>
+            <a:off x="640080" y="1828800"/>
+            <a:ext cx="7863840" cy="2926080"/>
           </a:xfrm>
           <a:prstGeom prst="rect">
             <a:avLst/>
@@ -3288,304 +3549,79 @@
           <a:bodyPr wrap="square" lIns="0" tIns="0" rIns="0" bIns="0" rtlCol="0" anchor="t"/>
           <a:lstStyle/>
           <a:p>
-            <a:pPr algn="l" marL="228600" indent="-228600">
+            <a:pPr marL="254000" indent="-254000">
               <a:lnSpc>
-                <a:spcPts val="2100"/>
+                <a:spcPts val="2200"/>
               </a:lnSpc>
+              <a:spcAft>
+                <a:spcPts val="2600"/>
+              </a:spcAft>
               <a:buSzPct val="100000"/>
               <a:buFont typeface="+mj-lt"/>
-              <a:buAutoNum type="arabicPeriod" startAt="4"/>
+              <a:buAutoNum type="arabicPeriod" startAt="1"/>
             </a:pPr>
             <a:r>
-              <a:rPr lang="en-US" sz="1500" b="1" dirty="0">
+              <a:rPr lang="en-US" sz="1600" dirty="0">
                 <a:solidFill>
-                  <a:srgbClr val="1A1A1A"/>
+                  <a:srgbClr val="FFFFFF"/>
                 </a:solidFill>
                 <a:latin typeface="Calibri" pitchFamily="34" charset="0"/>
                 <a:ea typeface="Calibri" pitchFamily="34" charset="-122"/>
                 <a:cs typeface="Calibri" pitchFamily="34" charset="-120"/>
               </a:rPr>
-              <a:t>Accountability and regulation. </a:t>
-            </a:r>
-            <a:pPr algn="l" marL="228600" indent="-228600">
+              <a:t>Do not just lower the cost of returning; change what teachers return to.</a:t>
+            </a:r>
+            <a:endParaRPr lang="en-US" sz="1600" dirty="0"/>
+          </a:p>
+          <a:p>
+            <a:pPr marL="254000" indent="-254000">
               <a:lnSpc>
-                <a:spcPts val="2100"/>
+                <a:spcPts val="2200"/>
               </a:lnSpc>
               <a:spcAft>
-                <a:spcPts val="2200"/>
+                <a:spcPts val="2600"/>
               </a:spcAft>
               <a:buSzPct val="100000"/>
               <a:buFont typeface="+mj-lt"/>
-              <a:buAutoNum type="arabicPeriod" startAt="4"/>
+              <a:buAutoNum type="arabicPeriod" startAt="1"/>
             </a:pPr>
             <a:r>
-              <a:rPr lang="en-US" sz="1500" dirty="0">
+              <a:rPr lang="en-US" sz="1600" dirty="0">
                 <a:solidFill>
-                  <a:srgbClr val="1A1A1A"/>
+                  <a:srgbClr val="FFFFFF"/>
                 </a:solidFill>
                 <a:latin typeface="Calibri" pitchFamily="34" charset="0"/>
                 <a:ea typeface="Calibri" pitchFamily="34" charset="-122"/>
                 <a:cs typeface="Calibri" pitchFamily="34" charset="-120"/>
               </a:rPr>
-              <a:t>The cost of recertification deserves attention; keep such burdens as low as regulatory purposes allow.</a:t>
-            </a:r>
-            <a:endParaRPr lang="en-US" sz="1500" dirty="0"/>
-          </a:p>
-          <a:p>
-            <a:pPr algn="l" marL="228600" indent="-228600">
+              <a:t>The match is the policy: workload, leadership, climate, flexibility.</a:t>
+            </a:r>
+            <a:endParaRPr lang="en-US" sz="1600" dirty="0"/>
+          </a:p>
+          <a:p>
+            <a:pPr marL="254000" indent="-254000">
               <a:lnSpc>
-                <a:spcPts val="2100"/>
+                <a:spcPts val="2200"/>
               </a:lnSpc>
+              <a:spcAft>
+                <a:spcPts val="2600"/>
+              </a:spcAft>
               <a:buSzPct val="100000"/>
               <a:buFont typeface="+mj-lt"/>
-              <a:buAutoNum type="arabicPeriod" startAt="4"/>
+              <a:buAutoNum type="arabicPeriod" startAt="1"/>
             </a:pPr>
             <a:r>
-              <a:rPr lang="en-US" sz="1500" b="1" dirty="0">
+              <a:rPr lang="en-US" sz="1600" i="1" dirty="0">
                 <a:solidFill>
-                  <a:srgbClr val="1A1A1A"/>
+                  <a:srgbClr val="FFFFFF"/>
                 </a:solidFill>
                 <a:latin typeface="Calibri" pitchFamily="34" charset="0"/>
                 <a:ea typeface="Calibri" pitchFamily="34" charset="-122"/>
                 <a:cs typeface="Calibri" pitchFamily="34" charset="-120"/>
               </a:rPr>
-              <a:t>Financial factors. </a:t>
-            </a:r>
-            <a:pPr algn="l" marL="228600" indent="-228600">
-              <a:lnSpc>
-                <a:spcPts val="2100"/>
-              </a:lnSpc>
-              <a:spcAft>
-                <a:spcPts val="2200"/>
-              </a:spcAft>
-              <a:buSzPct val="100000"/>
-              <a:buFont typeface="+mj-lt"/>
-              <a:buAutoNum type="arabicPeriod" startAt="4"/>
-            </a:pPr>
-            <a:r>
-              <a:rPr lang="en-US" sz="1500" dirty="0">
-                <a:solidFill>
-                  <a:srgbClr val="1A1A1A"/>
-                </a:solidFill>
-                <a:latin typeface="Calibri" pitchFamily="34" charset="0"/>
-                <a:ea typeface="Calibri" pitchFamily="34" charset="-122"/>
-                <a:cs typeface="Calibri" pitchFamily="34" charset="-120"/>
-              </a:rPr>
-              <a:t>Targeted pay retains, but only as long as the payment lasts; the paper draws no further policy lesson in this area.</a:t>
-            </a:r>
-            <a:endParaRPr lang="en-US" sz="1500" dirty="0"/>
-          </a:p>
-          <a:p>
-            <a:pPr algn="l" marL="228600" indent="-228600">
-              <a:lnSpc>
-                <a:spcPts val="2100"/>
-              </a:lnSpc>
-              <a:buSzPct val="100000"/>
-              <a:buFont typeface="+mj-lt"/>
-              <a:buAutoNum type="arabicPeriod" startAt="4"/>
-            </a:pPr>
-            <a:r>
-              <a:rPr lang="en-US" sz="1500" b="1" dirty="0">
-                <a:solidFill>
-                  <a:srgbClr val="1A1A1A"/>
-                </a:solidFill>
-                <a:latin typeface="Calibri" pitchFamily="34" charset="0"/>
-                <a:ea typeface="Calibri" pitchFamily="34" charset="-122"/>
-                <a:cs typeface="Calibri" pitchFamily="34" charset="-120"/>
-              </a:rPr>
-              <a:t>Personal and life-course factors. </a:t>
-            </a:r>
-            <a:pPr algn="l" marL="228600" indent="-228600">
-              <a:lnSpc>
-                <a:spcPts val="2100"/>
-              </a:lnSpc>
-              <a:spcAft>
-                <a:spcPts val="2200"/>
-              </a:spcAft>
-              <a:buSzPct val="100000"/>
-              <a:buFont typeface="+mj-lt"/>
-              <a:buAutoNum type="arabicPeriod" startAt="4"/>
-            </a:pPr>
-            <a:r>
-              <a:rPr lang="en-US" sz="1500" dirty="0">
-                <a:solidFill>
-                  <a:srgbClr val="1A1A1A"/>
-                </a:solidFill>
-                <a:latin typeface="Calibri" pitchFamily="34" charset="0"/>
-                <a:ea typeface="Calibri" pitchFamily="34" charset="-122"/>
-                <a:cs typeface="Calibri" pitchFamily="34" charset="-120"/>
-              </a:rPr>
-              <a:t>These exits are not about the school and can ease with time; focus on flexibility through part-time and phased returns, predictable timetables and care-compatible placements.</a:t>
-            </a:r>
-            <a:endParaRPr lang="en-US" sz="1500" dirty="0"/>
-          </a:p>
-        </p:txBody>
-      </p:sp>
-    </p:spTree>
-  </p:cSld>
-  <p:clrMapOvr>
-    <a:masterClrMapping/>
-  </p:clrMapOvr>
-</p:sld>
-</file>
-
-<file path=ppt/slides/slide7.xml><?xml version="1.0" encoding="utf-8"?>
-<p:sld xmlns:a="http://schemas.openxmlformats.org/drawingml/2006/main" xmlns:r="http://schemas.openxmlformats.org/officeDocument/2006/relationships" xmlns:p="http://schemas.openxmlformats.org/presentationml/2006/main">
-  <p:cSld name="Slide 7">
-    <p:bg>
-      <p:bgPr>
-        <a:solidFill>
-          <a:srgbClr val="FFFFFF"/>
-        </a:solidFill>
-      </p:bgPr>
-    </p:bg>
-    <p:spTree>
-      <p:nvGrpSpPr>
-        <p:cNvPr id="1" name=""/>
-        <p:cNvGrpSpPr/>
-        <p:nvPr/>
-      </p:nvGrpSpPr>
-      <p:grpSpPr>
-        <a:xfrm>
-          <a:off x="0" y="0"/>
-          <a:ext cx="0" cy="0"/>
-          <a:chOff x="0" y="0"/>
-          <a:chExt cx="0" cy="0"/>
-        </a:xfrm>
-      </p:grpSpPr>
-      <p:sp>
-        <p:nvSpPr>
-          <p:cNvPr id="2" name="Text 0"/>
-          <p:cNvSpPr txBox="1"/>
-          <p:nvPr/>
-        </p:nvSpPr>
-        <p:spPr>
-          <a:xfrm>
-            <a:off x="640080" y="438912"/>
-            <a:ext cx="7863840" cy="731520"/>
-          </a:xfrm>
-          <a:prstGeom prst="rect">
-            <a:avLst/>
-          </a:prstGeom>
-          <a:noFill/>
-          <a:ln/>
-        </p:spPr>
-        <p:txBody>
-          <a:bodyPr wrap="square" lIns="0" tIns="0" rIns="0" bIns="0" rtlCol="0" anchor="t"/>
-          <a:lstStyle/>
-          <a:p>
-            <a:pPr algn="l" indent="0" marL="0">
-              <a:buNone/>
-            </a:pPr>
-            <a:r>
-              <a:rPr lang="en-US" sz="2700" b="1" dirty="0">
-                <a:solidFill>
-                  <a:srgbClr val="1F3864"/>
-                </a:solidFill>
-                <a:latin typeface="Cambria" pitchFamily="34" charset="0"/>
-                <a:ea typeface="Cambria" pitchFamily="34" charset="-122"/>
-                <a:cs typeface="Cambria" pitchFamily="34" charset="-120"/>
-              </a:rPr>
-              <a:t>The message for policy</a:t>
-            </a:r>
-            <a:endParaRPr lang="en-US" sz="2700" dirty="0"/>
-          </a:p>
-        </p:txBody>
-      </p:sp>
-      <p:sp>
-        <p:nvSpPr>
-          <p:cNvPr id="3" name="Text 1"/>
-          <p:cNvSpPr txBox="1"/>
-          <p:nvPr/>
-        </p:nvSpPr>
-        <p:spPr>
-          <a:xfrm>
-            <a:off x="640080" y="1600200"/>
-            <a:ext cx="7863840" cy="3108960"/>
-          </a:xfrm>
-          <a:prstGeom prst="rect">
-            <a:avLst/>
-          </a:prstGeom>
-          <a:noFill/>
-          <a:ln/>
-        </p:spPr>
-        <p:txBody>
-          <a:bodyPr wrap="square" lIns="0" tIns="0" rIns="0" bIns="0" rtlCol="0" anchor="t"/>
-          <a:lstStyle/>
-          <a:p>
-            <a:pPr algn="l" marL="228600" indent="-228600">
-              <a:lnSpc>
-                <a:spcPts val="2100"/>
-              </a:lnSpc>
-              <a:spcAft>
-                <a:spcPts val="2400"/>
-              </a:spcAft>
-              <a:buSzPct val="100000"/>
-              <a:buFont typeface="+mj-lt"/>
-              <a:buAutoNum type="arabicPeriod" startAt="1"/>
-            </a:pPr>
-            <a:r>
-              <a:rPr lang="en-US" sz="1500" dirty="0">
-                <a:solidFill>
-                  <a:srgbClr val="1A1A1A"/>
-                </a:solidFill>
-                <a:latin typeface="Calibri" pitchFamily="34" charset="0"/>
-                <a:ea typeface="Calibri" pitchFamily="34" charset="-122"/>
-                <a:cs typeface="Calibri" pitchFamily="34" charset="-120"/>
-              </a:rPr>
-              <a:t>Bringing a teacher back without changing the conditions behind the first exit risks reproducing the same decision.</a:t>
-            </a:r>
-            <a:endParaRPr lang="en-US" sz="1500" dirty="0"/>
-          </a:p>
-          <a:p>
-            <a:pPr algn="l" marL="228600" indent="-228600">
-              <a:lnSpc>
-                <a:spcPts val="2100"/>
-              </a:lnSpc>
-              <a:spcAft>
-                <a:spcPts val="2400"/>
-              </a:spcAft>
-              <a:buSzPct val="100000"/>
-              <a:buFont typeface="+mj-lt"/>
-              <a:buAutoNum type="arabicPeriod" startAt="1"/>
-            </a:pPr>
-            <a:r>
-              <a:rPr lang="en-US" sz="1500" dirty="0">
-                <a:solidFill>
-                  <a:srgbClr val="1A1A1A"/>
-                </a:solidFill>
-                <a:latin typeface="Calibri" pitchFamily="34" charset="0"/>
-                <a:ea typeface="Calibri" pitchFamily="34" charset="-122"/>
-                <a:cs typeface="Calibri" pitchFamily="34" charset="-120"/>
-              </a:rPr>
-              <a:t>Re-entry policy is an opportunity to improve the match between teachers and schools: workload, leadership, collegial environment, classroom conditions and flexibility.</a:t>
-            </a:r>
-            <a:endParaRPr lang="en-US" sz="1500" dirty="0"/>
-          </a:p>
-          <a:p>
-            <a:pPr algn="l" marL="228600" indent="-228600">
-              <a:lnSpc>
-                <a:spcPts val="2100"/>
-              </a:lnSpc>
-              <a:spcAft>
-                <a:spcPts val="2400"/>
-              </a:spcAft>
-              <a:buSzPct val="100000"/>
-              <a:buFont typeface="+mj-lt"/>
-              <a:buAutoNum type="arabicPeriod" startAt="1"/>
-            </a:pPr>
-            <a:r>
-              <a:rPr lang="en-US" sz="1500" i="1" dirty="0">
-                <a:solidFill>
-                  <a:srgbClr val="1A1A1A"/>
-                </a:solidFill>
-                <a:latin typeface="Calibri" pitchFamily="34" charset="0"/>
-                <a:ea typeface="Calibri" pitchFamily="34" charset="-122"/>
-                <a:cs typeface="Calibri" pitchFamily="34" charset="-120"/>
-              </a:rPr>
-              <a:t>The relevant question is not how to make former teachers return, but whether the system can offer them a different set of conditions once they do.</a:t>
-            </a:r>
-            <a:endParaRPr lang="en-US" sz="1500" dirty="0"/>
+              <a:t>The question is not how to make former teachers return, but whether the system can offer them different conditions once they do.</a:t>
+            </a:r>
+            <a:endParaRPr lang="en-US" sz="1600" dirty="0"/>
           </a:p>
         </p:txBody>
       </p:sp>

</xml_diff>